<commit_message>
fix: pitch deck visual defects — cover, accent lines, clutter
</commit_message>
<xml_diff>
--- a/submission/gridai_lablab_band_of_agents_2026/assets/gridai_pitch_deck.pptx
+++ b/submission/gridai_lablab_band_of_agents_2026/assets/gridai_pitch_deck.pptx
@@ -3105,86 +3105,16 @@
         <p:nvPr/>
       </p:nvGrpSpPr>
       <p:grpSpPr/>
-      <p:pic>
-        <p:nvPicPr>
-          <p:cNvPr id="2" name="Picture 1" descr="07b_side_by_side_TRUE_peak_step211.png"/>
-          <p:cNvPicPr>
-            <a:picLocks noChangeAspect="1"/>
-          </p:cNvPicPr>
-          <p:nvPr/>
-        </p:nvPicPr>
-        <p:blipFill>
-          <a:blip r:embed="rId2"/>
-          <a:stretch>
-            <a:fillRect/>
-          </a:stretch>
-        </p:blipFill>
-        <p:spPr>
-          <a:xfrm>
-            <a:off x="4754880" y="0"/>
-            <a:ext cx="4389120" cy="6858000"/>
-          </a:xfrm>
-          <a:prstGeom prst="rect">
-            <a:avLst/>
-          </a:prstGeom>
-        </p:spPr>
-      </p:pic>
-      <p:sp>
-        <p:nvSpPr>
-          <p:cNvPr id="3" name="Rectangle 2"/>
-          <p:cNvSpPr/>
-          <p:nvPr/>
-        </p:nvSpPr>
-        <p:spPr>
-          <a:xfrm>
-            <a:off x="4754880" y="0"/>
-            <a:ext cx="4389120" cy="6858000"/>
-          </a:xfrm>
-          <a:prstGeom prst="rect">
-            <a:avLst/>
-          </a:prstGeom>
-          <a:solidFill>
-            <a:srgbClr val="0F1923">
-              <a:lumMod val="50000"/>
-              <a:lumOff val="50000"/>
-            </a:srgbClr>
-          </a:solidFill>
-          <a:ln>
-            <a:noFill/>
-          </a:ln>
-        </p:spPr>
-        <p:style>
-          <a:lnRef idx="1">
-            <a:schemeClr val="accent1"/>
-          </a:lnRef>
-          <a:fillRef idx="3">
-            <a:schemeClr val="accent1"/>
-          </a:fillRef>
-          <a:effectRef idx="2">
-            <a:schemeClr val="accent1"/>
-          </a:effectRef>
-          <a:fontRef idx="minor">
-            <a:schemeClr val="lt1"/>
-          </a:fontRef>
-        </p:style>
-        <p:txBody>
-          <a:bodyPr rtlCol="0" anchor="ctr"/>
-          <a:lstStyle/>
-          <a:p>
-            <a:pPr algn="ctr"/>
-          </a:p>
-        </p:txBody>
-      </p:sp>
-      <p:sp>
-        <p:nvSpPr>
-          <p:cNvPr id="4" name="TextBox 3"/>
-          <p:cNvSpPr txBox="1"/>
-          <p:nvPr/>
-        </p:nvSpPr>
-        <p:spPr>
-          <a:xfrm>
-            <a:off x="731520" y="1097280"/>
-            <a:ext cx="4114800" cy="731520"/>
+      <p:sp>
+        <p:nvSpPr>
+          <p:cNvPr id="2" name="TextBox 1"/>
+          <p:cNvSpPr txBox="1"/>
+          <p:nvPr/>
+        </p:nvSpPr>
+        <p:spPr>
+          <a:xfrm>
+            <a:off x="731520" y="1463040"/>
+            <a:ext cx="7315200" cy="822960"/>
           </a:xfrm>
           <a:prstGeom prst="rect">
             <a:avLst/>
@@ -3213,50 +3143,7 @@
       </p:sp>
       <p:sp>
         <p:nvSpPr>
-          <p:cNvPr id="5" name="Rectangle 4"/>
-          <p:cNvSpPr/>
-          <p:nvPr/>
-        </p:nvSpPr>
-        <p:spPr>
-          <a:xfrm>
-            <a:off x="731520" y="1920240"/>
-            <a:ext cx="548640" cy="36576"/>
-          </a:xfrm>
-          <a:prstGeom prst="rect">
-            <a:avLst/>
-          </a:prstGeom>
-          <a:solidFill>
-            <a:srgbClr val="F4A623"/>
-          </a:solidFill>
-          <a:ln>
-            <a:noFill/>
-          </a:ln>
-        </p:spPr>
-        <p:style>
-          <a:lnRef idx="1">
-            <a:schemeClr val="accent1"/>
-          </a:lnRef>
-          <a:fillRef idx="3">
-            <a:schemeClr val="accent1"/>
-          </a:fillRef>
-          <a:effectRef idx="2">
-            <a:schemeClr val="accent1"/>
-          </a:effectRef>
-          <a:fontRef idx="minor">
-            <a:schemeClr val="lt1"/>
-          </a:fontRef>
-        </p:style>
-        <p:txBody>
-          <a:bodyPr rtlCol="0" anchor="ctr"/>
-          <a:lstStyle/>
-          <a:p>
-            <a:pPr algn="ctr"/>
-          </a:p>
-        </p:txBody>
-      </p:sp>
-      <p:sp>
-        <p:nvSpPr>
-          <p:cNvPr id="6" name="TextBox 5"/>
+          <p:cNvPr id="3" name="TextBox 2"/>
           <p:cNvSpPr txBox="1"/>
           <p:nvPr/>
         </p:nvSpPr>
@@ -3292,7 +3179,7 @@
       </p:sp>
       <p:sp>
         <p:nvSpPr>
-          <p:cNvPr id="7" name="TextBox 6"/>
+          <p:cNvPr id="4" name="TextBox 3"/>
           <p:cNvSpPr txBox="1"/>
           <p:nvPr/>
         </p:nvSpPr>
@@ -3328,7 +3215,7 @@
       </p:sp>
       <p:sp>
         <p:nvSpPr>
-          <p:cNvPr id="8" name="TextBox 7"/>
+          <p:cNvPr id="5" name="TextBox 4"/>
           <p:cNvSpPr txBox="1"/>
           <p:nvPr/>
         </p:nvSpPr>
@@ -3432,49 +3319,6 @@
         </p:nvSpPr>
         <p:spPr>
           <a:xfrm>
-            <a:off x="548640" y="1371600"/>
-            <a:ext cx="1097280" cy="27432"/>
-          </a:xfrm>
-          <a:prstGeom prst="rect">
-            <a:avLst/>
-          </a:prstGeom>
-          <a:solidFill>
-            <a:srgbClr val="F4A623"/>
-          </a:solidFill>
-          <a:ln>
-            <a:noFill/>
-          </a:ln>
-        </p:spPr>
-        <p:style>
-          <a:lnRef idx="1">
-            <a:schemeClr val="accent1"/>
-          </a:lnRef>
-          <a:fillRef idx="3">
-            <a:schemeClr val="accent1"/>
-          </a:fillRef>
-          <a:effectRef idx="2">
-            <a:schemeClr val="accent1"/>
-          </a:effectRef>
-          <a:fontRef idx="minor">
-            <a:schemeClr val="lt1"/>
-          </a:fontRef>
-        </p:style>
-        <p:txBody>
-          <a:bodyPr rtlCol="0" anchor="ctr"/>
-          <a:lstStyle/>
-          <a:p>
-            <a:pPr algn="ctr"/>
-          </a:p>
-        </p:txBody>
-      </p:sp>
-      <p:sp>
-        <p:nvSpPr>
-          <p:cNvPr id="4" name="Rectangle 3"/>
-          <p:cNvSpPr/>
-          <p:nvPr/>
-        </p:nvSpPr>
-        <p:spPr>
-          <a:xfrm>
             <a:off x="548640" y="1737360"/>
             <a:ext cx="4114800" cy="411480"/>
           </a:xfrm>
@@ -3512,7 +3356,7 @@
       </p:sp>
       <p:sp>
         <p:nvSpPr>
-          <p:cNvPr id="5" name="TextBox 4"/>
+          <p:cNvPr id="4" name="TextBox 3"/>
           <p:cNvSpPr txBox="1"/>
           <p:nvPr/>
         </p:nvSpPr>
@@ -3548,7 +3392,7 @@
       </p:sp>
       <p:sp>
         <p:nvSpPr>
-          <p:cNvPr id="6" name="TextBox 5"/>
+          <p:cNvPr id="5" name="TextBox 4"/>
           <p:cNvSpPr txBox="1"/>
           <p:nvPr/>
         </p:nvSpPr>
@@ -3584,7 +3428,7 @@
       </p:sp>
       <p:sp>
         <p:nvSpPr>
-          <p:cNvPr id="7" name="Rectangle 6"/>
+          <p:cNvPr id="6" name="Rectangle 5"/>
           <p:cNvSpPr/>
           <p:nvPr/>
         </p:nvSpPr>
@@ -3627,7 +3471,7 @@
       </p:sp>
       <p:sp>
         <p:nvSpPr>
-          <p:cNvPr id="8" name="TextBox 7"/>
+          <p:cNvPr id="7" name="TextBox 6"/>
           <p:cNvSpPr txBox="1"/>
           <p:nvPr/>
         </p:nvSpPr>
@@ -3663,7 +3507,7 @@
       </p:sp>
       <p:sp>
         <p:nvSpPr>
-          <p:cNvPr id="9" name="TextBox 8"/>
+          <p:cNvPr id="8" name="TextBox 7"/>
           <p:cNvSpPr txBox="1"/>
           <p:nvPr/>
         </p:nvSpPr>
@@ -3699,7 +3543,7 @@
       </p:sp>
       <p:sp>
         <p:nvSpPr>
-          <p:cNvPr id="10" name="Rectangle 9"/>
+          <p:cNvPr id="9" name="Rectangle 8"/>
           <p:cNvSpPr/>
           <p:nvPr/>
         </p:nvSpPr>
@@ -3742,7 +3586,7 @@
       </p:sp>
       <p:sp>
         <p:nvSpPr>
-          <p:cNvPr id="11" name="TextBox 10"/>
+          <p:cNvPr id="10" name="TextBox 9"/>
           <p:cNvSpPr txBox="1"/>
           <p:nvPr/>
         </p:nvSpPr>
@@ -3778,7 +3622,7 @@
       </p:sp>
       <p:sp>
         <p:nvSpPr>
-          <p:cNvPr id="12" name="TextBox 11"/>
+          <p:cNvPr id="11" name="TextBox 10"/>
           <p:cNvSpPr txBox="1"/>
           <p:nvPr/>
         </p:nvSpPr>
@@ -3814,7 +3658,7 @@
       </p:sp>
       <p:sp>
         <p:nvSpPr>
-          <p:cNvPr id="13" name="Rectangle 12"/>
+          <p:cNvPr id="12" name="Rectangle 11"/>
           <p:cNvSpPr/>
           <p:nvPr/>
         </p:nvSpPr>
@@ -3857,7 +3701,7 @@
       </p:sp>
       <p:sp>
         <p:nvSpPr>
-          <p:cNvPr id="14" name="TextBox 13"/>
+          <p:cNvPr id="13" name="TextBox 12"/>
           <p:cNvSpPr txBox="1"/>
           <p:nvPr/>
         </p:nvSpPr>
@@ -3902,7 +3746,7 @@
       </p:sp>
       <p:sp>
         <p:nvSpPr>
-          <p:cNvPr id="15" name="TextBox 14"/>
+          <p:cNvPr id="14" name="TextBox 13"/>
           <p:cNvSpPr txBox="1"/>
           <p:nvPr/>
         </p:nvSpPr>
@@ -4000,14 +3844,194 @@
       </p:sp>
       <p:sp>
         <p:nvSpPr>
-          <p:cNvPr id="3" name="Rectangle 2"/>
+          <p:cNvPr id="3" name="TextBox 2"/>
+          <p:cNvSpPr txBox="1"/>
+          <p:nvPr/>
+        </p:nvSpPr>
+        <p:spPr>
+          <a:xfrm>
+            <a:off x="548640" y="1097280"/>
+            <a:ext cx="8046720" cy="457200"/>
+          </a:xfrm>
+          <a:prstGeom prst="rect">
+            <a:avLst/>
+          </a:prstGeom>
+          <a:noFill/>
+        </p:spPr>
+        <p:txBody>
+          <a:bodyPr wrap="square">
+            <a:spAutoFit/>
+          </a:bodyPr>
+          <a:lstStyle/>
+          <a:p>
+            <a:pPr algn="l">
+              <a:defRPr sz="2000" b="1" i="0">
+                <a:solidFill>
+                  <a:srgbClr val="FFFFFF"/>
+                </a:solidFill>
+                <a:latin typeface="Calibri"/>
+              </a:defRPr>
+            </a:pPr>
+            <a:r>
+              <a:t>Australia has 15 GWh of home batteries reading the same price signal.</a:t>
+            </a:r>
+          </a:p>
+        </p:txBody>
+      </p:sp>
+      <p:sp>
+        <p:nvSpPr>
+          <p:cNvPr id="4" name="TextBox 3"/>
+          <p:cNvSpPr txBox="1"/>
+          <p:nvPr/>
+        </p:nvSpPr>
+        <p:spPr>
+          <a:xfrm>
+            <a:off x="548640" y="1737360"/>
+            <a:ext cx="5029200" cy="320040"/>
+          </a:xfrm>
+          <a:prstGeom prst="rect">
+            <a:avLst/>
+          </a:prstGeom>
+          <a:noFill/>
+        </p:spPr>
+        <p:txBody>
+          <a:bodyPr wrap="square">
+            <a:spAutoFit/>
+          </a:bodyPr>
+          <a:lstStyle/>
+          <a:p>
+            <a:pPr algn="l">
+              <a:defRPr sz="1400" b="0" i="0">
+                <a:solidFill>
+                  <a:srgbClr val="FFFFFF"/>
+                </a:solidFill>
+                <a:latin typeface="Calibri"/>
+              </a:defRPr>
+            </a:pPr>
+            <a:r>
+              <a:t>When they all respond at once, they synchronise.</a:t>
+            </a:r>
+          </a:p>
+        </p:txBody>
+      </p:sp>
+      <p:sp>
+        <p:nvSpPr>
+          <p:cNvPr id="5" name="TextBox 4"/>
+          <p:cNvSpPr txBox="1"/>
+          <p:nvPr/>
+        </p:nvSpPr>
+        <p:spPr>
+          <a:xfrm>
+            <a:off x="548640" y="2057400"/>
+            <a:ext cx="5029200" cy="320040"/>
+          </a:xfrm>
+          <a:prstGeom prst="rect">
+            <a:avLst/>
+          </a:prstGeom>
+          <a:noFill/>
+        </p:spPr>
+        <p:txBody>
+          <a:bodyPr wrap="square">
+            <a:spAutoFit/>
+          </a:bodyPr>
+          <a:lstStyle/>
+          <a:p>
+            <a:pPr algn="l">
+              <a:defRPr sz="1400" b="0" i="0">
+                <a:solidFill>
+                  <a:srgbClr val="FFFFFF"/>
+                </a:solidFill>
+                <a:latin typeface="Calibri"/>
+              </a:defRPr>
+            </a:pPr>
+            <a:r>
+              <a:t>The fleet creates a new evening demand spike instead of smoothing the old one.</a:t>
+            </a:r>
+          </a:p>
+        </p:txBody>
+      </p:sp>
+      <p:sp>
+        <p:nvSpPr>
+          <p:cNvPr id="6" name="TextBox 5"/>
+          <p:cNvSpPr txBox="1"/>
+          <p:nvPr/>
+        </p:nvSpPr>
+        <p:spPr>
+          <a:xfrm>
+            <a:off x="548640" y="2377439"/>
+            <a:ext cx="5029200" cy="320040"/>
+          </a:xfrm>
+          <a:prstGeom prst="rect">
+            <a:avLst/>
+          </a:prstGeom>
+          <a:noFill/>
+        </p:spPr>
+        <p:txBody>
+          <a:bodyPr wrap="square">
+            <a:spAutoFit/>
+          </a:bodyPr>
+          <a:lstStyle/>
+          <a:p>
+            <a:pPr algn="l">
+              <a:defRPr sz="1400" b="1" i="0">
+                <a:solidFill>
+                  <a:srgbClr val="F4A623"/>
+                </a:solidFill>
+                <a:latin typeface="Calibri"/>
+              </a:defRPr>
+            </a:pPr>
+            <a:r>
+              <a:t>471 voltage breaches at the network edge.</a:t>
+            </a:r>
+          </a:p>
+        </p:txBody>
+      </p:sp>
+      <p:sp>
+        <p:nvSpPr>
+          <p:cNvPr id="7" name="TextBox 6"/>
+          <p:cNvSpPr txBox="1"/>
+          <p:nvPr/>
+        </p:nvSpPr>
+        <p:spPr>
+          <a:xfrm>
+            <a:off x="548640" y="2697479"/>
+            <a:ext cx="5029200" cy="320040"/>
+          </a:xfrm>
+          <a:prstGeom prst="rect">
+            <a:avLst/>
+          </a:prstGeom>
+          <a:noFill/>
+        </p:spPr>
+        <p:txBody>
+          <a:bodyPr wrap="square">
+            <a:spAutoFit/>
+          </a:bodyPr>
+          <a:lstStyle/>
+          <a:p>
+            <a:pPr algn="l">
+              <a:defRPr sz="1400" b="0" i="0">
+                <a:solidFill>
+                  <a:srgbClr val="FFFFFF"/>
+                </a:solidFill>
+                <a:latin typeface="Calibri"/>
+              </a:defRPr>
+            </a:pPr>
+            <a:r>
+              <a:t>This is the herding problem — and it gets worse as VPPs scale.</a:t>
+            </a:r>
+          </a:p>
+        </p:txBody>
+      </p:sp>
+      <p:sp>
+        <p:nvSpPr>
+          <p:cNvPr id="8" name="Rectangle 7"/>
           <p:cNvSpPr/>
           <p:nvPr/>
         </p:nvSpPr>
         <p:spPr>
           <a:xfrm>
-            <a:off x="548640" y="777240"/>
-            <a:ext cx="1097280" cy="27432"/>
+            <a:off x="5943600" y="2560320"/>
+            <a:ext cx="320040" cy="457200"/>
           </a:xfrm>
           <a:prstGeom prst="rect">
             <a:avLst/>
@@ -4043,193 +4067,13 @@
       </p:sp>
       <p:sp>
         <p:nvSpPr>
-          <p:cNvPr id="4" name="TextBox 3"/>
-          <p:cNvSpPr txBox="1"/>
-          <p:nvPr/>
-        </p:nvSpPr>
-        <p:spPr>
-          <a:xfrm>
-            <a:off x="548640" y="1097280"/>
-            <a:ext cx="8046720" cy="457200"/>
-          </a:xfrm>
-          <a:prstGeom prst="rect">
-            <a:avLst/>
-          </a:prstGeom>
-          <a:noFill/>
-        </p:spPr>
-        <p:txBody>
-          <a:bodyPr wrap="square">
-            <a:spAutoFit/>
-          </a:bodyPr>
-          <a:lstStyle/>
-          <a:p>
-            <a:pPr algn="l">
-              <a:defRPr sz="2000" b="1" i="0">
-                <a:solidFill>
-                  <a:srgbClr val="FFFFFF"/>
-                </a:solidFill>
-                <a:latin typeface="Calibri"/>
-              </a:defRPr>
-            </a:pPr>
-            <a:r>
-              <a:t>Australia has 15 GWh of home batteries reading the same price signal.</a:t>
-            </a:r>
-          </a:p>
-        </p:txBody>
-      </p:sp>
-      <p:sp>
-        <p:nvSpPr>
-          <p:cNvPr id="5" name="TextBox 4"/>
-          <p:cNvSpPr txBox="1"/>
-          <p:nvPr/>
-        </p:nvSpPr>
-        <p:spPr>
-          <a:xfrm>
-            <a:off x="548640" y="1737360"/>
-            <a:ext cx="5029200" cy="320040"/>
-          </a:xfrm>
-          <a:prstGeom prst="rect">
-            <a:avLst/>
-          </a:prstGeom>
-          <a:noFill/>
-        </p:spPr>
-        <p:txBody>
-          <a:bodyPr wrap="square">
-            <a:spAutoFit/>
-          </a:bodyPr>
-          <a:lstStyle/>
-          <a:p>
-            <a:pPr algn="l">
-              <a:defRPr sz="1400" b="0" i="0">
-                <a:solidFill>
-                  <a:srgbClr val="FFFFFF"/>
-                </a:solidFill>
-                <a:latin typeface="Calibri"/>
-              </a:defRPr>
-            </a:pPr>
-            <a:r>
-              <a:t>When they all respond at once, they synchronise.</a:t>
-            </a:r>
-          </a:p>
-        </p:txBody>
-      </p:sp>
-      <p:sp>
-        <p:nvSpPr>
-          <p:cNvPr id="6" name="TextBox 5"/>
-          <p:cNvSpPr txBox="1"/>
-          <p:nvPr/>
-        </p:nvSpPr>
-        <p:spPr>
-          <a:xfrm>
-            <a:off x="548640" y="2057400"/>
-            <a:ext cx="5029200" cy="320040"/>
-          </a:xfrm>
-          <a:prstGeom prst="rect">
-            <a:avLst/>
-          </a:prstGeom>
-          <a:noFill/>
-        </p:spPr>
-        <p:txBody>
-          <a:bodyPr wrap="square">
-            <a:spAutoFit/>
-          </a:bodyPr>
-          <a:lstStyle/>
-          <a:p>
-            <a:pPr algn="l">
-              <a:defRPr sz="1400" b="0" i="0">
-                <a:solidFill>
-                  <a:srgbClr val="FFFFFF"/>
-                </a:solidFill>
-                <a:latin typeface="Calibri"/>
-              </a:defRPr>
-            </a:pPr>
-            <a:r>
-              <a:t>The fleet creates a new evening demand spike instead of smoothing the old one.</a:t>
-            </a:r>
-          </a:p>
-        </p:txBody>
-      </p:sp>
-      <p:sp>
-        <p:nvSpPr>
-          <p:cNvPr id="7" name="TextBox 6"/>
-          <p:cNvSpPr txBox="1"/>
-          <p:nvPr/>
-        </p:nvSpPr>
-        <p:spPr>
-          <a:xfrm>
-            <a:off x="548640" y="2377439"/>
-            <a:ext cx="5029200" cy="320040"/>
-          </a:xfrm>
-          <a:prstGeom prst="rect">
-            <a:avLst/>
-          </a:prstGeom>
-          <a:noFill/>
-        </p:spPr>
-        <p:txBody>
-          <a:bodyPr wrap="square">
-            <a:spAutoFit/>
-          </a:bodyPr>
-          <a:lstStyle/>
-          <a:p>
-            <a:pPr algn="l">
-              <a:defRPr sz="1400" b="1" i="0">
-                <a:solidFill>
-                  <a:srgbClr val="F4A623"/>
-                </a:solidFill>
-                <a:latin typeface="Calibri"/>
-              </a:defRPr>
-            </a:pPr>
-            <a:r>
-              <a:t>471 voltage breaches at the network edge.</a:t>
-            </a:r>
-          </a:p>
-        </p:txBody>
-      </p:sp>
-      <p:sp>
-        <p:nvSpPr>
-          <p:cNvPr id="8" name="TextBox 7"/>
-          <p:cNvSpPr txBox="1"/>
-          <p:nvPr/>
-        </p:nvSpPr>
-        <p:spPr>
-          <a:xfrm>
-            <a:off x="548640" y="2697479"/>
-            <a:ext cx="5029200" cy="320040"/>
-          </a:xfrm>
-          <a:prstGeom prst="rect">
-            <a:avLst/>
-          </a:prstGeom>
-          <a:noFill/>
-        </p:spPr>
-        <p:txBody>
-          <a:bodyPr wrap="square">
-            <a:spAutoFit/>
-          </a:bodyPr>
-          <a:lstStyle/>
-          <a:p>
-            <a:pPr algn="l">
-              <a:defRPr sz="1400" b="0" i="0">
-                <a:solidFill>
-                  <a:srgbClr val="FFFFFF"/>
-                </a:solidFill>
-                <a:latin typeface="Calibri"/>
-              </a:defRPr>
-            </a:pPr>
-            <a:r>
-              <a:t>This is the herding problem — and it gets worse as VPPs scale.</a:t>
-            </a:r>
-          </a:p>
-        </p:txBody>
-      </p:sp>
-      <p:sp>
-        <p:nvSpPr>
           <p:cNvPr id="9" name="Rectangle 8"/>
           <p:cNvSpPr/>
           <p:nvPr/>
         </p:nvSpPr>
         <p:spPr>
           <a:xfrm>
-            <a:off x="5943600" y="2560320"/>
+            <a:off x="6400800" y="2560320"/>
             <a:ext cx="320040" cy="457200"/>
           </a:xfrm>
           <a:prstGeom prst="rect">
@@ -4272,7 +4116,7 @@
         </p:nvSpPr>
         <p:spPr>
           <a:xfrm>
-            <a:off x="6400800" y="2560320"/>
+            <a:off x="6858000" y="2560320"/>
             <a:ext cx="320040" cy="457200"/>
           </a:xfrm>
           <a:prstGeom prst="rect">
@@ -4309,50 +4153,7 @@
       </p:sp>
       <p:sp>
         <p:nvSpPr>
-          <p:cNvPr id="11" name="Rectangle 10"/>
-          <p:cNvSpPr/>
-          <p:nvPr/>
-        </p:nvSpPr>
-        <p:spPr>
-          <a:xfrm>
-            <a:off x="6858000" y="2560320"/>
-            <a:ext cx="320040" cy="457200"/>
-          </a:xfrm>
-          <a:prstGeom prst="rect">
-            <a:avLst/>
-          </a:prstGeom>
-          <a:solidFill>
-            <a:srgbClr val="F4A623"/>
-          </a:solidFill>
-          <a:ln>
-            <a:noFill/>
-          </a:ln>
-        </p:spPr>
-        <p:style>
-          <a:lnRef idx="1">
-            <a:schemeClr val="accent1"/>
-          </a:lnRef>
-          <a:fillRef idx="3">
-            <a:schemeClr val="accent1"/>
-          </a:fillRef>
-          <a:effectRef idx="2">
-            <a:schemeClr val="accent1"/>
-          </a:effectRef>
-          <a:fontRef idx="minor">
-            <a:schemeClr val="lt1"/>
-          </a:fontRef>
-        </p:style>
-        <p:txBody>
-          <a:bodyPr rtlCol="0" anchor="ctr"/>
-          <a:lstStyle/>
-          <a:p>
-            <a:pPr algn="ctr"/>
-          </a:p>
-        </p:txBody>
-      </p:sp>
-      <p:sp>
-        <p:nvSpPr>
-          <p:cNvPr id="12" name="TextBox 11"/>
+          <p:cNvPr id="11" name="TextBox 10"/>
           <p:cNvSpPr txBox="1"/>
           <p:nvPr/>
         </p:nvSpPr>
@@ -4388,7 +4189,7 @@
       </p:sp>
       <p:sp>
         <p:nvSpPr>
-          <p:cNvPr id="13" name="TextBox 12"/>
+          <p:cNvPr id="12" name="TextBox 11"/>
           <p:cNvSpPr txBox="1"/>
           <p:nvPr/>
         </p:nvSpPr>
@@ -4424,7 +4225,7 @@
       </p:sp>
       <p:sp>
         <p:nvSpPr>
-          <p:cNvPr id="14" name="Rectangle 13"/>
+          <p:cNvPr id="13" name="Rectangle 12"/>
           <p:cNvSpPr/>
           <p:nvPr/>
         </p:nvSpPr>
@@ -4467,7 +4268,7 @@
       </p:sp>
       <p:sp>
         <p:nvSpPr>
-          <p:cNvPr id="15" name="TextBox 14"/>
+          <p:cNvPr id="14" name="TextBox 13"/>
           <p:cNvSpPr txBox="1"/>
           <p:nvPr/>
         </p:nvSpPr>
@@ -4503,7 +4304,7 @@
       </p:sp>
       <p:sp>
         <p:nvSpPr>
-          <p:cNvPr id="16" name="Rectangle 15"/>
+          <p:cNvPr id="15" name="Rectangle 14"/>
           <p:cNvSpPr/>
           <p:nvPr/>
         </p:nvSpPr>
@@ -4546,7 +4347,7 @@
       </p:sp>
       <p:sp>
         <p:nvSpPr>
-          <p:cNvPr id="17" name="TextBox 16"/>
+          <p:cNvPr id="16" name="TextBox 15"/>
           <p:cNvSpPr txBox="1"/>
           <p:nvPr/>
         </p:nvSpPr>
@@ -4586,7 +4387,7 @@
       </p:sp>
       <p:sp>
         <p:nvSpPr>
-          <p:cNvPr id="18" name="TextBox 17"/>
+          <p:cNvPr id="17" name="TextBox 16"/>
           <p:cNvSpPr txBox="1"/>
           <p:nvPr/>
         </p:nvSpPr>
@@ -4684,50 +4485,7 @@
       </p:sp>
       <p:sp>
         <p:nvSpPr>
-          <p:cNvPr id="3" name="Rectangle 2"/>
-          <p:cNvSpPr/>
-          <p:nvPr/>
-        </p:nvSpPr>
-        <p:spPr>
-          <a:xfrm>
-            <a:off x="548640" y="777240"/>
-            <a:ext cx="1097280" cy="27432"/>
-          </a:xfrm>
-          <a:prstGeom prst="rect">
-            <a:avLst/>
-          </a:prstGeom>
-          <a:solidFill>
-            <a:srgbClr val="F4A623"/>
-          </a:solidFill>
-          <a:ln>
-            <a:noFill/>
-          </a:ln>
-        </p:spPr>
-        <p:style>
-          <a:lnRef idx="1">
-            <a:schemeClr val="accent1"/>
-          </a:lnRef>
-          <a:fillRef idx="3">
-            <a:schemeClr val="accent1"/>
-          </a:fillRef>
-          <a:effectRef idx="2">
-            <a:schemeClr val="accent1"/>
-          </a:effectRef>
-          <a:fontRef idx="minor">
-            <a:schemeClr val="lt1"/>
-          </a:fontRef>
-        </p:style>
-        <p:txBody>
-          <a:bodyPr rtlCol="0" anchor="ctr"/>
-          <a:lstStyle/>
-          <a:p>
-            <a:pPr algn="ctr"/>
-          </a:p>
-        </p:txBody>
-      </p:sp>
-      <p:sp>
-        <p:nvSpPr>
-          <p:cNvPr id="4" name="TextBox 3"/>
+          <p:cNvPr id="3" name="TextBox 2"/>
           <p:cNvSpPr txBox="1"/>
           <p:nvPr/>
         </p:nvSpPr>
@@ -4763,7 +4521,7 @@
       </p:sp>
       <p:sp>
         <p:nvSpPr>
-          <p:cNvPr id="5" name="TextBox 4"/>
+          <p:cNvPr id="4" name="TextBox 3"/>
           <p:cNvSpPr txBox="1"/>
           <p:nvPr/>
         </p:nvSpPr>
@@ -4799,7 +4557,7 @@
       </p:sp>
       <p:sp>
         <p:nvSpPr>
-          <p:cNvPr id="6" name="Rectangle 5"/>
+          <p:cNvPr id="5" name="Rectangle 4"/>
           <p:cNvSpPr/>
           <p:nvPr/>
         </p:nvSpPr>
@@ -4842,7 +4600,7 @@
       </p:sp>
       <p:sp>
         <p:nvSpPr>
-          <p:cNvPr id="7" name="TextBox 6"/>
+          <p:cNvPr id="6" name="TextBox 5"/>
           <p:cNvSpPr txBox="1"/>
           <p:nvPr/>
         </p:nvSpPr>
@@ -4878,7 +4636,7 @@
       </p:sp>
       <p:sp>
         <p:nvSpPr>
-          <p:cNvPr id="8" name="Rectangle 7"/>
+          <p:cNvPr id="7" name="Rectangle 6"/>
           <p:cNvSpPr/>
           <p:nvPr/>
         </p:nvSpPr>
@@ -4921,7 +4679,7 @@
       </p:sp>
       <p:sp>
         <p:nvSpPr>
-          <p:cNvPr id="9" name="TextBox 8"/>
+          <p:cNvPr id="8" name="TextBox 7"/>
           <p:cNvSpPr txBox="1"/>
           <p:nvPr/>
         </p:nvSpPr>
@@ -4957,7 +4715,7 @@
       </p:sp>
       <p:sp>
         <p:nvSpPr>
-          <p:cNvPr id="10" name="Rectangle 9"/>
+          <p:cNvPr id="9" name="Rectangle 8"/>
           <p:cNvSpPr/>
           <p:nvPr/>
         </p:nvSpPr>
@@ -5002,7 +4760,7 @@
       </p:sp>
       <p:sp>
         <p:nvSpPr>
-          <p:cNvPr id="11" name="TextBox 10"/>
+          <p:cNvPr id="10" name="TextBox 9"/>
           <p:cNvSpPr txBox="1"/>
           <p:nvPr/>
         </p:nvSpPr>
@@ -5038,7 +4796,7 @@
       </p:sp>
       <p:sp>
         <p:nvSpPr>
-          <p:cNvPr id="12" name="Rectangle 11"/>
+          <p:cNvPr id="11" name="Rectangle 10"/>
           <p:cNvSpPr/>
           <p:nvPr/>
         </p:nvSpPr>
@@ -5083,7 +4841,7 @@
       </p:sp>
       <p:sp>
         <p:nvSpPr>
-          <p:cNvPr id="13" name="TextBox 12"/>
+          <p:cNvPr id="12" name="TextBox 11"/>
           <p:cNvSpPr txBox="1"/>
           <p:nvPr/>
         </p:nvSpPr>
@@ -5119,7 +4877,7 @@
       </p:sp>
       <p:sp>
         <p:nvSpPr>
-          <p:cNvPr id="14" name="Rectangle 13"/>
+          <p:cNvPr id="13" name="Rectangle 12"/>
           <p:cNvSpPr/>
           <p:nvPr/>
         </p:nvSpPr>
@@ -5164,7 +4922,7 @@
       </p:sp>
       <p:sp>
         <p:nvSpPr>
-          <p:cNvPr id="15" name="TextBox 14"/>
+          <p:cNvPr id="14" name="TextBox 13"/>
           <p:cNvSpPr txBox="1"/>
           <p:nvPr/>
         </p:nvSpPr>
@@ -5200,7 +4958,7 @@
       </p:sp>
       <p:sp>
         <p:nvSpPr>
-          <p:cNvPr id="16" name="Rectangle 15"/>
+          <p:cNvPr id="15" name="Rectangle 14"/>
           <p:cNvSpPr/>
           <p:nvPr/>
         </p:nvSpPr>
@@ -5245,7 +5003,7 @@
       </p:sp>
       <p:sp>
         <p:nvSpPr>
-          <p:cNvPr id="17" name="TextBox 16"/>
+          <p:cNvPr id="16" name="TextBox 15"/>
           <p:cNvSpPr txBox="1"/>
           <p:nvPr/>
         </p:nvSpPr>
@@ -5281,7 +5039,7 @@
       </p:sp>
       <p:sp>
         <p:nvSpPr>
-          <p:cNvPr id="18" name="Rectangle 17"/>
+          <p:cNvPr id="17" name="Rectangle 16"/>
           <p:cNvSpPr/>
           <p:nvPr/>
         </p:nvSpPr>
@@ -5326,7 +5084,7 @@
       </p:sp>
       <p:sp>
         <p:nvSpPr>
-          <p:cNvPr id="19" name="TextBox 18"/>
+          <p:cNvPr id="18" name="TextBox 17"/>
           <p:cNvSpPr txBox="1"/>
           <p:nvPr/>
         </p:nvSpPr>
@@ -5362,7 +5120,7 @@
       </p:sp>
       <p:sp>
         <p:nvSpPr>
-          <p:cNvPr id="20" name="Rectangle 19"/>
+          <p:cNvPr id="19" name="Rectangle 18"/>
           <p:cNvSpPr/>
           <p:nvPr/>
         </p:nvSpPr>
@@ -5407,7 +5165,7 @@
       </p:sp>
       <p:sp>
         <p:nvSpPr>
-          <p:cNvPr id="21" name="TextBox 20"/>
+          <p:cNvPr id="20" name="TextBox 19"/>
           <p:cNvSpPr txBox="1"/>
           <p:nvPr/>
         </p:nvSpPr>
@@ -5443,7 +5201,7 @@
       </p:sp>
       <p:sp>
         <p:nvSpPr>
-          <p:cNvPr id="22" name="TextBox 21"/>
+          <p:cNvPr id="21" name="TextBox 20"/>
           <p:cNvSpPr txBox="1"/>
           <p:nvPr/>
         </p:nvSpPr>
@@ -5541,50 +5299,7 @@
       </p:sp>
       <p:sp>
         <p:nvSpPr>
-          <p:cNvPr id="3" name="Rectangle 2"/>
-          <p:cNvSpPr/>
-          <p:nvPr/>
-        </p:nvSpPr>
-        <p:spPr>
-          <a:xfrm>
-            <a:off x="548640" y="777240"/>
-            <a:ext cx="1097280" cy="27432"/>
-          </a:xfrm>
-          <a:prstGeom prst="rect">
-            <a:avLst/>
-          </a:prstGeom>
-          <a:solidFill>
-            <a:srgbClr val="F4A623"/>
-          </a:solidFill>
-          <a:ln>
-            <a:noFill/>
-          </a:ln>
-        </p:spPr>
-        <p:style>
-          <a:lnRef idx="1">
-            <a:schemeClr val="accent1"/>
-          </a:lnRef>
-          <a:fillRef idx="3">
-            <a:schemeClr val="accent1"/>
-          </a:fillRef>
-          <a:effectRef idx="2">
-            <a:schemeClr val="accent1"/>
-          </a:effectRef>
-          <a:fontRef idx="minor">
-            <a:schemeClr val="lt1"/>
-          </a:fontRef>
-        </p:style>
-        <p:txBody>
-          <a:bodyPr rtlCol="0" anchor="ctr"/>
-          <a:lstStyle/>
-          <a:p>
-            <a:pPr algn="ctr"/>
-          </a:p>
-        </p:txBody>
-      </p:sp>
-      <p:sp>
-        <p:nvSpPr>
-          <p:cNvPr id="4" name="TextBox 3"/>
+          <p:cNvPr id="3" name="TextBox 2"/>
           <p:cNvSpPr txBox="1"/>
           <p:nvPr/>
         </p:nvSpPr>
@@ -5620,7 +5335,7 @@
       </p:sp>
       <p:sp>
         <p:nvSpPr>
-          <p:cNvPr id="5" name="TextBox 4"/>
+          <p:cNvPr id="4" name="TextBox 3"/>
           <p:cNvSpPr txBox="1"/>
           <p:nvPr/>
         </p:nvSpPr>
@@ -5656,7 +5371,7 @@
       </p:sp>
       <p:sp>
         <p:nvSpPr>
-          <p:cNvPr id="6" name="Rectangle 5"/>
+          <p:cNvPr id="5" name="Rectangle 4"/>
           <p:cNvSpPr/>
           <p:nvPr/>
         </p:nvSpPr>
@@ -5699,50 +5414,7 @@
       </p:sp>
       <p:sp>
         <p:nvSpPr>
-          <p:cNvPr id="7" name="Rectangle 6"/>
-          <p:cNvSpPr/>
-          <p:nvPr/>
-        </p:nvSpPr>
-        <p:spPr>
-          <a:xfrm>
-            <a:off x="548640" y="2194560"/>
-            <a:ext cx="2468880" cy="36576"/>
-          </a:xfrm>
-          <a:prstGeom prst="rect">
-            <a:avLst/>
-          </a:prstGeom>
-          <a:solidFill>
-            <a:srgbClr val="E74C3C"/>
-          </a:solidFill>
-          <a:ln>
-            <a:noFill/>
-          </a:ln>
-        </p:spPr>
-        <p:style>
-          <a:lnRef idx="1">
-            <a:schemeClr val="accent1"/>
-          </a:lnRef>
-          <a:fillRef idx="3">
-            <a:schemeClr val="accent1"/>
-          </a:fillRef>
-          <a:effectRef idx="2">
-            <a:schemeClr val="accent1"/>
-          </a:effectRef>
-          <a:fontRef idx="minor">
-            <a:schemeClr val="lt1"/>
-          </a:fontRef>
-        </p:style>
-        <p:txBody>
-          <a:bodyPr rtlCol="0" anchor="ctr"/>
-          <a:lstStyle/>
-          <a:p>
-            <a:pPr algn="ctr"/>
-          </a:p>
-        </p:txBody>
-      </p:sp>
-      <p:sp>
-        <p:nvSpPr>
-          <p:cNvPr id="8" name="TextBox 7"/>
+          <p:cNvPr id="6" name="TextBox 5"/>
           <p:cNvSpPr txBox="1"/>
           <p:nvPr/>
         </p:nvSpPr>
@@ -5778,7 +5450,7 @@
       </p:sp>
       <p:sp>
         <p:nvSpPr>
-          <p:cNvPr id="9" name="TextBox 8"/>
+          <p:cNvPr id="7" name="TextBox 6"/>
           <p:cNvSpPr txBox="1"/>
           <p:nvPr/>
         </p:nvSpPr>
@@ -5814,7 +5486,7 @@
       </p:sp>
       <p:sp>
         <p:nvSpPr>
-          <p:cNvPr id="10" name="TextBox 9"/>
+          <p:cNvPr id="8" name="TextBox 7"/>
           <p:cNvSpPr txBox="1"/>
           <p:nvPr/>
         </p:nvSpPr>
@@ -5854,7 +5526,7 @@
       </p:sp>
       <p:sp>
         <p:nvSpPr>
-          <p:cNvPr id="11" name="Rectangle 10"/>
+          <p:cNvPr id="9" name="Rectangle 8"/>
           <p:cNvSpPr/>
           <p:nvPr/>
         </p:nvSpPr>
@@ -5897,50 +5569,7 @@
       </p:sp>
       <p:sp>
         <p:nvSpPr>
-          <p:cNvPr id="12" name="Rectangle 11"/>
-          <p:cNvSpPr/>
-          <p:nvPr/>
-        </p:nvSpPr>
-        <p:spPr>
-          <a:xfrm>
-            <a:off x="3246120" y="2194560"/>
-            <a:ext cx="2468880" cy="36576"/>
-          </a:xfrm>
-          <a:prstGeom prst="rect">
-            <a:avLst/>
-          </a:prstGeom>
-          <a:solidFill>
-            <a:srgbClr val="F4A623"/>
-          </a:solidFill>
-          <a:ln>
-            <a:noFill/>
-          </a:ln>
-        </p:spPr>
-        <p:style>
-          <a:lnRef idx="1">
-            <a:schemeClr val="accent1"/>
-          </a:lnRef>
-          <a:fillRef idx="3">
-            <a:schemeClr val="accent1"/>
-          </a:fillRef>
-          <a:effectRef idx="2">
-            <a:schemeClr val="accent1"/>
-          </a:effectRef>
-          <a:fontRef idx="minor">
-            <a:schemeClr val="lt1"/>
-          </a:fontRef>
-        </p:style>
-        <p:txBody>
-          <a:bodyPr rtlCol="0" anchor="ctr"/>
-          <a:lstStyle/>
-          <a:p>
-            <a:pPr algn="ctr"/>
-          </a:p>
-        </p:txBody>
-      </p:sp>
-      <p:sp>
-        <p:nvSpPr>
-          <p:cNvPr id="13" name="TextBox 12"/>
+          <p:cNvPr id="10" name="TextBox 9"/>
           <p:cNvSpPr txBox="1"/>
           <p:nvPr/>
         </p:nvSpPr>
@@ -5980,7 +5609,7 @@
       </p:sp>
       <p:sp>
         <p:nvSpPr>
-          <p:cNvPr id="14" name="TextBox 13"/>
+          <p:cNvPr id="11" name="TextBox 10"/>
           <p:cNvSpPr txBox="1"/>
           <p:nvPr/>
         </p:nvSpPr>
@@ -6016,7 +5645,7 @@
       </p:sp>
       <p:sp>
         <p:nvSpPr>
-          <p:cNvPr id="15" name="TextBox 14"/>
+          <p:cNvPr id="12" name="TextBox 11"/>
           <p:cNvSpPr txBox="1"/>
           <p:nvPr/>
         </p:nvSpPr>
@@ -6056,7 +5685,7 @@
       </p:sp>
       <p:sp>
         <p:nvSpPr>
-          <p:cNvPr id="16" name="Rectangle 15"/>
+          <p:cNvPr id="13" name="Rectangle 12"/>
           <p:cNvSpPr/>
           <p:nvPr/>
         </p:nvSpPr>
@@ -6099,50 +5728,7 @@
       </p:sp>
       <p:sp>
         <p:nvSpPr>
-          <p:cNvPr id="17" name="Rectangle 16"/>
-          <p:cNvSpPr/>
-          <p:nvPr/>
-        </p:nvSpPr>
-        <p:spPr>
-          <a:xfrm>
-            <a:off x="5943600" y="2194560"/>
-            <a:ext cx="2468880" cy="36576"/>
-          </a:xfrm>
-          <a:prstGeom prst="rect">
-            <a:avLst/>
-          </a:prstGeom>
-          <a:solidFill>
-            <a:srgbClr val="27AE60"/>
-          </a:solidFill>
-          <a:ln>
-            <a:noFill/>
-          </a:ln>
-        </p:spPr>
-        <p:style>
-          <a:lnRef idx="1">
-            <a:schemeClr val="accent1"/>
-          </a:lnRef>
-          <a:fillRef idx="3">
-            <a:schemeClr val="accent1"/>
-          </a:fillRef>
-          <a:effectRef idx="2">
-            <a:schemeClr val="accent1"/>
-          </a:effectRef>
-          <a:fontRef idx="minor">
-            <a:schemeClr val="lt1"/>
-          </a:fontRef>
-        </p:style>
-        <p:txBody>
-          <a:bodyPr rtlCol="0" anchor="ctr"/>
-          <a:lstStyle/>
-          <a:p>
-            <a:pPr algn="ctr"/>
-          </a:p>
-        </p:txBody>
-      </p:sp>
-      <p:sp>
-        <p:nvSpPr>
-          <p:cNvPr id="18" name="TextBox 17"/>
+          <p:cNvPr id="14" name="TextBox 13"/>
           <p:cNvSpPr txBox="1"/>
           <p:nvPr/>
         </p:nvSpPr>
@@ -6182,7 +5768,7 @@
       </p:sp>
       <p:sp>
         <p:nvSpPr>
-          <p:cNvPr id="19" name="TextBox 18"/>
+          <p:cNvPr id="15" name="TextBox 14"/>
           <p:cNvSpPr txBox="1"/>
           <p:nvPr/>
         </p:nvSpPr>
@@ -6218,7 +5804,7 @@
       </p:sp>
       <p:sp>
         <p:nvSpPr>
-          <p:cNvPr id="20" name="TextBox 19"/>
+          <p:cNvPr id="16" name="TextBox 15"/>
           <p:cNvSpPr txBox="1"/>
           <p:nvPr/>
         </p:nvSpPr>
@@ -6258,7 +5844,7 @@
       </p:sp>
       <p:sp>
         <p:nvSpPr>
-          <p:cNvPr id="21" name="TextBox 20"/>
+          <p:cNvPr id="17" name="TextBox 16"/>
           <p:cNvSpPr txBox="1"/>
           <p:nvPr/>
         </p:nvSpPr>
@@ -6292,30 +5878,6 @@
           </a:p>
         </p:txBody>
       </p:sp>
-      <p:pic>
-        <p:nvPicPr>
-          <p:cNvPr id="22" name="Picture 21" descr="08_threeway_contrast.png"/>
-          <p:cNvPicPr>
-            <a:picLocks noChangeAspect="1"/>
-          </p:cNvPicPr>
-          <p:nvPr/>
-        </p:nvPicPr>
-        <p:blipFill>
-          <a:blip r:embed="rId2"/>
-          <a:stretch>
-            <a:fillRect/>
-          </a:stretch>
-        </p:blipFill>
-        <p:spPr>
-          <a:xfrm>
-            <a:off x="7772400" y="4480560"/>
-            <a:ext cx="1371600" cy="640080"/>
-          </a:xfrm>
-          <a:prstGeom prst="rect">
-            <a:avLst/>
-          </a:prstGeom>
-        </p:spPr>
-      </p:pic>
     </p:spTree>
   </p:cSld>
   <p:clrMapOvr>
@@ -6380,50 +5942,7 @@
       </p:sp>
       <p:sp>
         <p:nvSpPr>
-          <p:cNvPr id="3" name="Rectangle 2"/>
-          <p:cNvSpPr/>
-          <p:nvPr/>
-        </p:nvSpPr>
-        <p:spPr>
-          <a:xfrm>
-            <a:off x="548640" y="777240"/>
-            <a:ext cx="1097280" cy="27432"/>
-          </a:xfrm>
-          <a:prstGeom prst="rect">
-            <a:avLst/>
-          </a:prstGeom>
-          <a:solidFill>
-            <a:srgbClr val="F4A623"/>
-          </a:solidFill>
-          <a:ln>
-            <a:noFill/>
-          </a:ln>
-        </p:spPr>
-        <p:style>
-          <a:lnRef idx="1">
-            <a:schemeClr val="accent1"/>
-          </a:lnRef>
-          <a:fillRef idx="3">
-            <a:schemeClr val="accent1"/>
-          </a:fillRef>
-          <a:effectRef idx="2">
-            <a:schemeClr val="accent1"/>
-          </a:effectRef>
-          <a:fontRef idx="minor">
-            <a:schemeClr val="lt1"/>
-          </a:fontRef>
-        </p:style>
-        <p:txBody>
-          <a:bodyPr rtlCol="0" anchor="ctr"/>
-          <a:lstStyle/>
-          <a:p>
-            <a:pPr algn="ctr"/>
-          </a:p>
-        </p:txBody>
-      </p:sp>
-      <p:sp>
-        <p:nvSpPr>
-          <p:cNvPr id="4" name="TextBox 3"/>
+          <p:cNvPr id="3" name="TextBox 2"/>
           <p:cNvSpPr txBox="1"/>
           <p:nvPr/>
         </p:nvSpPr>
@@ -6459,14 +5978,14 @@
       </p:sp>
       <p:sp>
         <p:nvSpPr>
-          <p:cNvPr id="5" name="TextBox 4"/>
+          <p:cNvPr id="4" name="TextBox 3"/>
           <p:cNvSpPr txBox="1"/>
           <p:nvPr/>
         </p:nvSpPr>
         <p:spPr>
           <a:xfrm>
             <a:off x="731520" y="1828800"/>
-            <a:ext cx="4572000" cy="320040"/>
+            <a:ext cx="4572000" cy="457200"/>
           </a:xfrm>
           <a:prstGeom prst="rect">
             <a:avLst/>
@@ -6495,14 +6014,14 @@
       </p:sp>
       <p:sp>
         <p:nvSpPr>
-          <p:cNvPr id="6" name="TextBox 5"/>
-          <p:cNvSpPr txBox="1"/>
-          <p:nvPr/>
-        </p:nvSpPr>
-        <p:spPr>
-          <a:xfrm>
-            <a:off x="731520" y="2148840"/>
-            <a:ext cx="4572000" cy="320040"/>
+          <p:cNvPr id="5" name="TextBox 4"/>
+          <p:cNvSpPr txBox="1"/>
+          <p:nvPr/>
+        </p:nvSpPr>
+        <p:spPr>
+          <a:xfrm>
+            <a:off x="731520" y="2331720"/>
+            <a:ext cx="4572000" cy="457200"/>
           </a:xfrm>
           <a:prstGeom prst="rect">
             <a:avLst/>
@@ -6531,13 +6050,13 @@
       </p:sp>
       <p:sp>
         <p:nvSpPr>
-          <p:cNvPr id="7" name="TextBox 6"/>
-          <p:cNvSpPr txBox="1"/>
-          <p:nvPr/>
-        </p:nvSpPr>
-        <p:spPr>
-          <a:xfrm>
-            <a:off x="548640" y="2651760"/>
+          <p:cNvPr id="6" name="TextBox 5"/>
+          <p:cNvSpPr txBox="1"/>
+          <p:nvPr/>
+        </p:nvSpPr>
+        <p:spPr>
+          <a:xfrm>
+            <a:off x="548640" y="3017520"/>
             <a:ext cx="4572000" cy="320040"/>
           </a:xfrm>
           <a:prstGeom prst="rect">
@@ -6567,13 +6086,13 @@
       </p:sp>
       <p:sp>
         <p:nvSpPr>
-          <p:cNvPr id="8" name="TextBox 7"/>
-          <p:cNvSpPr txBox="1"/>
-          <p:nvPr/>
-        </p:nvSpPr>
-        <p:spPr>
-          <a:xfrm>
-            <a:off x="548640" y="3017520"/>
+          <p:cNvPr id="7" name="TextBox 6"/>
+          <p:cNvSpPr txBox="1"/>
+          <p:nvPr/>
+        </p:nvSpPr>
+        <p:spPr>
+          <a:xfrm>
+            <a:off x="548640" y="3383279"/>
             <a:ext cx="4572000" cy="502920"/>
           </a:xfrm>
           <a:prstGeom prst="rect">
@@ -6603,13 +6122,13 @@
       </p:sp>
       <p:sp>
         <p:nvSpPr>
-          <p:cNvPr id="9" name="TextBox 8"/>
-          <p:cNvSpPr txBox="1"/>
-          <p:nvPr/>
-        </p:nvSpPr>
-        <p:spPr>
-          <a:xfrm>
-            <a:off x="548640" y="3566160"/>
+          <p:cNvPr id="8" name="TextBox 7"/>
+          <p:cNvSpPr txBox="1"/>
+          <p:nvPr/>
+        </p:nvSpPr>
+        <p:spPr>
+          <a:xfrm>
+            <a:off x="548640" y="3931920"/>
             <a:ext cx="4572000" cy="320040"/>
           </a:xfrm>
           <a:prstGeom prst="rect">
@@ -6639,7 +6158,7 @@
       </p:sp>
       <p:pic>
         <p:nvPicPr>
-          <p:cNvPr id="10" name="Picture 9" descr="03_naive_peak_HERO.png"/>
+          <p:cNvPr id="9" name="Picture 8" descr="03_naive_peak_HERO.png"/>
           <p:cNvPicPr>
             <a:picLocks noChangeAspect="1"/>
           </p:cNvPicPr>
@@ -6725,50 +6244,7 @@
       </p:sp>
       <p:sp>
         <p:nvSpPr>
-          <p:cNvPr id="3" name="Rectangle 2"/>
-          <p:cNvSpPr/>
-          <p:nvPr/>
-        </p:nvSpPr>
-        <p:spPr>
-          <a:xfrm>
-            <a:off x="548640" y="777240"/>
-            <a:ext cx="1097280" cy="27432"/>
-          </a:xfrm>
-          <a:prstGeom prst="rect">
-            <a:avLst/>
-          </a:prstGeom>
-          <a:solidFill>
-            <a:srgbClr val="F4A623"/>
-          </a:solidFill>
-          <a:ln>
-            <a:noFill/>
-          </a:ln>
-        </p:spPr>
-        <p:style>
-          <a:lnRef idx="1">
-            <a:schemeClr val="accent1"/>
-          </a:lnRef>
-          <a:fillRef idx="3">
-            <a:schemeClr val="accent1"/>
-          </a:fillRef>
-          <a:effectRef idx="2">
-            <a:schemeClr val="accent1"/>
-          </a:effectRef>
-          <a:fontRef idx="minor">
-            <a:schemeClr val="lt1"/>
-          </a:fontRef>
-        </p:style>
-        <p:txBody>
-          <a:bodyPr rtlCol="0" anchor="ctr"/>
-          <a:lstStyle/>
-          <a:p>
-            <a:pPr algn="ctr"/>
-          </a:p>
-        </p:txBody>
-      </p:sp>
-      <p:sp>
-        <p:nvSpPr>
-          <p:cNvPr id="4" name="TextBox 3"/>
+          <p:cNvPr id="3" name="TextBox 2"/>
           <p:cNvSpPr txBox="1"/>
           <p:nvPr/>
         </p:nvSpPr>
@@ -6804,7 +6280,7 @@
       </p:sp>
       <p:sp>
         <p:nvSpPr>
-          <p:cNvPr id="5" name="Rectangle 4"/>
+          <p:cNvPr id="4" name="Rectangle 3"/>
           <p:cNvSpPr/>
           <p:nvPr/>
         </p:nvSpPr>
@@ -6847,50 +6323,7 @@
       </p:sp>
       <p:sp>
         <p:nvSpPr>
-          <p:cNvPr id="6" name="Rectangle 5"/>
-          <p:cNvSpPr/>
-          <p:nvPr/>
-        </p:nvSpPr>
-        <p:spPr>
-          <a:xfrm>
-            <a:off x="548640" y="1645920"/>
-            <a:ext cx="1828800" cy="36576"/>
-          </a:xfrm>
-          <a:prstGeom prst="rect">
-            <a:avLst/>
-          </a:prstGeom>
-          <a:solidFill>
-            <a:srgbClr val="4A90D9"/>
-          </a:solidFill>
-          <a:ln>
-            <a:noFill/>
-          </a:ln>
-        </p:spPr>
-        <p:style>
-          <a:lnRef idx="1">
-            <a:schemeClr val="accent1"/>
-          </a:lnRef>
-          <a:fillRef idx="3">
-            <a:schemeClr val="accent1"/>
-          </a:fillRef>
-          <a:effectRef idx="2">
-            <a:schemeClr val="accent1"/>
-          </a:effectRef>
-          <a:fontRef idx="minor">
-            <a:schemeClr val="lt1"/>
-          </a:fontRef>
-        </p:style>
-        <p:txBody>
-          <a:bodyPr rtlCol="0" anchor="ctr"/>
-          <a:lstStyle/>
-          <a:p>
-            <a:pPr algn="ctr"/>
-          </a:p>
-        </p:txBody>
-      </p:sp>
-      <p:sp>
-        <p:nvSpPr>
-          <p:cNvPr id="7" name="TextBox 6"/>
+          <p:cNvPr id="5" name="TextBox 4"/>
           <p:cNvSpPr txBox="1"/>
           <p:nvPr/>
         </p:nvSpPr>
@@ -6926,7 +6359,7 @@
       </p:sp>
       <p:sp>
         <p:nvSpPr>
-          <p:cNvPr id="8" name="TextBox 7"/>
+          <p:cNvPr id="6" name="TextBox 5"/>
           <p:cNvSpPr txBox="1"/>
           <p:nvPr/>
         </p:nvSpPr>
@@ -6966,7 +6399,7 @@
       </p:sp>
       <p:sp>
         <p:nvSpPr>
-          <p:cNvPr id="9" name="TextBox 8"/>
+          <p:cNvPr id="7" name="TextBox 6"/>
           <p:cNvSpPr txBox="1"/>
           <p:nvPr/>
         </p:nvSpPr>
@@ -7002,7 +6435,7 @@
       </p:sp>
       <p:sp>
         <p:nvSpPr>
-          <p:cNvPr id="10" name="Rectangle 9"/>
+          <p:cNvPr id="8" name="Rectangle 7"/>
           <p:cNvSpPr/>
           <p:nvPr/>
         </p:nvSpPr>
@@ -7045,50 +6478,7 @@
       </p:sp>
       <p:sp>
         <p:nvSpPr>
-          <p:cNvPr id="11" name="Rectangle 10"/>
-          <p:cNvSpPr/>
-          <p:nvPr/>
-        </p:nvSpPr>
-        <p:spPr>
-          <a:xfrm>
-            <a:off x="2651760" y="1645920"/>
-            <a:ext cx="1828800" cy="36576"/>
-          </a:xfrm>
-          <a:prstGeom prst="rect">
-            <a:avLst/>
-          </a:prstGeom>
-          <a:solidFill>
-            <a:srgbClr val="50B87D"/>
-          </a:solidFill>
-          <a:ln>
-            <a:noFill/>
-          </a:ln>
-        </p:spPr>
-        <p:style>
-          <a:lnRef idx="1">
-            <a:schemeClr val="accent1"/>
-          </a:lnRef>
-          <a:fillRef idx="3">
-            <a:schemeClr val="accent1"/>
-          </a:fillRef>
-          <a:effectRef idx="2">
-            <a:schemeClr val="accent1"/>
-          </a:effectRef>
-          <a:fontRef idx="minor">
-            <a:schemeClr val="lt1"/>
-          </a:fontRef>
-        </p:style>
-        <p:txBody>
-          <a:bodyPr rtlCol="0" anchor="ctr"/>
-          <a:lstStyle/>
-          <a:p>
-            <a:pPr algn="ctr"/>
-          </a:p>
-        </p:txBody>
-      </p:sp>
-      <p:sp>
-        <p:nvSpPr>
-          <p:cNvPr id="12" name="TextBox 11"/>
+          <p:cNvPr id="9" name="TextBox 8"/>
           <p:cNvSpPr txBox="1"/>
           <p:nvPr/>
         </p:nvSpPr>
@@ -7124,7 +6514,7 @@
       </p:sp>
       <p:sp>
         <p:nvSpPr>
-          <p:cNvPr id="13" name="TextBox 12"/>
+          <p:cNvPr id="10" name="TextBox 9"/>
           <p:cNvSpPr txBox="1"/>
           <p:nvPr/>
         </p:nvSpPr>
@@ -7164,7 +6554,7 @@
       </p:sp>
       <p:sp>
         <p:nvSpPr>
-          <p:cNvPr id="14" name="TextBox 13"/>
+          <p:cNvPr id="11" name="TextBox 10"/>
           <p:cNvSpPr txBox="1"/>
           <p:nvPr/>
         </p:nvSpPr>
@@ -7200,7 +6590,7 @@
       </p:sp>
       <p:sp>
         <p:nvSpPr>
-          <p:cNvPr id="15" name="Rectangle 14"/>
+          <p:cNvPr id="12" name="Rectangle 11"/>
           <p:cNvSpPr/>
           <p:nvPr/>
         </p:nvSpPr>
@@ -7243,50 +6633,7 @@
       </p:sp>
       <p:sp>
         <p:nvSpPr>
-          <p:cNvPr id="16" name="Rectangle 15"/>
-          <p:cNvSpPr/>
-          <p:nvPr/>
-        </p:nvSpPr>
-        <p:spPr>
-          <a:xfrm>
-            <a:off x="4754879" y="1645920"/>
-            <a:ext cx="1828800" cy="36576"/>
-          </a:xfrm>
-          <a:prstGeom prst="rect">
-            <a:avLst/>
-          </a:prstGeom>
-          <a:solidFill>
-            <a:srgbClr val="F4A623"/>
-          </a:solidFill>
-          <a:ln>
-            <a:noFill/>
-          </a:ln>
-        </p:spPr>
-        <p:style>
-          <a:lnRef idx="1">
-            <a:schemeClr val="accent1"/>
-          </a:lnRef>
-          <a:fillRef idx="3">
-            <a:schemeClr val="accent1"/>
-          </a:fillRef>
-          <a:effectRef idx="2">
-            <a:schemeClr val="accent1"/>
-          </a:effectRef>
-          <a:fontRef idx="minor">
-            <a:schemeClr val="lt1"/>
-          </a:fontRef>
-        </p:style>
-        <p:txBody>
-          <a:bodyPr rtlCol="0" anchor="ctr"/>
-          <a:lstStyle/>
-          <a:p>
-            <a:pPr algn="ctr"/>
-          </a:p>
-        </p:txBody>
-      </p:sp>
-      <p:sp>
-        <p:nvSpPr>
-          <p:cNvPr id="17" name="TextBox 16"/>
+          <p:cNvPr id="13" name="TextBox 12"/>
           <p:cNvSpPr txBox="1"/>
           <p:nvPr/>
         </p:nvSpPr>
@@ -7322,7 +6669,7 @@
       </p:sp>
       <p:sp>
         <p:nvSpPr>
-          <p:cNvPr id="18" name="TextBox 17"/>
+          <p:cNvPr id="14" name="TextBox 13"/>
           <p:cNvSpPr txBox="1"/>
           <p:nvPr/>
         </p:nvSpPr>
@@ -7362,7 +6709,7 @@
       </p:sp>
       <p:sp>
         <p:nvSpPr>
-          <p:cNvPr id="19" name="TextBox 18"/>
+          <p:cNvPr id="15" name="TextBox 14"/>
           <p:cNvSpPr txBox="1"/>
           <p:nvPr/>
         </p:nvSpPr>
@@ -7398,7 +6745,7 @@
       </p:sp>
       <p:sp>
         <p:nvSpPr>
-          <p:cNvPr id="20" name="Rectangle 19"/>
+          <p:cNvPr id="16" name="Rectangle 15"/>
           <p:cNvSpPr/>
           <p:nvPr/>
         </p:nvSpPr>
@@ -7441,50 +6788,7 @@
       </p:sp>
       <p:sp>
         <p:nvSpPr>
-          <p:cNvPr id="21" name="Rectangle 20"/>
-          <p:cNvSpPr/>
-          <p:nvPr/>
-        </p:nvSpPr>
-        <p:spPr>
-          <a:xfrm>
-            <a:off x="6857999" y="1645920"/>
-            <a:ext cx="1828800" cy="36576"/>
-          </a:xfrm>
-          <a:prstGeom prst="rect">
-            <a:avLst/>
-          </a:prstGeom>
-          <a:solidFill>
-            <a:srgbClr val="E74C3C"/>
-          </a:solidFill>
-          <a:ln>
-            <a:noFill/>
-          </a:ln>
-        </p:spPr>
-        <p:style>
-          <a:lnRef idx="1">
-            <a:schemeClr val="accent1"/>
-          </a:lnRef>
-          <a:fillRef idx="3">
-            <a:schemeClr val="accent1"/>
-          </a:fillRef>
-          <a:effectRef idx="2">
-            <a:schemeClr val="accent1"/>
-          </a:effectRef>
-          <a:fontRef idx="minor">
-            <a:schemeClr val="lt1"/>
-          </a:fontRef>
-        </p:style>
-        <p:txBody>
-          <a:bodyPr rtlCol="0" anchor="ctr"/>
-          <a:lstStyle/>
-          <a:p>
-            <a:pPr algn="ctr"/>
-          </a:p>
-        </p:txBody>
-      </p:sp>
-      <p:sp>
-        <p:nvSpPr>
-          <p:cNvPr id="22" name="TextBox 21"/>
+          <p:cNvPr id="17" name="TextBox 16"/>
           <p:cNvSpPr txBox="1"/>
           <p:nvPr/>
         </p:nvSpPr>
@@ -7520,7 +6824,7 @@
       </p:sp>
       <p:sp>
         <p:nvSpPr>
-          <p:cNvPr id="23" name="TextBox 22"/>
+          <p:cNvPr id="18" name="TextBox 17"/>
           <p:cNvSpPr txBox="1"/>
           <p:nvPr/>
         </p:nvSpPr>
@@ -7560,7 +6864,7 @@
       </p:sp>
       <p:sp>
         <p:nvSpPr>
-          <p:cNvPr id="24" name="Rectangle 23"/>
+          <p:cNvPr id="19" name="Rectangle 18"/>
           <p:cNvSpPr/>
           <p:nvPr/>
         </p:nvSpPr>
@@ -7603,7 +6907,7 @@
       </p:sp>
       <p:sp>
         <p:nvSpPr>
-          <p:cNvPr id="25" name="TextBox 24"/>
+          <p:cNvPr id="20" name="TextBox 19"/>
           <p:cNvSpPr txBox="1"/>
           <p:nvPr/>
         </p:nvSpPr>
@@ -7639,7 +6943,7 @@
       </p:sp>
       <p:sp>
         <p:nvSpPr>
-          <p:cNvPr id="26" name="Rectangle 25"/>
+          <p:cNvPr id="21" name="Rectangle 20"/>
           <p:cNvSpPr/>
           <p:nvPr/>
         </p:nvSpPr>
@@ -7682,7 +6986,7 @@
       </p:sp>
       <p:sp>
         <p:nvSpPr>
-          <p:cNvPr id="27" name="TextBox 26"/>
+          <p:cNvPr id="22" name="TextBox 21"/>
           <p:cNvSpPr txBox="1"/>
           <p:nvPr/>
         </p:nvSpPr>
@@ -7718,7 +7022,7 @@
       </p:sp>
       <p:sp>
         <p:nvSpPr>
-          <p:cNvPr id="28" name="TextBox 27"/>
+          <p:cNvPr id="23" name="TextBox 22"/>
           <p:cNvSpPr txBox="1"/>
           <p:nvPr/>
         </p:nvSpPr>
@@ -7822,49 +7126,6 @@
         </p:nvSpPr>
         <p:spPr>
           <a:xfrm>
-            <a:off x="548640" y="777240"/>
-            <a:ext cx="1097280" cy="27432"/>
-          </a:xfrm>
-          <a:prstGeom prst="rect">
-            <a:avLst/>
-          </a:prstGeom>
-          <a:solidFill>
-            <a:srgbClr val="F4A623"/>
-          </a:solidFill>
-          <a:ln>
-            <a:noFill/>
-          </a:ln>
-        </p:spPr>
-        <p:style>
-          <a:lnRef idx="1">
-            <a:schemeClr val="accent1"/>
-          </a:lnRef>
-          <a:fillRef idx="3">
-            <a:schemeClr val="accent1"/>
-          </a:fillRef>
-          <a:effectRef idx="2">
-            <a:schemeClr val="accent1"/>
-          </a:effectRef>
-          <a:fontRef idx="minor">
-            <a:schemeClr val="lt1"/>
-          </a:fontRef>
-        </p:style>
-        <p:txBody>
-          <a:bodyPr rtlCol="0" anchor="ctr"/>
-          <a:lstStyle/>
-          <a:p>
-            <a:pPr algn="ctr"/>
-          </a:p>
-        </p:txBody>
-      </p:sp>
-      <p:sp>
-        <p:nvSpPr>
-          <p:cNvPr id="4" name="Rectangle 3"/>
-          <p:cNvSpPr/>
-          <p:nvPr/>
-        </p:nvSpPr>
-        <p:spPr>
-          <a:xfrm>
             <a:off x="640080" y="1188720"/>
             <a:ext cx="3657600" cy="347472"/>
           </a:xfrm>
@@ -7902,7 +7163,7 @@
       </p:sp>
       <p:sp>
         <p:nvSpPr>
-          <p:cNvPr id="5" name="TextBox 4"/>
+          <p:cNvPr id="4" name="TextBox 3"/>
           <p:cNvSpPr txBox="1"/>
           <p:nvPr/>
         </p:nvSpPr>
@@ -7938,7 +7199,7 @@
       </p:sp>
       <p:sp>
         <p:nvSpPr>
-          <p:cNvPr id="6" name="Rectangle 5"/>
+          <p:cNvPr id="5" name="Rectangle 4"/>
           <p:cNvSpPr/>
           <p:nvPr/>
         </p:nvSpPr>
@@ -7981,7 +7242,7 @@
       </p:sp>
       <p:sp>
         <p:nvSpPr>
-          <p:cNvPr id="7" name="TextBox 6"/>
+          <p:cNvPr id="6" name="TextBox 5"/>
           <p:cNvSpPr txBox="1"/>
           <p:nvPr/>
         </p:nvSpPr>
@@ -8017,7 +7278,7 @@
       </p:sp>
       <p:sp>
         <p:nvSpPr>
-          <p:cNvPr id="8" name="Rectangle 7"/>
+          <p:cNvPr id="7" name="Rectangle 6"/>
           <p:cNvSpPr/>
           <p:nvPr/>
         </p:nvSpPr>
@@ -8060,7 +7321,7 @@
       </p:sp>
       <p:sp>
         <p:nvSpPr>
-          <p:cNvPr id="9" name="TextBox 8"/>
+          <p:cNvPr id="8" name="TextBox 7"/>
           <p:cNvSpPr txBox="1"/>
           <p:nvPr/>
         </p:nvSpPr>
@@ -8096,7 +7357,7 @@
       </p:sp>
       <p:sp>
         <p:nvSpPr>
-          <p:cNvPr id="10" name="TextBox 9"/>
+          <p:cNvPr id="9" name="TextBox 8"/>
           <p:cNvSpPr txBox="1"/>
           <p:nvPr/>
         </p:nvSpPr>
@@ -8132,7 +7393,7 @@
       </p:sp>
       <p:sp>
         <p:nvSpPr>
-          <p:cNvPr id="11" name="TextBox 10"/>
+          <p:cNvPr id="10" name="TextBox 9"/>
           <p:cNvSpPr txBox="1"/>
           <p:nvPr/>
         </p:nvSpPr>
@@ -8168,7 +7429,7 @@
       </p:sp>
       <p:sp>
         <p:nvSpPr>
-          <p:cNvPr id="12" name="TextBox 11"/>
+          <p:cNvPr id="11" name="TextBox 10"/>
           <p:cNvSpPr txBox="1"/>
           <p:nvPr/>
         </p:nvSpPr>
@@ -8204,7 +7465,7 @@
       </p:sp>
       <p:sp>
         <p:nvSpPr>
-          <p:cNvPr id="13" name="Rectangle 12"/>
+          <p:cNvPr id="12" name="Rectangle 11"/>
           <p:cNvSpPr/>
           <p:nvPr/>
         </p:nvSpPr>
@@ -8247,7 +7508,7 @@
       </p:sp>
       <p:sp>
         <p:nvSpPr>
-          <p:cNvPr id="14" name="TextBox 13"/>
+          <p:cNvPr id="13" name="TextBox 12"/>
           <p:cNvSpPr txBox="1"/>
           <p:nvPr/>
         </p:nvSpPr>
@@ -8283,7 +7544,7 @@
       </p:sp>
       <p:sp>
         <p:nvSpPr>
-          <p:cNvPr id="15" name="Rectangle 14"/>
+          <p:cNvPr id="14" name="Rectangle 13"/>
           <p:cNvSpPr/>
           <p:nvPr/>
         </p:nvSpPr>
@@ -8326,7 +7587,7 @@
       </p:sp>
       <p:sp>
         <p:nvSpPr>
-          <p:cNvPr id="16" name="TextBox 15"/>
+          <p:cNvPr id="15" name="TextBox 14"/>
           <p:cNvSpPr txBox="1"/>
           <p:nvPr/>
         </p:nvSpPr>
@@ -8362,7 +7623,7 @@
       </p:sp>
       <p:sp>
         <p:nvSpPr>
-          <p:cNvPr id="17" name="Rectangle 16"/>
+          <p:cNvPr id="16" name="Rectangle 15"/>
           <p:cNvSpPr/>
           <p:nvPr/>
         </p:nvSpPr>
@@ -8405,7 +7666,7 @@
       </p:sp>
       <p:sp>
         <p:nvSpPr>
-          <p:cNvPr id="18" name="TextBox 17"/>
+          <p:cNvPr id="17" name="TextBox 16"/>
           <p:cNvSpPr txBox="1"/>
           <p:nvPr/>
         </p:nvSpPr>
@@ -8441,7 +7702,7 @@
       </p:sp>
       <p:sp>
         <p:nvSpPr>
-          <p:cNvPr id="19" name="TextBox 18"/>
+          <p:cNvPr id="18" name="TextBox 17"/>
           <p:cNvSpPr txBox="1"/>
           <p:nvPr/>
         </p:nvSpPr>
@@ -8477,7 +7738,7 @@
       </p:sp>
       <p:sp>
         <p:nvSpPr>
-          <p:cNvPr id="20" name="TextBox 19"/>
+          <p:cNvPr id="19" name="TextBox 18"/>
           <p:cNvSpPr txBox="1"/>
           <p:nvPr/>
         </p:nvSpPr>
@@ -8513,7 +7774,7 @@
       </p:sp>
       <p:sp>
         <p:nvSpPr>
-          <p:cNvPr id="21" name="TextBox 20"/>
+          <p:cNvPr id="20" name="TextBox 19"/>
           <p:cNvSpPr txBox="1"/>
           <p:nvPr/>
         </p:nvSpPr>
@@ -8549,7 +7810,7 @@
       </p:sp>
       <p:sp>
         <p:nvSpPr>
-          <p:cNvPr id="22" name="Rectangle 21"/>
+          <p:cNvPr id="21" name="Rectangle 20"/>
           <p:cNvSpPr/>
           <p:nvPr/>
         </p:nvSpPr>
@@ -8592,7 +7853,7 @@
       </p:sp>
       <p:sp>
         <p:nvSpPr>
-          <p:cNvPr id="23" name="TextBox 22"/>
+          <p:cNvPr id="22" name="TextBox 21"/>
           <p:cNvSpPr txBox="1"/>
           <p:nvPr/>
         </p:nvSpPr>
@@ -8628,7 +7889,7 @@
       </p:sp>
       <p:sp>
         <p:nvSpPr>
-          <p:cNvPr id="24" name="Rectangle 23"/>
+          <p:cNvPr id="23" name="Rectangle 22"/>
           <p:cNvSpPr/>
           <p:nvPr/>
         </p:nvSpPr>
@@ -8671,7 +7932,7 @@
       </p:sp>
       <p:sp>
         <p:nvSpPr>
-          <p:cNvPr id="25" name="TextBox 24"/>
+          <p:cNvPr id="24" name="TextBox 23"/>
           <p:cNvSpPr txBox="1"/>
           <p:nvPr/>
         </p:nvSpPr>
@@ -8707,7 +7968,7 @@
       </p:sp>
       <p:sp>
         <p:nvSpPr>
-          <p:cNvPr id="26" name="Rectangle 25"/>
+          <p:cNvPr id="25" name="Rectangle 24"/>
           <p:cNvSpPr/>
           <p:nvPr/>
         </p:nvSpPr>
@@ -8750,7 +8011,7 @@
       </p:sp>
       <p:sp>
         <p:nvSpPr>
-          <p:cNvPr id="27" name="TextBox 26"/>
+          <p:cNvPr id="26" name="TextBox 25"/>
           <p:cNvSpPr txBox="1"/>
           <p:nvPr/>
         </p:nvSpPr>
@@ -8786,7 +8047,7 @@
       </p:sp>
       <p:sp>
         <p:nvSpPr>
-          <p:cNvPr id="28" name="TextBox 27"/>
+          <p:cNvPr id="27" name="TextBox 26"/>
           <p:cNvSpPr txBox="1"/>
           <p:nvPr/>
         </p:nvSpPr>
@@ -8822,7 +8083,7 @@
       </p:sp>
       <p:sp>
         <p:nvSpPr>
-          <p:cNvPr id="29" name="TextBox 28"/>
+          <p:cNvPr id="28" name="TextBox 27"/>
           <p:cNvSpPr txBox="1"/>
           <p:nvPr/>
         </p:nvSpPr>
@@ -8858,7 +8119,7 @@
       </p:sp>
       <p:sp>
         <p:nvSpPr>
-          <p:cNvPr id="30" name="TextBox 29"/>
+          <p:cNvPr id="29" name="TextBox 28"/>
           <p:cNvSpPr txBox="1"/>
           <p:nvPr/>
         </p:nvSpPr>
@@ -8894,7 +8155,7 @@
       </p:sp>
       <p:sp>
         <p:nvSpPr>
-          <p:cNvPr id="31" name="TextBox 30"/>
+          <p:cNvPr id="30" name="TextBox 29"/>
           <p:cNvSpPr txBox="1"/>
           <p:nvPr/>
         </p:nvSpPr>
@@ -8930,7 +8191,7 @@
       </p:sp>
       <p:sp>
         <p:nvSpPr>
-          <p:cNvPr id="32" name="TextBox 31"/>
+          <p:cNvPr id="31" name="TextBox 30"/>
           <p:cNvSpPr txBox="1"/>
           <p:nvPr/>
         </p:nvSpPr>
@@ -8964,30 +8225,6 @@
           </a:p>
         </p:txBody>
       </p:sp>
-      <p:pic>
-        <p:nvPicPr>
-          <p:cNvPr id="33" name="Picture 32" descr="07_side_by_side_peak.png"/>
-          <p:cNvPicPr>
-            <a:picLocks noChangeAspect="1"/>
-          </p:cNvPicPr>
-          <p:nvPr/>
-        </p:nvPicPr>
-        <p:blipFill>
-          <a:blip r:embed="rId2"/>
-          <a:stretch>
-            <a:fillRect/>
-          </a:stretch>
-        </p:blipFill>
-        <p:spPr>
-          <a:xfrm>
-            <a:off x="5486400" y="4297680"/>
-            <a:ext cx="3657600" cy="822960"/>
-          </a:xfrm>
-          <a:prstGeom prst="rect">
-            <a:avLst/>
-          </a:prstGeom>
-        </p:spPr>
-      </p:pic>
     </p:spTree>
   </p:cSld>
   <p:clrMapOvr>
@@ -9050,52 +8287,9 @@
           </a:p>
         </p:txBody>
       </p:sp>
-      <p:sp>
-        <p:nvSpPr>
-          <p:cNvPr id="3" name="Rectangle 2"/>
-          <p:cNvSpPr/>
-          <p:nvPr/>
-        </p:nvSpPr>
-        <p:spPr>
-          <a:xfrm>
-            <a:off x="548640" y="777240"/>
-            <a:ext cx="1097280" cy="27432"/>
-          </a:xfrm>
-          <a:prstGeom prst="rect">
-            <a:avLst/>
-          </a:prstGeom>
-          <a:solidFill>
-            <a:srgbClr val="F4A623"/>
-          </a:solidFill>
-          <a:ln>
-            <a:noFill/>
-          </a:ln>
-        </p:spPr>
-        <p:style>
-          <a:lnRef idx="1">
-            <a:schemeClr val="accent1"/>
-          </a:lnRef>
-          <a:fillRef idx="3">
-            <a:schemeClr val="accent1"/>
-          </a:fillRef>
-          <a:effectRef idx="2">
-            <a:schemeClr val="accent1"/>
-          </a:effectRef>
-          <a:fontRef idx="minor">
-            <a:schemeClr val="lt1"/>
-          </a:fontRef>
-        </p:style>
-        <p:txBody>
-          <a:bodyPr rtlCol="0" anchor="ctr"/>
-          <a:lstStyle/>
-          <a:p>
-            <a:pPr algn="ctr"/>
-          </a:p>
-        </p:txBody>
-      </p:sp>
       <p:pic>
         <p:nvPicPr>
-          <p:cNvPr id="4" name="Picture 3" descr="06_gossip_compliance_card.png"/>
+          <p:cNvPr id="3" name="Picture 2" descr="06_gossip_compliance_card.png"/>
           <p:cNvPicPr>
             <a:picLocks noChangeAspect="1"/>
           </p:cNvPicPr>
@@ -9119,7 +8313,7 @@
       </p:pic>
       <p:sp>
         <p:nvSpPr>
-          <p:cNvPr id="5" name="TextBox 4"/>
+          <p:cNvPr id="4" name="TextBox 3"/>
           <p:cNvSpPr txBox="1"/>
           <p:nvPr/>
         </p:nvSpPr>
@@ -9155,7 +8349,7 @@
       </p:sp>
       <p:sp>
         <p:nvSpPr>
-          <p:cNvPr id="6" name="TextBox 5"/>
+          <p:cNvPr id="5" name="TextBox 4"/>
           <p:cNvSpPr txBox="1"/>
           <p:nvPr/>
         </p:nvSpPr>
@@ -9191,7 +8385,7 @@
       </p:sp>
       <p:sp>
         <p:nvSpPr>
-          <p:cNvPr id="7" name="TextBox 6"/>
+          <p:cNvPr id="6" name="TextBox 5"/>
           <p:cNvSpPr txBox="1"/>
           <p:nvPr/>
         </p:nvSpPr>
@@ -9227,7 +8421,7 @@
       </p:sp>
       <p:sp>
         <p:nvSpPr>
-          <p:cNvPr id="8" name="TextBox 7"/>
+          <p:cNvPr id="7" name="TextBox 6"/>
           <p:cNvSpPr txBox="1"/>
           <p:nvPr/>
         </p:nvSpPr>
@@ -9263,7 +8457,7 @@
       </p:sp>
       <p:sp>
         <p:nvSpPr>
-          <p:cNvPr id="9" name="TextBox 8"/>
+          <p:cNvPr id="8" name="TextBox 7"/>
           <p:cNvSpPr txBox="1"/>
           <p:nvPr/>
         </p:nvSpPr>
@@ -9299,7 +8493,7 @@
       </p:sp>
       <p:sp>
         <p:nvSpPr>
-          <p:cNvPr id="10" name="TextBox 9"/>
+          <p:cNvPr id="9" name="TextBox 8"/>
           <p:cNvSpPr txBox="1"/>
           <p:nvPr/>
         </p:nvSpPr>
@@ -9335,56 +8529,13 @@
       </p:sp>
       <p:sp>
         <p:nvSpPr>
-          <p:cNvPr id="11" name="Rectangle 10"/>
-          <p:cNvSpPr/>
-          <p:nvPr/>
-        </p:nvSpPr>
-        <p:spPr>
-          <a:xfrm>
-            <a:off x="5394960" y="3520440"/>
-            <a:ext cx="3474720" cy="36576"/>
-          </a:xfrm>
-          <a:prstGeom prst="rect">
-            <a:avLst/>
-          </a:prstGeom>
-          <a:solidFill>
-            <a:srgbClr val="F4A623"/>
-          </a:solidFill>
-          <a:ln>
-            <a:noFill/>
-          </a:ln>
-        </p:spPr>
-        <p:style>
-          <a:lnRef idx="1">
-            <a:schemeClr val="accent1"/>
-          </a:lnRef>
-          <a:fillRef idx="3">
-            <a:schemeClr val="accent1"/>
-          </a:fillRef>
-          <a:effectRef idx="2">
-            <a:schemeClr val="accent1"/>
-          </a:effectRef>
-          <a:fontRef idx="minor">
-            <a:schemeClr val="lt1"/>
-          </a:fontRef>
-        </p:style>
-        <p:txBody>
-          <a:bodyPr rtlCol="0" anchor="ctr"/>
-          <a:lstStyle/>
-          <a:p>
-            <a:pPr algn="ctr"/>
-          </a:p>
-        </p:txBody>
-      </p:sp>
-      <p:sp>
-        <p:nvSpPr>
-          <p:cNvPr id="12" name="TextBox 11"/>
-          <p:cNvSpPr txBox="1"/>
-          <p:nvPr/>
-        </p:nvSpPr>
-        <p:spPr>
-          <a:xfrm>
-            <a:off x="5394960" y="3703320"/>
+          <p:cNvPr id="10" name="TextBox 9"/>
+          <p:cNvSpPr txBox="1"/>
+          <p:nvPr/>
+        </p:nvSpPr>
+        <p:spPr>
+          <a:xfrm>
+            <a:off x="5394960" y="3566160"/>
             <a:ext cx="3474720" cy="457200"/>
           </a:xfrm>
           <a:prstGeom prst="rect">
@@ -9414,7 +8565,7 @@
       </p:sp>
       <p:sp>
         <p:nvSpPr>
-          <p:cNvPr id="13" name="TextBox 12"/>
+          <p:cNvPr id="11" name="TextBox 10"/>
           <p:cNvSpPr txBox="1"/>
           <p:nvPr/>
         </p:nvSpPr>
@@ -9512,14 +8663,287 @@
       </p:sp>
       <p:sp>
         <p:nvSpPr>
-          <p:cNvPr id="3" name="Rectangle 2"/>
+          <p:cNvPr id="3" name="TextBox 2"/>
+          <p:cNvSpPr txBox="1"/>
+          <p:nvPr/>
+        </p:nvSpPr>
+        <p:spPr>
+          <a:xfrm>
+            <a:off x="548640" y="1097280"/>
+            <a:ext cx="8046720" cy="411480"/>
+          </a:xfrm>
+          <a:prstGeom prst="rect">
+            <a:avLst/>
+          </a:prstGeom>
+          <a:noFill/>
+        </p:spPr>
+        <p:txBody>
+          <a:bodyPr wrap="square">
+            <a:spAutoFit/>
+          </a:bodyPr>
+          <a:lstStyle/>
+          <a:p>
+            <a:pPr algn="l">
+              <a:defRPr sz="1600" b="1" i="0">
+                <a:solidFill>
+                  <a:srgbClr val="FFFFFF"/>
+                </a:solidFill>
+                <a:latin typeface="Calibri"/>
+              </a:defRPr>
+            </a:pPr>
+            <a:r>
+              <a:t>GridAI is not a replacement for DERMS or VPP platforms.</a:t>
+            </a:r>
+          </a:p>
+        </p:txBody>
+      </p:sp>
+      <p:sp>
+        <p:nvSpPr>
+          <p:cNvPr id="4" name="TextBox 3"/>
+          <p:cNvSpPr txBox="1"/>
+          <p:nvPr/>
+        </p:nvSpPr>
+        <p:spPr>
+          <a:xfrm>
+            <a:off x="548640" y="1508760"/>
+            <a:ext cx="8046720" cy="320040"/>
+          </a:xfrm>
+          <a:prstGeom prst="rect">
+            <a:avLst/>
+          </a:prstGeom>
+          <a:noFill/>
+        </p:spPr>
+        <p:txBody>
+          <a:bodyPr wrap="square">
+            <a:spAutoFit/>
+          </a:bodyPr>
+          <a:lstStyle/>
+          <a:p>
+            <a:pPr algn="l">
+              <a:defRPr sz="1300" b="0" i="0">
+                <a:solidFill>
+                  <a:srgbClr val="B8C8D8"/>
+                </a:solidFill>
+                <a:latin typeface="Calibri"/>
+              </a:defRPr>
+            </a:pPr>
+            <a:r>
+              <a:t>It is an assurance and attribution layer that sits between fleets and the network.</a:t>
+            </a:r>
+          </a:p>
+        </p:txBody>
+      </p:sp>
+      <p:sp>
+        <p:nvSpPr>
+          <p:cNvPr id="5" name="Rectangle 4"/>
           <p:cNvSpPr/>
           <p:nvPr/>
         </p:nvSpPr>
         <p:spPr>
           <a:xfrm>
-            <a:off x="548640" y="777240"/>
-            <a:ext cx="1097280" cy="27432"/>
+            <a:off x="2834640" y="2194560"/>
+            <a:ext cx="3657600" cy="457200"/>
+          </a:xfrm>
+          <a:prstGeom prst="rect">
+            <a:avLst/>
+          </a:prstGeom>
+          <a:solidFill>
+            <a:srgbClr val="162535"/>
+          </a:solidFill>
+          <a:ln>
+            <a:noFill/>
+          </a:ln>
+        </p:spPr>
+        <p:style>
+          <a:lnRef idx="1">
+            <a:schemeClr val="accent1"/>
+          </a:lnRef>
+          <a:fillRef idx="3">
+            <a:schemeClr val="accent1"/>
+          </a:fillRef>
+          <a:effectRef idx="2">
+            <a:schemeClr val="accent1"/>
+          </a:effectRef>
+          <a:fontRef idx="minor">
+            <a:schemeClr val="lt1"/>
+          </a:fontRef>
+        </p:style>
+        <p:txBody>
+          <a:bodyPr rtlCol="0" anchor="ctr"/>
+          <a:lstStyle/>
+          <a:p>
+            <a:pPr algn="ctr"/>
+          </a:p>
+        </p:txBody>
+      </p:sp>
+      <p:sp>
+        <p:nvSpPr>
+          <p:cNvPr id="6" name="Rectangle 5"/>
+          <p:cNvSpPr/>
+          <p:nvPr/>
+        </p:nvSpPr>
+        <p:spPr>
+          <a:xfrm>
+            <a:off x="2834640" y="2194560"/>
+            <a:ext cx="45720" cy="457200"/>
+          </a:xfrm>
+          <a:prstGeom prst="rect">
+            <a:avLst/>
+          </a:prstGeom>
+          <a:solidFill>
+            <a:srgbClr val="4A90D9"/>
+          </a:solidFill>
+          <a:ln>
+            <a:noFill/>
+          </a:ln>
+        </p:spPr>
+        <p:style>
+          <a:lnRef idx="1">
+            <a:schemeClr val="accent1"/>
+          </a:lnRef>
+          <a:fillRef idx="3">
+            <a:schemeClr val="accent1"/>
+          </a:fillRef>
+          <a:effectRef idx="2">
+            <a:schemeClr val="accent1"/>
+          </a:effectRef>
+          <a:fontRef idx="minor">
+            <a:schemeClr val="lt1"/>
+          </a:fontRef>
+        </p:style>
+        <p:txBody>
+          <a:bodyPr rtlCol="0" anchor="ctr"/>
+          <a:lstStyle/>
+          <a:p>
+            <a:pPr algn="ctr"/>
+          </a:p>
+        </p:txBody>
+      </p:sp>
+      <p:sp>
+        <p:nvSpPr>
+          <p:cNvPr id="7" name="TextBox 6"/>
+          <p:cNvSpPr txBox="1"/>
+          <p:nvPr/>
+        </p:nvSpPr>
+        <p:spPr>
+          <a:xfrm>
+            <a:off x="3017520" y="2221991"/>
+            <a:ext cx="3383280" cy="228600"/>
+          </a:xfrm>
+          <a:prstGeom prst="rect">
+            <a:avLst/>
+          </a:prstGeom>
+          <a:noFill/>
+        </p:spPr>
+        <p:txBody>
+          <a:bodyPr wrap="square">
+            <a:spAutoFit/>
+          </a:bodyPr>
+          <a:lstStyle/>
+          <a:p>
+            <a:pPr algn="l">
+              <a:defRPr sz="1100" b="1" i="0">
+                <a:solidFill>
+                  <a:srgbClr val="4A90D9"/>
+                </a:solidFill>
+                <a:latin typeface="Calibri"/>
+              </a:defRPr>
+            </a:pPr>
+            <a:r>
+              <a:t>VPP / DERMS PLATFORMS</a:t>
+            </a:r>
+          </a:p>
+        </p:txBody>
+      </p:sp>
+      <p:sp>
+        <p:nvSpPr>
+          <p:cNvPr id="8" name="TextBox 7"/>
+          <p:cNvSpPr txBox="1"/>
+          <p:nvPr/>
+        </p:nvSpPr>
+        <p:spPr>
+          <a:xfrm>
+            <a:off x="3017520" y="2450591"/>
+            <a:ext cx="3383280" cy="182880"/>
+          </a:xfrm>
+          <a:prstGeom prst="rect">
+            <a:avLst/>
+          </a:prstGeom>
+          <a:noFill/>
+        </p:spPr>
+        <p:txBody>
+          <a:bodyPr wrap="square">
+            <a:spAutoFit/>
+          </a:bodyPr>
+          <a:lstStyle/>
+          <a:p>
+            <a:pPr algn="l">
+              <a:defRPr sz="800" b="0" i="0">
+                <a:solidFill>
+                  <a:srgbClr val="B8C8D8"/>
+                </a:solidFill>
+                <a:latin typeface="Calibri"/>
+              </a:defRPr>
+            </a:pPr>
+            <a:r>
+              <a:t>EnergyHub · Kraken · AutoGrid · Tesla VPP</a:t>
+            </a:r>
+          </a:p>
+        </p:txBody>
+      </p:sp>
+      <p:sp>
+        <p:nvSpPr>
+          <p:cNvPr id="9" name="Rectangle 8"/>
+          <p:cNvSpPr/>
+          <p:nvPr/>
+        </p:nvSpPr>
+        <p:spPr>
+          <a:xfrm>
+            <a:off x="2834640" y="2788920"/>
+            <a:ext cx="3657600" cy="457200"/>
+          </a:xfrm>
+          <a:prstGeom prst="rect">
+            <a:avLst/>
+          </a:prstGeom>
+          <a:solidFill>
+            <a:srgbClr val="162535"/>
+          </a:solidFill>
+          <a:ln>
+            <a:noFill/>
+          </a:ln>
+        </p:spPr>
+        <p:style>
+          <a:lnRef idx="1">
+            <a:schemeClr val="accent1"/>
+          </a:lnRef>
+          <a:fillRef idx="3">
+            <a:schemeClr val="accent1"/>
+          </a:fillRef>
+          <a:effectRef idx="2">
+            <a:schemeClr val="accent1"/>
+          </a:effectRef>
+          <a:fontRef idx="minor">
+            <a:schemeClr val="lt1"/>
+          </a:fontRef>
+        </p:style>
+        <p:txBody>
+          <a:bodyPr rtlCol="0" anchor="ctr"/>
+          <a:lstStyle/>
+          <a:p>
+            <a:pPr algn="ctr"/>
+          </a:p>
+        </p:txBody>
+      </p:sp>
+      <p:sp>
+        <p:nvSpPr>
+          <p:cNvPr id="10" name="Rectangle 9"/>
+          <p:cNvSpPr/>
+          <p:nvPr/>
+        </p:nvSpPr>
+        <p:spPr>
+          <a:xfrm>
+            <a:off x="2834640" y="2788920"/>
+            <a:ext cx="45720" cy="457200"/>
           </a:xfrm>
           <a:prstGeom prst="rect">
             <a:avLst/>
@@ -9555,14 +8979,14 @@
       </p:sp>
       <p:sp>
         <p:nvSpPr>
-          <p:cNvPr id="4" name="TextBox 3"/>
-          <p:cNvSpPr txBox="1"/>
-          <p:nvPr/>
-        </p:nvSpPr>
-        <p:spPr>
-          <a:xfrm>
-            <a:off x="548640" y="1097280"/>
-            <a:ext cx="8046720" cy="411480"/>
+          <p:cNvPr id="11" name="TextBox 10"/>
+          <p:cNvSpPr txBox="1"/>
+          <p:nvPr/>
+        </p:nvSpPr>
+        <p:spPr>
+          <a:xfrm>
+            <a:off x="3017520" y="2816351"/>
+            <a:ext cx="3383280" cy="228600"/>
           </a:xfrm>
           <a:prstGeom prst="rect">
             <a:avLst/>
@@ -9576,29 +9000,29 @@
           <a:lstStyle/>
           <a:p>
             <a:pPr algn="l">
-              <a:defRPr sz="1600" b="1" i="0">
-                <a:solidFill>
-                  <a:srgbClr val="FFFFFF"/>
-                </a:solidFill>
-                <a:latin typeface="Calibri"/>
-              </a:defRPr>
-            </a:pPr>
-            <a:r>
-              <a:t>GridAI is not a replacement for DERMS or VPP platforms.</a:t>
-            </a:r>
-          </a:p>
-        </p:txBody>
-      </p:sp>
-      <p:sp>
-        <p:nvSpPr>
-          <p:cNvPr id="5" name="TextBox 4"/>
-          <p:cNvSpPr txBox="1"/>
-          <p:nvPr/>
-        </p:nvSpPr>
-        <p:spPr>
-          <a:xfrm>
-            <a:off x="548640" y="1508760"/>
-            <a:ext cx="8046720" cy="320040"/>
+              <a:defRPr sz="1100" b="1" i="0">
+                <a:solidFill>
+                  <a:srgbClr val="F4A623"/>
+                </a:solidFill>
+                <a:latin typeface="Calibri"/>
+              </a:defRPr>
+            </a:pPr>
+            <a:r>
+              <a:t>GRIDAI  ←  assurance &amp; attribution</a:t>
+            </a:r>
+          </a:p>
+        </p:txBody>
+      </p:sp>
+      <p:sp>
+        <p:nvSpPr>
+          <p:cNvPr id="12" name="TextBox 11"/>
+          <p:cNvSpPr txBox="1"/>
+          <p:nvPr/>
+        </p:nvSpPr>
+        <p:spPr>
+          <a:xfrm>
+            <a:off x="3017520" y="3044952"/>
+            <a:ext cx="3383280" cy="182880"/>
           </a:xfrm>
           <a:prstGeom prst="rect">
             <a:avLst/>
@@ -9612,7 +9036,7 @@
           <a:lstStyle/>
           <a:p>
             <a:pPr algn="l">
-              <a:defRPr sz="1300" b="0" i="0">
+              <a:defRPr sz="800" b="0" i="0">
                 <a:solidFill>
                   <a:srgbClr val="B8C8D8"/>
                 </a:solidFill>
@@ -9620,20 +9044,20 @@
               </a:defRPr>
             </a:pPr>
             <a:r>
-              <a:t>It is an assurance and attribution layer that sits between fleets and the network.</a:t>
-            </a:r>
-          </a:p>
-        </p:txBody>
-      </p:sp>
-      <p:sp>
-        <p:nvSpPr>
-          <p:cNvPr id="6" name="Rectangle 5"/>
+              <a:t>Anti-herding + cause-attributed compliance</a:t>
+            </a:r>
+          </a:p>
+        </p:txBody>
+      </p:sp>
+      <p:sp>
+        <p:nvSpPr>
+          <p:cNvPr id="13" name="Rectangle 12"/>
           <p:cNvSpPr/>
           <p:nvPr/>
         </p:nvSpPr>
         <p:spPr>
           <a:xfrm>
-            <a:off x="2834640" y="2194560"/>
+            <a:off x="2834640" y="3383280"/>
             <a:ext cx="3657600" cy="457200"/>
           </a:xfrm>
           <a:prstGeom prst="rect">
@@ -9670,323 +9094,7 @@
       </p:sp>
       <p:sp>
         <p:nvSpPr>
-          <p:cNvPr id="7" name="Rectangle 6"/>
-          <p:cNvSpPr/>
-          <p:nvPr/>
-        </p:nvSpPr>
-        <p:spPr>
-          <a:xfrm>
-            <a:off x="2834640" y="2194560"/>
-            <a:ext cx="45720" cy="457200"/>
-          </a:xfrm>
-          <a:prstGeom prst="rect">
-            <a:avLst/>
-          </a:prstGeom>
-          <a:solidFill>
-            <a:srgbClr val="4A90D9"/>
-          </a:solidFill>
-          <a:ln>
-            <a:noFill/>
-          </a:ln>
-        </p:spPr>
-        <p:style>
-          <a:lnRef idx="1">
-            <a:schemeClr val="accent1"/>
-          </a:lnRef>
-          <a:fillRef idx="3">
-            <a:schemeClr val="accent1"/>
-          </a:fillRef>
-          <a:effectRef idx="2">
-            <a:schemeClr val="accent1"/>
-          </a:effectRef>
-          <a:fontRef idx="minor">
-            <a:schemeClr val="lt1"/>
-          </a:fontRef>
-        </p:style>
-        <p:txBody>
-          <a:bodyPr rtlCol="0" anchor="ctr"/>
-          <a:lstStyle/>
-          <a:p>
-            <a:pPr algn="ctr"/>
-          </a:p>
-        </p:txBody>
-      </p:sp>
-      <p:sp>
-        <p:nvSpPr>
-          <p:cNvPr id="8" name="TextBox 7"/>
-          <p:cNvSpPr txBox="1"/>
-          <p:nvPr/>
-        </p:nvSpPr>
-        <p:spPr>
-          <a:xfrm>
-            <a:off x="3017520" y="2221991"/>
-            <a:ext cx="3383280" cy="228600"/>
-          </a:xfrm>
-          <a:prstGeom prst="rect">
-            <a:avLst/>
-          </a:prstGeom>
-          <a:noFill/>
-        </p:spPr>
-        <p:txBody>
-          <a:bodyPr wrap="square">
-            <a:spAutoFit/>
-          </a:bodyPr>
-          <a:lstStyle/>
-          <a:p>
-            <a:pPr algn="l">
-              <a:defRPr sz="1100" b="1" i="0">
-                <a:solidFill>
-                  <a:srgbClr val="4A90D9"/>
-                </a:solidFill>
-                <a:latin typeface="Calibri"/>
-              </a:defRPr>
-            </a:pPr>
-            <a:r>
-              <a:t>VPP / DERMS PLATFORMS</a:t>
-            </a:r>
-          </a:p>
-        </p:txBody>
-      </p:sp>
-      <p:sp>
-        <p:nvSpPr>
-          <p:cNvPr id="9" name="TextBox 8"/>
-          <p:cNvSpPr txBox="1"/>
-          <p:nvPr/>
-        </p:nvSpPr>
-        <p:spPr>
-          <a:xfrm>
-            <a:off x="3017520" y="2450591"/>
-            <a:ext cx="3383280" cy="182880"/>
-          </a:xfrm>
-          <a:prstGeom prst="rect">
-            <a:avLst/>
-          </a:prstGeom>
-          <a:noFill/>
-        </p:spPr>
-        <p:txBody>
-          <a:bodyPr wrap="square">
-            <a:spAutoFit/>
-          </a:bodyPr>
-          <a:lstStyle/>
-          <a:p>
-            <a:pPr algn="l">
-              <a:defRPr sz="800" b="0" i="0">
-                <a:solidFill>
-                  <a:srgbClr val="B8C8D8"/>
-                </a:solidFill>
-                <a:latin typeface="Calibri"/>
-              </a:defRPr>
-            </a:pPr>
-            <a:r>
-              <a:t>EnergyHub · Kraken · AutoGrid · Tesla VPP</a:t>
-            </a:r>
-          </a:p>
-        </p:txBody>
-      </p:sp>
-      <p:sp>
-        <p:nvSpPr>
-          <p:cNvPr id="10" name="Rectangle 9"/>
-          <p:cNvSpPr/>
-          <p:nvPr/>
-        </p:nvSpPr>
-        <p:spPr>
-          <a:xfrm>
-            <a:off x="2834640" y="2788920"/>
-            <a:ext cx="3657600" cy="457200"/>
-          </a:xfrm>
-          <a:prstGeom prst="rect">
-            <a:avLst/>
-          </a:prstGeom>
-          <a:solidFill>
-            <a:srgbClr val="162535"/>
-          </a:solidFill>
-          <a:ln>
-            <a:noFill/>
-          </a:ln>
-        </p:spPr>
-        <p:style>
-          <a:lnRef idx="1">
-            <a:schemeClr val="accent1"/>
-          </a:lnRef>
-          <a:fillRef idx="3">
-            <a:schemeClr val="accent1"/>
-          </a:fillRef>
-          <a:effectRef idx="2">
-            <a:schemeClr val="accent1"/>
-          </a:effectRef>
-          <a:fontRef idx="minor">
-            <a:schemeClr val="lt1"/>
-          </a:fontRef>
-        </p:style>
-        <p:txBody>
-          <a:bodyPr rtlCol="0" anchor="ctr"/>
-          <a:lstStyle/>
-          <a:p>
-            <a:pPr algn="ctr"/>
-          </a:p>
-        </p:txBody>
-      </p:sp>
-      <p:sp>
-        <p:nvSpPr>
-          <p:cNvPr id="11" name="Rectangle 10"/>
-          <p:cNvSpPr/>
-          <p:nvPr/>
-        </p:nvSpPr>
-        <p:spPr>
-          <a:xfrm>
-            <a:off x="2834640" y="2788920"/>
-            <a:ext cx="45720" cy="457200"/>
-          </a:xfrm>
-          <a:prstGeom prst="rect">
-            <a:avLst/>
-          </a:prstGeom>
-          <a:solidFill>
-            <a:srgbClr val="F4A623"/>
-          </a:solidFill>
-          <a:ln>
-            <a:noFill/>
-          </a:ln>
-        </p:spPr>
-        <p:style>
-          <a:lnRef idx="1">
-            <a:schemeClr val="accent1"/>
-          </a:lnRef>
-          <a:fillRef idx="3">
-            <a:schemeClr val="accent1"/>
-          </a:fillRef>
-          <a:effectRef idx="2">
-            <a:schemeClr val="accent1"/>
-          </a:effectRef>
-          <a:fontRef idx="minor">
-            <a:schemeClr val="lt1"/>
-          </a:fontRef>
-        </p:style>
-        <p:txBody>
-          <a:bodyPr rtlCol="0" anchor="ctr"/>
-          <a:lstStyle/>
-          <a:p>
-            <a:pPr algn="ctr"/>
-          </a:p>
-        </p:txBody>
-      </p:sp>
-      <p:sp>
-        <p:nvSpPr>
-          <p:cNvPr id="12" name="TextBox 11"/>
-          <p:cNvSpPr txBox="1"/>
-          <p:nvPr/>
-        </p:nvSpPr>
-        <p:spPr>
-          <a:xfrm>
-            <a:off x="3017520" y="2816351"/>
-            <a:ext cx="3383280" cy="228600"/>
-          </a:xfrm>
-          <a:prstGeom prst="rect">
-            <a:avLst/>
-          </a:prstGeom>
-          <a:noFill/>
-        </p:spPr>
-        <p:txBody>
-          <a:bodyPr wrap="square">
-            <a:spAutoFit/>
-          </a:bodyPr>
-          <a:lstStyle/>
-          <a:p>
-            <a:pPr algn="l">
-              <a:defRPr sz="1100" b="1" i="0">
-                <a:solidFill>
-                  <a:srgbClr val="F4A623"/>
-                </a:solidFill>
-                <a:latin typeface="Calibri"/>
-              </a:defRPr>
-            </a:pPr>
-            <a:r>
-              <a:t>GRIDAI  ←  assurance &amp; attribution</a:t>
-            </a:r>
-          </a:p>
-        </p:txBody>
-      </p:sp>
-      <p:sp>
-        <p:nvSpPr>
-          <p:cNvPr id="13" name="TextBox 12"/>
-          <p:cNvSpPr txBox="1"/>
-          <p:nvPr/>
-        </p:nvSpPr>
-        <p:spPr>
-          <a:xfrm>
-            <a:off x="3017520" y="3044952"/>
-            <a:ext cx="3383280" cy="182880"/>
-          </a:xfrm>
-          <a:prstGeom prst="rect">
-            <a:avLst/>
-          </a:prstGeom>
-          <a:noFill/>
-        </p:spPr>
-        <p:txBody>
-          <a:bodyPr wrap="square">
-            <a:spAutoFit/>
-          </a:bodyPr>
-          <a:lstStyle/>
-          <a:p>
-            <a:pPr algn="l">
-              <a:defRPr sz="800" b="0" i="0">
-                <a:solidFill>
-                  <a:srgbClr val="B8C8D8"/>
-                </a:solidFill>
-                <a:latin typeface="Calibri"/>
-              </a:defRPr>
-            </a:pPr>
-            <a:r>
-              <a:t>Anti-herding + cause-attributed compliance</a:t>
-            </a:r>
-          </a:p>
-        </p:txBody>
-      </p:sp>
-      <p:sp>
-        <p:nvSpPr>
           <p:cNvPr id="14" name="Rectangle 13"/>
-          <p:cNvSpPr/>
-          <p:nvPr/>
-        </p:nvSpPr>
-        <p:spPr>
-          <a:xfrm>
-            <a:off x="2834640" y="3383280"/>
-            <a:ext cx="3657600" cy="457200"/>
-          </a:xfrm>
-          <a:prstGeom prst="rect">
-            <a:avLst/>
-          </a:prstGeom>
-          <a:solidFill>
-            <a:srgbClr val="162535"/>
-          </a:solidFill>
-          <a:ln>
-            <a:noFill/>
-          </a:ln>
-        </p:spPr>
-        <p:style>
-          <a:lnRef idx="1">
-            <a:schemeClr val="accent1"/>
-          </a:lnRef>
-          <a:fillRef idx="3">
-            <a:schemeClr val="accent1"/>
-          </a:fillRef>
-          <a:effectRef idx="2">
-            <a:schemeClr val="accent1"/>
-          </a:effectRef>
-          <a:fontRef idx="minor">
-            <a:schemeClr val="lt1"/>
-          </a:fontRef>
-        </p:style>
-        <p:txBody>
-          <a:bodyPr rtlCol="0" anchor="ctr"/>
-          <a:lstStyle/>
-          <a:p>
-            <a:pPr algn="ctr"/>
-          </a:p>
-        </p:txBody>
-      </p:sp>
-      <p:sp>
-        <p:nvSpPr>
-          <p:cNvPr id="15" name="Rectangle 14"/>
           <p:cNvSpPr/>
           <p:nvPr/>
         </p:nvSpPr>
@@ -10029,7 +9137,7 @@
       </p:sp>
       <p:sp>
         <p:nvSpPr>
-          <p:cNvPr id="16" name="TextBox 15"/>
+          <p:cNvPr id="15" name="TextBox 14"/>
           <p:cNvSpPr txBox="1"/>
           <p:nvPr/>
         </p:nvSpPr>
@@ -10065,7 +9173,7 @@
       </p:sp>
       <p:sp>
         <p:nvSpPr>
-          <p:cNvPr id="17" name="TextBox 16"/>
+          <p:cNvPr id="16" name="TextBox 15"/>
           <p:cNvSpPr txBox="1"/>
           <p:nvPr/>
         </p:nvSpPr>
@@ -10101,7 +9209,7 @@
       </p:sp>
       <p:sp>
         <p:nvSpPr>
-          <p:cNvPr id="18" name="TextBox 17"/>
+          <p:cNvPr id="17" name="TextBox 16"/>
           <p:cNvSpPr txBox="1"/>
           <p:nvPr/>
         </p:nvSpPr>
@@ -10137,7 +9245,7 @@
       </p:sp>
       <p:sp>
         <p:nvSpPr>
-          <p:cNvPr id="19" name="TextBox 18"/>
+          <p:cNvPr id="18" name="TextBox 17"/>
           <p:cNvSpPr txBox="1"/>
           <p:nvPr/>
         </p:nvSpPr>
@@ -10173,7 +9281,7 @@
       </p:sp>
       <p:sp>
         <p:nvSpPr>
-          <p:cNvPr id="20" name="TextBox 19"/>
+          <p:cNvPr id="19" name="TextBox 18"/>
           <p:cNvSpPr txBox="1"/>
           <p:nvPr/>
         </p:nvSpPr>
@@ -10209,7 +9317,7 @@
       </p:sp>
       <p:sp>
         <p:nvSpPr>
-          <p:cNvPr id="21" name="TextBox 20"/>
+          <p:cNvPr id="20" name="TextBox 19"/>
           <p:cNvSpPr txBox="1"/>
           <p:nvPr/>
         </p:nvSpPr>
@@ -10245,7 +9353,7 @@
       </p:sp>
       <p:sp>
         <p:nvSpPr>
-          <p:cNvPr id="22" name="TextBox 21"/>
+          <p:cNvPr id="21" name="TextBox 20"/>
           <p:cNvSpPr txBox="1"/>
           <p:nvPr/>
         </p:nvSpPr>
@@ -10281,7 +9389,7 @@
       </p:sp>
       <p:sp>
         <p:nvSpPr>
-          <p:cNvPr id="23" name="TextBox 22"/>
+          <p:cNvPr id="22" name="TextBox 21"/>
           <p:cNvSpPr txBox="1"/>
           <p:nvPr/>
         </p:nvSpPr>
@@ -10317,7 +9425,7 @@
       </p:sp>
       <p:sp>
         <p:nvSpPr>
-          <p:cNvPr id="24" name="TextBox 23"/>
+          <p:cNvPr id="23" name="TextBox 22"/>
           <p:cNvSpPr txBox="1"/>
           <p:nvPr/>
         </p:nvSpPr>

</xml_diff>

<commit_message>
docs: add limitations and clean submission assets
</commit_message>
<xml_diff>
--- a/submission/gridai_lablab_band_of_agents_2026/assets/gridai_pitch_deck.pptx
+++ b/submission/gridai_lablab_band_of_agents_2026/assets/gridai_pitch_deck.pptx
@@ -5,18 +5,18 @@
     <p:sldMasterId id="2147483648" r:id="rId1"/>
   </p:sldMasterIdLst>
   <p:sldIdLst>
-    <p:sldId id="256" r:id="rId7"/>
-    <p:sldId id="257" r:id="rId8"/>
-    <p:sldId id="258" r:id="rId9"/>
-    <p:sldId id="259" r:id="rId10"/>
-    <p:sldId id="260" r:id="rId11"/>
-    <p:sldId id="261" r:id="rId12"/>
-    <p:sldId id="262" r:id="rId13"/>
-    <p:sldId id="263" r:id="rId14"/>
-    <p:sldId id="264" r:id="rId15"/>
-    <p:sldId id="265" r:id="rId16"/>
+    <p:sldId id="256" r:id="rId2"/>
+    <p:sldId id="257" r:id="rId3"/>
+    <p:sldId id="258" r:id="rId4"/>
+    <p:sldId id="259" r:id="rId5"/>
+    <p:sldId id="260" r:id="rId6"/>
+    <p:sldId id="261" r:id="rId7"/>
+    <p:sldId id="262" r:id="rId8"/>
+    <p:sldId id="263" r:id="rId9"/>
+    <p:sldId id="264" r:id="rId10"/>
+    <p:sldId id="265" r:id="rId11"/>
   </p:sldIdLst>
-  <p:sldSz cx="12191695" cy="6858000" type="screen4x3"/>
+  <p:sldSz cx="12192000" cy="6858000"/>
   <p:notesSz cx="6858000" cy="9144000"/>
   <p:defaultTextStyle>
     <a:defPPr>
@@ -113,6 +113,22 @@
       </a:defRPr>
     </a:lvl9pPr>
   </p:defaultTextStyle>
+  <p:extLst>
+    <p:ext uri="{EFAFB233-063F-42B5-8137-9DF3F51BA10A}">
+      <p15:sldGuideLst xmlns:p15="http://schemas.microsoft.com/office/powerpoint/2012/main">
+        <p15:guide id="1" orient="horz" pos="2160">
+          <p15:clr>
+            <a:srgbClr val="A4A3A4"/>
+          </p15:clr>
+        </p15:guide>
+        <p15:guide id="2" pos="2880">
+          <p15:clr>
+            <a:srgbClr val="A4A3A4"/>
+          </p15:clr>
+        </p15:guide>
+      </p15:sldGuideLst>
+    </p:ext>
+  </p:extLst>
 </p:presentation>
 </file>
 
@@ -154,10 +170,9 @@
           <a:lstStyle/>
           <a:p>
             <a:r>
-              <a:rPr lang="en-US" smtClean="0"/>
+              <a:rPr lang="en-US"/>
               <a:t>Click to edit Master title style</a:t>
             </a:r>
-            <a:endParaRPr lang="en-US"/>
           </a:p>
         </p:txBody>
       </p:sp>
@@ -273,10 +288,9 @@
           </a:lstStyle>
           <a:p>
             <a:r>
-              <a:rPr lang="en-US" smtClean="0"/>
+              <a:rPr lang="en-US"/>
               <a:t>Click to edit Master subtitle style</a:t>
             </a:r>
-            <a:endParaRPr lang="en-US"/>
           </a:p>
         </p:txBody>
       </p:sp>
@@ -297,7 +311,7 @@
           <a:p>
             <a:fld id="{5BCAD085-E8A6-8845-BD4E-CB4CCA059FC4}" type="datetimeFigureOut">
               <a:rPr lang="en-US" smtClean="0"/>
-              <a:t>1/27/13</a:t>
+              <a:t>6/19/26</a:t>
             </a:fld>
             <a:endParaRPr lang="en-US"/>
           </a:p>
@@ -391,10 +405,9 @@
           <a:lstStyle/>
           <a:p>
             <a:r>
-              <a:rPr lang="en-US" smtClean="0"/>
+              <a:rPr lang="en-US"/>
               <a:t>Click to edit Master title style</a:t>
             </a:r>
-            <a:endParaRPr lang="en-US"/>
           </a:p>
         </p:txBody>
       </p:sp>
@@ -415,38 +428,37 @@
           <a:p>
             <a:pPr lvl="0"/>
             <a:r>
-              <a:rPr lang="en-US" smtClean="0"/>
+              <a:rPr lang="en-US"/>
               <a:t>Click to edit Master text styles</a:t>
             </a:r>
           </a:p>
           <a:p>
             <a:pPr lvl="1"/>
             <a:r>
-              <a:rPr lang="en-US" smtClean="0"/>
+              <a:rPr lang="en-US"/>
               <a:t>Second level</a:t>
             </a:r>
           </a:p>
           <a:p>
             <a:pPr lvl="2"/>
             <a:r>
-              <a:rPr lang="en-US" smtClean="0"/>
+              <a:rPr lang="en-US"/>
               <a:t>Third level</a:t>
             </a:r>
           </a:p>
           <a:p>
             <a:pPr lvl="3"/>
             <a:r>
-              <a:rPr lang="en-US" smtClean="0"/>
+              <a:rPr lang="en-US"/>
               <a:t>Fourth level</a:t>
             </a:r>
           </a:p>
           <a:p>
             <a:pPr lvl="4"/>
             <a:r>
-              <a:rPr lang="en-US" smtClean="0"/>
+              <a:rPr lang="en-US"/>
               <a:t>Fifth level</a:t>
             </a:r>
-            <a:endParaRPr lang="en-US"/>
           </a:p>
         </p:txBody>
       </p:sp>
@@ -467,7 +479,7 @@
           <a:p>
             <a:fld id="{5BCAD085-E8A6-8845-BD4E-CB4CCA059FC4}" type="datetimeFigureOut">
               <a:rPr lang="en-US" smtClean="0"/>
-              <a:t>1/27/13</a:t>
+              <a:t>6/19/26</a:t>
             </a:fld>
             <a:endParaRPr lang="en-US"/>
           </a:p>
@@ -566,10 +578,9 @@
           <a:lstStyle/>
           <a:p>
             <a:r>
-              <a:rPr lang="en-US" smtClean="0"/>
+              <a:rPr lang="en-US"/>
               <a:t>Click to edit Master title style</a:t>
             </a:r>
-            <a:endParaRPr lang="en-US"/>
           </a:p>
         </p:txBody>
       </p:sp>
@@ -595,38 +606,37 @@
           <a:p>
             <a:pPr lvl="0"/>
             <a:r>
-              <a:rPr lang="en-US" smtClean="0"/>
+              <a:rPr lang="en-US"/>
               <a:t>Click to edit Master text styles</a:t>
             </a:r>
           </a:p>
           <a:p>
             <a:pPr lvl="1"/>
             <a:r>
-              <a:rPr lang="en-US" smtClean="0"/>
+              <a:rPr lang="en-US"/>
               <a:t>Second level</a:t>
             </a:r>
           </a:p>
           <a:p>
             <a:pPr lvl="2"/>
             <a:r>
-              <a:rPr lang="en-US" smtClean="0"/>
+              <a:rPr lang="en-US"/>
               <a:t>Third level</a:t>
             </a:r>
           </a:p>
           <a:p>
             <a:pPr lvl="3"/>
             <a:r>
-              <a:rPr lang="en-US" smtClean="0"/>
+              <a:rPr lang="en-US"/>
               <a:t>Fourth level</a:t>
             </a:r>
           </a:p>
           <a:p>
             <a:pPr lvl="4"/>
             <a:r>
-              <a:rPr lang="en-US" smtClean="0"/>
+              <a:rPr lang="en-US"/>
               <a:t>Fifth level</a:t>
             </a:r>
-            <a:endParaRPr lang="en-US"/>
           </a:p>
         </p:txBody>
       </p:sp>
@@ -647,7 +657,7 @@
           <a:p>
             <a:fld id="{5BCAD085-E8A6-8845-BD4E-CB4CCA059FC4}" type="datetimeFigureOut">
               <a:rPr lang="en-US" smtClean="0"/>
-              <a:t>1/27/13</a:t>
+              <a:t>6/19/26</a:t>
             </a:fld>
             <a:endParaRPr lang="en-US"/>
           </a:p>
@@ -741,10 +751,9 @@
           <a:lstStyle/>
           <a:p>
             <a:r>
-              <a:rPr lang="en-US" smtClean="0"/>
+              <a:rPr lang="en-US"/>
               <a:t>Click to edit Master title style</a:t>
             </a:r>
-            <a:endParaRPr lang="en-US"/>
           </a:p>
         </p:txBody>
       </p:sp>
@@ -765,38 +774,37 @@
           <a:p>
             <a:pPr lvl="0"/>
             <a:r>
-              <a:rPr lang="en-US" smtClean="0"/>
+              <a:rPr lang="en-US"/>
               <a:t>Click to edit Master text styles</a:t>
             </a:r>
           </a:p>
           <a:p>
             <a:pPr lvl="1"/>
             <a:r>
-              <a:rPr lang="en-US" smtClean="0"/>
+              <a:rPr lang="en-US"/>
               <a:t>Second level</a:t>
             </a:r>
           </a:p>
           <a:p>
             <a:pPr lvl="2"/>
             <a:r>
-              <a:rPr lang="en-US" smtClean="0"/>
+              <a:rPr lang="en-US"/>
               <a:t>Third level</a:t>
             </a:r>
           </a:p>
           <a:p>
             <a:pPr lvl="3"/>
             <a:r>
-              <a:rPr lang="en-US" smtClean="0"/>
+              <a:rPr lang="en-US"/>
               <a:t>Fourth level</a:t>
             </a:r>
           </a:p>
           <a:p>
             <a:pPr lvl="4"/>
             <a:r>
-              <a:rPr lang="en-US" smtClean="0"/>
+              <a:rPr lang="en-US"/>
               <a:t>Fifth level</a:t>
             </a:r>
-            <a:endParaRPr lang="en-US"/>
           </a:p>
         </p:txBody>
       </p:sp>
@@ -817,7 +825,7 @@
           <a:p>
             <a:fld id="{5BCAD085-E8A6-8845-BD4E-CB4CCA059FC4}" type="datetimeFigureOut">
               <a:rPr lang="en-US" smtClean="0"/>
-              <a:t>1/27/13</a:t>
+              <a:t>6/19/26</a:t>
             </a:fld>
             <a:endParaRPr lang="en-US"/>
           </a:p>
@@ -920,10 +928,9 @@
           </a:lstStyle>
           <a:p>
             <a:r>
-              <a:rPr lang="en-US" smtClean="0"/>
+              <a:rPr lang="en-US"/>
               <a:t>Click to edit Master title style</a:t>
             </a:r>
-            <a:endParaRPr lang="en-US"/>
           </a:p>
         </p:txBody>
       </p:sp>
@@ -1040,7 +1047,7 @@
           <a:p>
             <a:pPr lvl="0"/>
             <a:r>
-              <a:rPr lang="en-US" smtClean="0"/>
+              <a:rPr lang="en-US"/>
               <a:t>Click to edit Master text styles</a:t>
             </a:r>
           </a:p>
@@ -1063,7 +1070,7 @@
           <a:p>
             <a:fld id="{5BCAD085-E8A6-8845-BD4E-CB4CCA059FC4}" type="datetimeFigureOut">
               <a:rPr lang="en-US" smtClean="0"/>
-              <a:t>1/27/13</a:t>
+              <a:t>6/19/26</a:t>
             </a:fld>
             <a:endParaRPr lang="en-US"/>
           </a:p>
@@ -1157,10 +1164,9 @@
           <a:lstStyle/>
           <a:p>
             <a:r>
-              <a:rPr lang="en-US" smtClean="0"/>
+              <a:rPr lang="en-US"/>
               <a:t>Click to edit Master title style</a:t>
             </a:r>
-            <a:endParaRPr lang="en-US"/>
           </a:p>
         </p:txBody>
       </p:sp>
@@ -1214,38 +1220,37 @@
           <a:p>
             <a:pPr lvl="0"/>
             <a:r>
-              <a:rPr lang="en-US" smtClean="0"/>
+              <a:rPr lang="en-US"/>
               <a:t>Click to edit Master text styles</a:t>
             </a:r>
           </a:p>
           <a:p>
             <a:pPr lvl="1"/>
             <a:r>
-              <a:rPr lang="en-US" smtClean="0"/>
+              <a:rPr lang="en-US"/>
               <a:t>Second level</a:t>
             </a:r>
           </a:p>
           <a:p>
             <a:pPr lvl="2"/>
             <a:r>
-              <a:rPr lang="en-US" smtClean="0"/>
+              <a:rPr lang="en-US"/>
               <a:t>Third level</a:t>
             </a:r>
           </a:p>
           <a:p>
             <a:pPr lvl="3"/>
             <a:r>
-              <a:rPr lang="en-US" smtClean="0"/>
+              <a:rPr lang="en-US"/>
               <a:t>Fourth level</a:t>
             </a:r>
           </a:p>
           <a:p>
             <a:pPr lvl="4"/>
             <a:r>
-              <a:rPr lang="en-US" smtClean="0"/>
+              <a:rPr lang="en-US"/>
               <a:t>Fifth level</a:t>
             </a:r>
-            <a:endParaRPr lang="en-US"/>
           </a:p>
         </p:txBody>
       </p:sp>
@@ -1299,38 +1304,37 @@
           <a:p>
             <a:pPr lvl="0"/>
             <a:r>
-              <a:rPr lang="en-US" smtClean="0"/>
+              <a:rPr lang="en-US"/>
               <a:t>Click to edit Master text styles</a:t>
             </a:r>
           </a:p>
           <a:p>
             <a:pPr lvl="1"/>
             <a:r>
-              <a:rPr lang="en-US" smtClean="0"/>
+              <a:rPr lang="en-US"/>
               <a:t>Second level</a:t>
             </a:r>
           </a:p>
           <a:p>
             <a:pPr lvl="2"/>
             <a:r>
-              <a:rPr lang="en-US" smtClean="0"/>
+              <a:rPr lang="en-US"/>
               <a:t>Third level</a:t>
             </a:r>
           </a:p>
           <a:p>
             <a:pPr lvl="3"/>
             <a:r>
-              <a:rPr lang="en-US" smtClean="0"/>
+              <a:rPr lang="en-US"/>
               <a:t>Fourth level</a:t>
             </a:r>
           </a:p>
           <a:p>
             <a:pPr lvl="4"/>
             <a:r>
-              <a:rPr lang="en-US" smtClean="0"/>
+              <a:rPr lang="en-US"/>
               <a:t>Fifth level</a:t>
             </a:r>
-            <a:endParaRPr lang="en-US"/>
           </a:p>
         </p:txBody>
       </p:sp>
@@ -1351,7 +1355,7 @@
           <a:p>
             <a:fld id="{5BCAD085-E8A6-8845-BD4E-CB4CCA059FC4}" type="datetimeFigureOut">
               <a:rPr lang="en-US" smtClean="0"/>
-              <a:t>1/27/13</a:t>
+              <a:t>6/19/26</a:t>
             </a:fld>
             <a:endParaRPr lang="en-US"/>
           </a:p>
@@ -1449,10 +1453,9 @@
           </a:lstStyle>
           <a:p>
             <a:r>
-              <a:rPr lang="en-US" smtClean="0"/>
+              <a:rPr lang="en-US"/>
               <a:t>Click to edit Master title style</a:t>
             </a:r>
-            <a:endParaRPr lang="en-US"/>
           </a:p>
         </p:txBody>
       </p:sp>
@@ -1515,7 +1518,7 @@
           <a:p>
             <a:pPr lvl="0"/>
             <a:r>
-              <a:rPr lang="en-US" smtClean="0"/>
+              <a:rPr lang="en-US"/>
               <a:t>Click to edit Master text styles</a:t>
             </a:r>
           </a:p>
@@ -1571,38 +1574,37 @@
           <a:p>
             <a:pPr lvl="0"/>
             <a:r>
-              <a:rPr lang="en-US" smtClean="0"/>
+              <a:rPr lang="en-US"/>
               <a:t>Click to edit Master text styles</a:t>
             </a:r>
           </a:p>
           <a:p>
             <a:pPr lvl="1"/>
             <a:r>
-              <a:rPr lang="en-US" smtClean="0"/>
+              <a:rPr lang="en-US"/>
               <a:t>Second level</a:t>
             </a:r>
           </a:p>
           <a:p>
             <a:pPr lvl="2"/>
             <a:r>
-              <a:rPr lang="en-US" smtClean="0"/>
+              <a:rPr lang="en-US"/>
               <a:t>Third level</a:t>
             </a:r>
           </a:p>
           <a:p>
             <a:pPr lvl="3"/>
             <a:r>
-              <a:rPr lang="en-US" smtClean="0"/>
+              <a:rPr lang="en-US"/>
               <a:t>Fourth level</a:t>
             </a:r>
           </a:p>
           <a:p>
             <a:pPr lvl="4"/>
             <a:r>
-              <a:rPr lang="en-US" smtClean="0"/>
+              <a:rPr lang="en-US"/>
               <a:t>Fifth level</a:t>
             </a:r>
-            <a:endParaRPr lang="en-US"/>
           </a:p>
         </p:txBody>
       </p:sp>
@@ -1665,7 +1667,7 @@
           <a:p>
             <a:pPr lvl="0"/>
             <a:r>
-              <a:rPr lang="en-US" smtClean="0"/>
+              <a:rPr lang="en-US"/>
               <a:t>Click to edit Master text styles</a:t>
             </a:r>
           </a:p>
@@ -1721,38 +1723,37 @@
           <a:p>
             <a:pPr lvl="0"/>
             <a:r>
-              <a:rPr lang="en-US" smtClean="0"/>
+              <a:rPr lang="en-US"/>
               <a:t>Click to edit Master text styles</a:t>
             </a:r>
           </a:p>
           <a:p>
             <a:pPr lvl="1"/>
             <a:r>
-              <a:rPr lang="en-US" smtClean="0"/>
+              <a:rPr lang="en-US"/>
               <a:t>Second level</a:t>
             </a:r>
           </a:p>
           <a:p>
             <a:pPr lvl="2"/>
             <a:r>
-              <a:rPr lang="en-US" smtClean="0"/>
+              <a:rPr lang="en-US"/>
               <a:t>Third level</a:t>
             </a:r>
           </a:p>
           <a:p>
             <a:pPr lvl="3"/>
             <a:r>
-              <a:rPr lang="en-US" smtClean="0"/>
+              <a:rPr lang="en-US"/>
               <a:t>Fourth level</a:t>
             </a:r>
           </a:p>
           <a:p>
             <a:pPr lvl="4"/>
             <a:r>
-              <a:rPr lang="en-US" smtClean="0"/>
+              <a:rPr lang="en-US"/>
               <a:t>Fifth level</a:t>
             </a:r>
-            <a:endParaRPr lang="en-US"/>
           </a:p>
         </p:txBody>
       </p:sp>
@@ -1773,7 +1774,7 @@
           <a:p>
             <a:fld id="{5BCAD085-E8A6-8845-BD4E-CB4CCA059FC4}" type="datetimeFigureOut">
               <a:rPr lang="en-US" smtClean="0"/>
-              <a:t>1/27/13</a:t>
+              <a:t>6/19/26</a:t>
             </a:fld>
             <a:endParaRPr lang="en-US"/>
           </a:p>
@@ -1867,10 +1868,9 @@
           <a:lstStyle/>
           <a:p>
             <a:r>
-              <a:rPr lang="en-US" smtClean="0"/>
+              <a:rPr lang="en-US"/>
               <a:t>Click to edit Master title style</a:t>
             </a:r>
-            <a:endParaRPr lang="en-US"/>
           </a:p>
         </p:txBody>
       </p:sp>
@@ -1891,7 +1891,7 @@
           <a:p>
             <a:fld id="{5BCAD085-E8A6-8845-BD4E-CB4CCA059FC4}" type="datetimeFigureOut">
               <a:rPr lang="en-US" smtClean="0"/>
-              <a:t>1/27/13</a:t>
+              <a:t>6/19/26</a:t>
             </a:fld>
             <a:endParaRPr lang="en-US"/>
           </a:p>
@@ -1986,7 +1986,7 @@
           <a:p>
             <a:fld id="{5BCAD085-E8A6-8845-BD4E-CB4CCA059FC4}" type="datetimeFigureOut">
               <a:rPr lang="en-US" smtClean="0"/>
-              <a:t>1/27/13</a:t>
+              <a:t>6/19/26</a:t>
             </a:fld>
             <a:endParaRPr lang="en-US"/>
           </a:p>
@@ -2089,10 +2089,9 @@
           </a:lstStyle>
           <a:p>
             <a:r>
-              <a:rPr lang="en-US" smtClean="0"/>
+              <a:rPr lang="en-US"/>
               <a:t>Click to edit Master title style</a:t>
             </a:r>
-            <a:endParaRPr lang="en-US"/>
           </a:p>
         </p:txBody>
       </p:sp>
@@ -2146,38 +2145,37 @@
           <a:p>
             <a:pPr lvl="0"/>
             <a:r>
-              <a:rPr lang="en-US" smtClean="0"/>
+              <a:rPr lang="en-US"/>
               <a:t>Click to edit Master text styles</a:t>
             </a:r>
           </a:p>
           <a:p>
             <a:pPr lvl="1"/>
             <a:r>
-              <a:rPr lang="en-US" smtClean="0"/>
+              <a:rPr lang="en-US"/>
               <a:t>Second level</a:t>
             </a:r>
           </a:p>
           <a:p>
             <a:pPr lvl="2"/>
             <a:r>
-              <a:rPr lang="en-US" smtClean="0"/>
+              <a:rPr lang="en-US"/>
               <a:t>Third level</a:t>
             </a:r>
           </a:p>
           <a:p>
             <a:pPr lvl="3"/>
             <a:r>
-              <a:rPr lang="en-US" smtClean="0"/>
+              <a:rPr lang="en-US"/>
               <a:t>Fourth level</a:t>
             </a:r>
           </a:p>
           <a:p>
             <a:pPr lvl="4"/>
             <a:r>
-              <a:rPr lang="en-US" smtClean="0"/>
+              <a:rPr lang="en-US"/>
               <a:t>Fifth level</a:t>
             </a:r>
-            <a:endParaRPr lang="en-US"/>
           </a:p>
         </p:txBody>
       </p:sp>
@@ -2240,7 +2238,7 @@
           <a:p>
             <a:pPr lvl="0"/>
             <a:r>
-              <a:rPr lang="en-US" smtClean="0"/>
+              <a:rPr lang="en-US"/>
               <a:t>Click to edit Master text styles</a:t>
             </a:r>
           </a:p>
@@ -2263,7 +2261,7 @@
           <a:p>
             <a:fld id="{5BCAD085-E8A6-8845-BD4E-CB4CCA059FC4}" type="datetimeFigureOut">
               <a:rPr lang="en-US" smtClean="0"/>
-              <a:t>1/27/13</a:t>
+              <a:t>6/19/26</a:t>
             </a:fld>
             <a:endParaRPr lang="en-US"/>
           </a:p>
@@ -2366,10 +2364,9 @@
           </a:lstStyle>
           <a:p>
             <a:r>
-              <a:rPr lang="en-US" smtClean="0"/>
+              <a:rPr lang="en-US"/>
               <a:t>Click to edit Master title style</a:t>
             </a:r>
-            <a:endParaRPr lang="en-US"/>
           </a:p>
         </p:txBody>
       </p:sp>
@@ -2493,7 +2490,7 @@
           <a:p>
             <a:pPr lvl="0"/>
             <a:r>
-              <a:rPr lang="en-US" smtClean="0"/>
+              <a:rPr lang="en-US"/>
               <a:t>Click to edit Master text styles</a:t>
             </a:r>
           </a:p>
@@ -2516,7 +2513,7 @@
           <a:p>
             <a:fld id="{5BCAD085-E8A6-8845-BD4E-CB4CCA059FC4}" type="datetimeFigureOut">
               <a:rPr lang="en-US" smtClean="0"/>
-              <a:t>1/27/13</a:t>
+              <a:t>6/19/26</a:t>
             </a:fld>
             <a:endParaRPr lang="en-US"/>
           </a:p>
@@ -2625,10 +2622,9 @@
           <a:lstStyle/>
           <a:p>
             <a:r>
-              <a:rPr lang="en-US" smtClean="0"/>
+              <a:rPr lang="en-US"/>
               <a:t>Click to edit Master title style</a:t>
             </a:r>
-            <a:endParaRPr lang="en-US"/>
           </a:p>
         </p:txBody>
       </p:sp>
@@ -2659,38 +2655,37 @@
           <a:p>
             <a:pPr lvl="0"/>
             <a:r>
-              <a:rPr lang="en-US" smtClean="0"/>
+              <a:rPr lang="en-US"/>
               <a:t>Click to edit Master text styles</a:t>
             </a:r>
           </a:p>
           <a:p>
             <a:pPr lvl="1"/>
             <a:r>
-              <a:rPr lang="en-US" smtClean="0"/>
+              <a:rPr lang="en-US"/>
               <a:t>Second level</a:t>
             </a:r>
           </a:p>
           <a:p>
             <a:pPr lvl="2"/>
             <a:r>
-              <a:rPr lang="en-US" smtClean="0"/>
+              <a:rPr lang="en-US"/>
               <a:t>Third level</a:t>
             </a:r>
           </a:p>
           <a:p>
             <a:pPr lvl="3"/>
             <a:r>
-              <a:rPr lang="en-US" smtClean="0"/>
+              <a:rPr lang="en-US"/>
               <a:t>Fourth level</a:t>
             </a:r>
           </a:p>
           <a:p>
             <a:pPr lvl="4"/>
             <a:r>
-              <a:rPr lang="en-US" smtClean="0"/>
+              <a:rPr lang="en-US"/>
               <a:t>Fifth level</a:t>
             </a:r>
-            <a:endParaRPr lang="en-US"/>
           </a:p>
         </p:txBody>
       </p:sp>
@@ -2729,7 +2724,7 @@
           <a:p>
             <a:fld id="{5BCAD085-E8A6-8845-BD4E-CB4CCA059FC4}" type="datetimeFigureOut">
               <a:rPr lang="en-US" smtClean="0"/>
-              <a:t>1/27/13</a:t>
+              <a:t>6/19/26</a:t>
             </a:fld>
             <a:endParaRPr lang="en-US"/>
           </a:p>
@@ -3088,7 +3083,7 @@
 </file>
 
 <file path=ppt/slides/slide1.xml><?xml version="1.0" encoding="utf-8"?>
-<p:sld xmlns:a="http://schemas.openxmlformats.org/drawingml/2006/main" xmlns:p="http://schemas.openxmlformats.org/presentationml/2006/main" xmlns:r="http://schemas.openxmlformats.org/officeDocument/2006/relationships">
+<p:sld xmlns:a="http://schemas.openxmlformats.org/drawingml/2006/main" xmlns:r="http://schemas.openxmlformats.org/officeDocument/2006/relationships" xmlns:p="http://schemas.openxmlformats.org/presentationml/2006/main">
   <p:cSld>
     <p:bg>
       <p:bgPr>
@@ -3104,7 +3099,14 @@
         <p:cNvGrpSpPr/>
         <p:nvPr/>
       </p:nvGrpSpPr>
-      <p:grpSpPr/>
+      <p:grpSpPr>
+        <a:xfrm>
+          <a:off x="0" y="0"/>
+          <a:ext cx="0" cy="0"/>
+          <a:chOff x="0" y="0"/>
+          <a:chExt cx="0" cy="0"/>
+        </a:xfrm>
+      </p:grpSpPr>
       <p:sp>
         <p:nvSpPr>
           <p:cNvPr id="2" name="TextBox 1"/>
@@ -3258,7 +3260,7 @@
 </file>
 
 <file path=ppt/slides/slide10.xml><?xml version="1.0" encoding="utf-8"?>
-<p:sld xmlns:a="http://schemas.openxmlformats.org/drawingml/2006/main" xmlns:p="http://schemas.openxmlformats.org/presentationml/2006/main" xmlns:r="http://schemas.openxmlformats.org/officeDocument/2006/relationships">
+<p:sld xmlns:a="http://schemas.openxmlformats.org/drawingml/2006/main" xmlns:r="http://schemas.openxmlformats.org/officeDocument/2006/relationships" xmlns:p="http://schemas.openxmlformats.org/presentationml/2006/main">
   <p:cSld>
     <p:bg>
       <p:bgPr>
@@ -3274,7 +3276,14 @@
         <p:cNvGrpSpPr/>
         <p:nvPr/>
       </p:nvGrpSpPr>
-      <p:grpSpPr/>
+      <p:grpSpPr>
+        <a:xfrm>
+          <a:off x="0" y="0"/>
+          <a:ext cx="0" cy="0"/>
+          <a:chOff x="0" y="0"/>
+          <a:chExt cx="0" cy="0"/>
+        </a:xfrm>
+      </p:grpSpPr>
       <p:sp>
         <p:nvSpPr>
           <p:cNvPr id="2" name="TextBox 1"/>
@@ -3319,8 +3328,8 @@
         </p:nvSpPr>
         <p:spPr>
           <a:xfrm>
-            <a:off x="548640" y="1737360"/>
-            <a:ext cx="4114800" cy="411480"/>
+            <a:off x="640080" y="1920240"/>
+            <a:ext cx="10908792" cy="457200"/>
           </a:xfrm>
           <a:prstGeom prst="rect">
             <a:avLst/>
@@ -3351,6 +3360,7 @@
           <a:lstStyle/>
           <a:p>
             <a:pPr algn="ctr"/>
+            <a:endParaRPr/>
           </a:p>
         </p:txBody>
       </p:sp>
@@ -3362,8 +3372,8 @@
         </p:nvSpPr>
         <p:spPr>
           <a:xfrm>
-            <a:off x="731520" y="1737360"/>
-            <a:ext cx="1371600" cy="411480"/>
+            <a:off x="822960" y="1920240"/>
+            <a:ext cx="1463040" cy="457200"/>
           </a:xfrm>
           <a:prstGeom prst="rect">
             <a:avLst/>
@@ -3398,8 +3408,8 @@
         </p:nvSpPr>
         <p:spPr>
           <a:xfrm>
-            <a:off x="2103120" y="1737360"/>
-            <a:ext cx="2468880" cy="411480"/>
+            <a:off x="2331720" y="1920240"/>
+            <a:ext cx="8686800" cy="457200"/>
           </a:xfrm>
           <a:prstGeom prst="rect">
             <a:avLst/>
@@ -3434,8 +3444,8 @@
         </p:nvSpPr>
         <p:spPr>
           <a:xfrm>
-            <a:off x="548640" y="2240280"/>
-            <a:ext cx="4114800" cy="411480"/>
+            <a:off x="640080" y="2560320"/>
+            <a:ext cx="10908792" cy="457200"/>
           </a:xfrm>
           <a:prstGeom prst="rect">
             <a:avLst/>
@@ -3466,6 +3476,7 @@
           <a:lstStyle/>
           <a:p>
             <a:pPr algn="ctr"/>
+            <a:endParaRPr/>
           </a:p>
         </p:txBody>
       </p:sp>
@@ -3477,8 +3488,8 @@
         </p:nvSpPr>
         <p:spPr>
           <a:xfrm>
-            <a:off x="731520" y="2240280"/>
-            <a:ext cx="1371600" cy="411480"/>
+            <a:off x="822960" y="2560320"/>
+            <a:ext cx="1463040" cy="457200"/>
           </a:xfrm>
           <a:prstGeom prst="rect">
             <a:avLst/>
@@ -3513,8 +3524,8 @@
         </p:nvSpPr>
         <p:spPr>
           <a:xfrm>
-            <a:off x="2103120" y="2240280"/>
-            <a:ext cx="2468880" cy="411480"/>
+            <a:off x="2331720" y="2560320"/>
+            <a:ext cx="8686800" cy="457200"/>
           </a:xfrm>
           <a:prstGeom prst="rect">
             <a:avLst/>
@@ -3549,8 +3560,8 @@
         </p:nvSpPr>
         <p:spPr>
           <a:xfrm>
-            <a:off x="548640" y="2743200"/>
-            <a:ext cx="4114800" cy="411480"/>
+            <a:off x="640080" y="3200400"/>
+            <a:ext cx="10908792" cy="457200"/>
           </a:xfrm>
           <a:prstGeom prst="rect">
             <a:avLst/>
@@ -3581,6 +3592,7 @@
           <a:lstStyle/>
           <a:p>
             <a:pPr algn="ctr"/>
+            <a:endParaRPr/>
           </a:p>
         </p:txBody>
       </p:sp>
@@ -3592,8 +3604,8 @@
         </p:nvSpPr>
         <p:spPr>
           <a:xfrm>
-            <a:off x="731520" y="2743200"/>
-            <a:ext cx="1371600" cy="411480"/>
+            <a:off x="822960" y="3200400"/>
+            <a:ext cx="1463040" cy="457200"/>
           </a:xfrm>
           <a:prstGeom prst="rect">
             <a:avLst/>
@@ -3628,8 +3640,8 @@
         </p:nvSpPr>
         <p:spPr>
           <a:xfrm>
-            <a:off x="2103120" y="2743200"/>
-            <a:ext cx="2468880" cy="411480"/>
+            <a:off x="2331720" y="3200400"/>
+            <a:ext cx="8686800" cy="457200"/>
           </a:xfrm>
           <a:prstGeom prst="rect">
             <a:avLst/>
@@ -3664,8 +3676,8 @@
         </p:nvSpPr>
         <p:spPr>
           <a:xfrm>
-            <a:off x="548640" y="3429000"/>
-            <a:ext cx="8046720" cy="1051560"/>
+            <a:off x="640080" y="4023360"/>
+            <a:ext cx="10908792" cy="1188720"/>
           </a:xfrm>
           <a:prstGeom prst="rect">
             <a:avLst/>
@@ -3696,6 +3708,7 @@
           <a:lstStyle/>
           <a:p>
             <a:pPr algn="ctr"/>
+            <a:endParaRPr/>
           </a:p>
         </p:txBody>
       </p:sp>
@@ -3707,8 +3720,8 @@
         </p:nvSpPr>
         <p:spPr>
           <a:xfrm>
-            <a:off x="822960" y="3566160"/>
-            <a:ext cx="7498079" cy="777240"/>
+            <a:off x="914400" y="4160520"/>
+            <a:ext cx="10360152" cy="914400"/>
           </a:xfrm>
           <a:prstGeom prst="rect">
             <a:avLst/>
@@ -3739,7 +3752,7 @@
             </a:r>
             <a:br/>
             <a:r>
-              <a:t>Heterogeneous gossip 0.167  →  Homogeneous gossip 0.367  →  Naive 1.000 synchrony baseline</a:t>
+              <a:t>GridAI heterogeneous 0.167  →  GridAI homogeneous 0.367  →  Naive 1.000 synchrony baseline</a:t>
             </a:r>
           </a:p>
         </p:txBody>
@@ -3752,8 +3765,8 @@
         </p:nvSpPr>
         <p:spPr>
           <a:xfrm>
-            <a:off x="548640" y="4846320"/>
-            <a:ext cx="8046720" cy="274320"/>
+            <a:off x="548640" y="6126480"/>
+            <a:ext cx="10908792" cy="274320"/>
           </a:xfrm>
           <a:prstGeom prst="rect">
             <a:avLst/>
@@ -3789,7 +3802,7 @@
 </file>
 
 <file path=ppt/slides/slide2.xml><?xml version="1.0" encoding="utf-8"?>
-<p:sld xmlns:a="http://schemas.openxmlformats.org/drawingml/2006/main" xmlns:p="http://schemas.openxmlformats.org/presentationml/2006/main" xmlns:r="http://schemas.openxmlformats.org/officeDocument/2006/relationships">
+<p:sld xmlns:a="http://schemas.openxmlformats.org/drawingml/2006/main" xmlns:r="http://schemas.openxmlformats.org/officeDocument/2006/relationships" xmlns:p="http://schemas.openxmlformats.org/presentationml/2006/main">
   <p:cSld>
     <p:bg>
       <p:bgPr>
@@ -3805,7 +3818,14 @@
         <p:cNvGrpSpPr/>
         <p:nvPr/>
       </p:nvGrpSpPr>
-      <p:grpSpPr/>
+      <p:grpSpPr>
+        <a:xfrm>
+          <a:off x="0" y="0"/>
+          <a:ext cx="0" cy="0"/>
+          <a:chOff x="0" y="0"/>
+          <a:chExt cx="0" cy="0"/>
+        </a:xfrm>
+      </p:grpSpPr>
       <p:sp>
         <p:nvSpPr>
           <p:cNvPr id="2" name="TextBox 1"/>
@@ -3850,8 +3870,8 @@
         </p:nvSpPr>
         <p:spPr>
           <a:xfrm>
-            <a:off x="548640" y="1097280"/>
-            <a:ext cx="8046720" cy="457200"/>
+            <a:off x="548640" y="1417320"/>
+            <a:ext cx="10908792" cy="457200"/>
           </a:xfrm>
           <a:prstGeom prst="rect">
             <a:avLst/>
@@ -3886,8 +3906,8 @@
         </p:nvSpPr>
         <p:spPr>
           <a:xfrm>
-            <a:off x="548640" y="1737360"/>
-            <a:ext cx="5029200" cy="320040"/>
+            <a:off x="548640" y="2423160"/>
+            <a:ext cx="5760720" cy="365760"/>
           </a:xfrm>
           <a:prstGeom prst="rect">
             <a:avLst/>
@@ -3922,8 +3942,8 @@
         </p:nvSpPr>
         <p:spPr>
           <a:xfrm>
-            <a:off x="548640" y="2057400"/>
-            <a:ext cx="5029200" cy="320040"/>
+            <a:off x="548640" y="3017520"/>
+            <a:ext cx="5760720" cy="365760"/>
           </a:xfrm>
           <a:prstGeom prst="rect">
             <a:avLst/>
@@ -3958,8 +3978,8 @@
         </p:nvSpPr>
         <p:spPr>
           <a:xfrm>
-            <a:off x="548640" y="2377439"/>
-            <a:ext cx="5029200" cy="320040"/>
+            <a:off x="548640" y="3611880"/>
+            <a:ext cx="5760720" cy="365760"/>
           </a:xfrm>
           <a:prstGeom prst="rect">
             <a:avLst/>
@@ -3994,8 +4014,8 @@
         </p:nvSpPr>
         <p:spPr>
           <a:xfrm>
-            <a:off x="548640" y="2697479"/>
-            <a:ext cx="5029200" cy="320040"/>
+            <a:off x="548640" y="4206240"/>
+            <a:ext cx="5760720" cy="365760"/>
           </a:xfrm>
           <a:prstGeom prst="rect">
             <a:avLst/>
@@ -4030,8 +4050,8 @@
         </p:nvSpPr>
         <p:spPr>
           <a:xfrm>
-            <a:off x="5943600" y="2560320"/>
-            <a:ext cx="320040" cy="457200"/>
+            <a:off x="7818120" y="3246120"/>
+            <a:ext cx="502920" cy="731520"/>
           </a:xfrm>
           <a:prstGeom prst="rect">
             <a:avLst/>
@@ -4062,6 +4082,7 @@
           <a:lstStyle/>
           <a:p>
             <a:pPr algn="ctr"/>
+            <a:endParaRPr/>
           </a:p>
         </p:txBody>
       </p:sp>
@@ -4073,8 +4094,8 @@
         </p:nvSpPr>
         <p:spPr>
           <a:xfrm>
-            <a:off x="6400800" y="2560320"/>
-            <a:ext cx="320040" cy="457200"/>
+            <a:off x="8458200" y="3246120"/>
+            <a:ext cx="502920" cy="731520"/>
           </a:xfrm>
           <a:prstGeom prst="rect">
             <a:avLst/>
@@ -4105,6 +4126,7 @@
           <a:lstStyle/>
           <a:p>
             <a:pPr algn="ctr"/>
+            <a:endParaRPr/>
           </a:p>
         </p:txBody>
       </p:sp>
@@ -4116,8 +4138,8 @@
         </p:nvSpPr>
         <p:spPr>
           <a:xfrm>
-            <a:off x="6858000" y="2560320"/>
-            <a:ext cx="320040" cy="457200"/>
+            <a:off x="9098280" y="3246120"/>
+            <a:ext cx="502920" cy="731520"/>
           </a:xfrm>
           <a:prstGeom prst="rect">
             <a:avLst/>
@@ -4148,6 +4170,7 @@
           <a:lstStyle/>
           <a:p>
             <a:pPr algn="ctr"/>
+            <a:endParaRPr/>
           </a:p>
         </p:txBody>
       </p:sp>
@@ -4159,8 +4182,8 @@
         </p:nvSpPr>
         <p:spPr>
           <a:xfrm>
-            <a:off x="5943600" y="3063240"/>
-            <a:ext cx="1645920" cy="228600"/>
+            <a:off x="7772400" y="4069080"/>
+            <a:ext cx="1920240" cy="274320"/>
           </a:xfrm>
           <a:prstGeom prst="rect">
             <a:avLst/>
@@ -4195,8 +4218,8 @@
         </p:nvSpPr>
         <p:spPr>
           <a:xfrm>
-            <a:off x="7589520" y="2468880"/>
-            <a:ext cx="548640" cy="365760"/>
+            <a:off x="9784080" y="3383280"/>
+            <a:ext cx="502920" cy="457200"/>
           </a:xfrm>
           <a:prstGeom prst="rect">
             <a:avLst/>
@@ -4231,8 +4254,8 @@
         </p:nvSpPr>
         <p:spPr>
           <a:xfrm>
-            <a:off x="6217920" y="2103120"/>
-            <a:ext cx="1828800" cy="274320"/>
+            <a:off x="7772400" y="2560320"/>
+            <a:ext cx="2194560" cy="365760"/>
           </a:xfrm>
           <a:prstGeom prst="rect">
             <a:avLst/>
@@ -4263,6 +4286,7 @@
           <a:lstStyle/>
           <a:p>
             <a:pPr algn="ctr"/>
+            <a:endParaRPr/>
           </a:p>
         </p:txBody>
       </p:sp>
@@ -4274,8 +4298,8 @@
         </p:nvSpPr>
         <p:spPr>
           <a:xfrm>
-            <a:off x="6217920" y="2103120"/>
-            <a:ext cx="1828800" cy="274320"/>
+            <a:off x="7772400" y="2560320"/>
+            <a:ext cx="2194560" cy="365760"/>
           </a:xfrm>
           <a:prstGeom prst="rect">
             <a:avLst/>
@@ -4310,8 +4334,8 @@
         </p:nvSpPr>
         <p:spPr>
           <a:xfrm>
-            <a:off x="8229600" y="1965960"/>
-            <a:ext cx="640080" cy="1371600"/>
+            <a:off x="10469880" y="2697480"/>
+            <a:ext cx="914400" cy="1920240"/>
           </a:xfrm>
           <a:prstGeom prst="rect">
             <a:avLst/>
@@ -4342,6 +4366,7 @@
           <a:lstStyle/>
           <a:p>
             <a:pPr algn="ctr"/>
+            <a:endParaRPr/>
           </a:p>
         </p:txBody>
       </p:sp>
@@ -4353,8 +4378,8 @@
         </p:nvSpPr>
         <p:spPr>
           <a:xfrm>
-            <a:off x="8229600" y="3383280"/>
-            <a:ext cx="640080" cy="457200"/>
+            <a:off x="10378440" y="4663440"/>
+            <a:ext cx="1097280" cy="365760"/>
           </a:xfrm>
           <a:prstGeom prst="rect">
             <a:avLst/>
@@ -4393,8 +4418,8 @@
         </p:nvSpPr>
         <p:spPr>
           <a:xfrm>
-            <a:off x="548640" y="4206240"/>
-            <a:ext cx="8046720" cy="365760"/>
+            <a:off x="548640" y="5989320"/>
+            <a:ext cx="10908792" cy="365760"/>
           </a:xfrm>
           <a:prstGeom prst="rect">
             <a:avLst/>
@@ -4430,7 +4455,7 @@
 </file>
 
 <file path=ppt/slides/slide3.xml><?xml version="1.0" encoding="utf-8"?>
-<p:sld xmlns:a="http://schemas.openxmlformats.org/drawingml/2006/main" xmlns:p="http://schemas.openxmlformats.org/presentationml/2006/main" xmlns:r="http://schemas.openxmlformats.org/officeDocument/2006/relationships">
+<p:sld xmlns:a="http://schemas.openxmlformats.org/drawingml/2006/main" xmlns:r="http://schemas.openxmlformats.org/officeDocument/2006/relationships" xmlns:p="http://schemas.openxmlformats.org/presentationml/2006/main">
   <p:cSld>
     <p:bg>
       <p:bgPr>
@@ -4446,7 +4471,14 @@
         <p:cNvGrpSpPr/>
         <p:nvPr/>
       </p:nvGrpSpPr>
-      <p:grpSpPr/>
+      <p:grpSpPr>
+        <a:xfrm>
+          <a:off x="0" y="0"/>
+          <a:ext cx="0" cy="0"/>
+          <a:chOff x="0" y="0"/>
+          <a:chExt cx="0" cy="0"/>
+        </a:xfrm>
+      </p:grpSpPr>
       <p:sp>
         <p:nvSpPr>
           <p:cNvPr id="2" name="TextBox 1"/>
@@ -4491,8 +4523,8 @@
         </p:nvSpPr>
         <p:spPr>
           <a:xfrm>
-            <a:off x="548640" y="1097280"/>
-            <a:ext cx="8046720" cy="411480"/>
+            <a:off x="548640" y="1325880"/>
+            <a:ext cx="10908792" cy="411480"/>
           </a:xfrm>
           <a:prstGeom prst="rect">
             <a:avLst/>
@@ -4527,8 +4559,8 @@
         </p:nvSpPr>
         <p:spPr>
           <a:xfrm>
-            <a:off x="548640" y="1508760"/>
-            <a:ext cx="8046720" cy="320040"/>
+            <a:off x="548640" y="1783080"/>
+            <a:ext cx="10908792" cy="320040"/>
           </a:xfrm>
           <a:prstGeom prst="rect">
             <a:avLst/>
@@ -4563,8 +4595,8 @@
         </p:nvSpPr>
         <p:spPr>
           <a:xfrm>
-            <a:off x="548640" y="2194560"/>
-            <a:ext cx="3931920" cy="365760"/>
+            <a:off x="640080" y="2697480"/>
+            <a:ext cx="5257800" cy="457200"/>
           </a:xfrm>
           <a:prstGeom prst="rect">
             <a:avLst/>
@@ -4595,6 +4627,7 @@
           <a:lstStyle/>
           <a:p>
             <a:pPr algn="ctr"/>
+            <a:endParaRPr/>
           </a:p>
         </p:txBody>
       </p:sp>
@@ -4606,8 +4639,8 @@
         </p:nvSpPr>
         <p:spPr>
           <a:xfrm>
-            <a:off x="548640" y="2194560"/>
-            <a:ext cx="3931920" cy="365760"/>
+            <a:off x="640080" y="2697480"/>
+            <a:ext cx="5257800" cy="457200"/>
           </a:xfrm>
           <a:prstGeom prst="rect">
             <a:avLst/>
@@ -4642,8 +4675,8 @@
         </p:nvSpPr>
         <p:spPr>
           <a:xfrm>
-            <a:off x="4663440" y="2194560"/>
-            <a:ext cx="3931920" cy="365760"/>
+            <a:off x="6291072" y="2697480"/>
+            <a:ext cx="5257800" cy="457200"/>
           </a:xfrm>
           <a:prstGeom prst="rect">
             <a:avLst/>
@@ -4674,6 +4707,7 @@
           <a:lstStyle/>
           <a:p>
             <a:pPr algn="ctr"/>
+            <a:endParaRPr/>
           </a:p>
         </p:txBody>
       </p:sp>
@@ -4685,8 +4719,8 @@
         </p:nvSpPr>
         <p:spPr>
           <a:xfrm>
-            <a:off x="4663440" y="2194560"/>
-            <a:ext cx="3931920" cy="365760"/>
+            <a:off x="6291072" y="2697480"/>
+            <a:ext cx="5257800" cy="457200"/>
           </a:xfrm>
           <a:prstGeom prst="rect">
             <a:avLst/>
@@ -4721,8 +4755,8 @@
         </p:nvSpPr>
         <p:spPr>
           <a:xfrm>
-            <a:off x="548640" y="2560320"/>
-            <a:ext cx="3931920" cy="502920"/>
+            <a:off x="640080" y="3383280"/>
+            <a:ext cx="5257800" cy="603504"/>
           </a:xfrm>
           <a:prstGeom prst="rect">
             <a:avLst/>
@@ -4755,6 +4789,7 @@
           <a:lstStyle/>
           <a:p>
             <a:pPr algn="ctr"/>
+            <a:endParaRPr/>
           </a:p>
         </p:txBody>
       </p:sp>
@@ -4766,8 +4801,8 @@
         </p:nvSpPr>
         <p:spPr>
           <a:xfrm>
-            <a:off x="685800" y="2560320"/>
-            <a:ext cx="3657600" cy="502920"/>
+            <a:off x="822960" y="3383280"/>
+            <a:ext cx="4983480" cy="603504"/>
           </a:xfrm>
           <a:prstGeom prst="rect">
             <a:avLst/>
@@ -4802,8 +4837,8 @@
         </p:nvSpPr>
         <p:spPr>
           <a:xfrm>
-            <a:off x="4663440" y="2560320"/>
-            <a:ext cx="3931920" cy="502920"/>
+            <a:off x="6291072" y="3383280"/>
+            <a:ext cx="5257800" cy="603504"/>
           </a:xfrm>
           <a:prstGeom prst="rect">
             <a:avLst/>
@@ -4836,6 +4871,7 @@
           <a:lstStyle/>
           <a:p>
             <a:pPr algn="ctr"/>
+            <a:endParaRPr/>
           </a:p>
         </p:txBody>
       </p:sp>
@@ -4847,8 +4883,8 @@
         </p:nvSpPr>
         <p:spPr>
           <a:xfrm>
-            <a:off x="4800600" y="2560320"/>
-            <a:ext cx="3657600" cy="502920"/>
+            <a:off x="6473952" y="3383280"/>
+            <a:ext cx="4983480" cy="603504"/>
           </a:xfrm>
           <a:prstGeom prst="rect">
             <a:avLst/>
@@ -4883,8 +4919,8 @@
         </p:nvSpPr>
         <p:spPr>
           <a:xfrm>
-            <a:off x="548640" y="3063239"/>
-            <a:ext cx="3931920" cy="502920"/>
+            <a:off x="640080" y="4069080"/>
+            <a:ext cx="5257800" cy="603504"/>
           </a:xfrm>
           <a:prstGeom prst="rect">
             <a:avLst/>
@@ -4917,6 +4953,7 @@
           <a:lstStyle/>
           <a:p>
             <a:pPr algn="ctr"/>
+            <a:endParaRPr/>
           </a:p>
         </p:txBody>
       </p:sp>
@@ -4928,8 +4965,8 @@
         </p:nvSpPr>
         <p:spPr>
           <a:xfrm>
-            <a:off x="685800" y="3063239"/>
-            <a:ext cx="3657600" cy="502920"/>
+            <a:off x="822960" y="4069080"/>
+            <a:ext cx="4983480" cy="603504"/>
           </a:xfrm>
           <a:prstGeom prst="rect">
             <a:avLst/>
@@ -4964,8 +5001,8 @@
         </p:nvSpPr>
         <p:spPr>
           <a:xfrm>
-            <a:off x="4663440" y="3063239"/>
-            <a:ext cx="3931920" cy="502920"/>
+            <a:off x="6291072" y="4069080"/>
+            <a:ext cx="5257800" cy="603504"/>
           </a:xfrm>
           <a:prstGeom prst="rect">
             <a:avLst/>
@@ -4998,6 +5035,7 @@
           <a:lstStyle/>
           <a:p>
             <a:pPr algn="ctr"/>
+            <a:endParaRPr/>
           </a:p>
         </p:txBody>
       </p:sp>
@@ -5009,8 +5047,8 @@
         </p:nvSpPr>
         <p:spPr>
           <a:xfrm>
-            <a:off x="4800600" y="3063239"/>
-            <a:ext cx="3657600" cy="502920"/>
+            <a:off x="6473952" y="4069080"/>
+            <a:ext cx="4983480" cy="603504"/>
           </a:xfrm>
           <a:prstGeom prst="rect">
             <a:avLst/>
@@ -5045,8 +5083,8 @@
         </p:nvSpPr>
         <p:spPr>
           <a:xfrm>
-            <a:off x="548640" y="3566160"/>
-            <a:ext cx="3931920" cy="502920"/>
+            <a:off x="640080" y="4754880"/>
+            <a:ext cx="5257800" cy="603504"/>
           </a:xfrm>
           <a:prstGeom prst="rect">
             <a:avLst/>
@@ -5079,6 +5117,7 @@
           <a:lstStyle/>
           <a:p>
             <a:pPr algn="ctr"/>
+            <a:endParaRPr/>
           </a:p>
         </p:txBody>
       </p:sp>
@@ -5090,8 +5129,8 @@
         </p:nvSpPr>
         <p:spPr>
           <a:xfrm>
-            <a:off x="685800" y="3566160"/>
-            <a:ext cx="3657600" cy="502920"/>
+            <a:off x="822960" y="4754880"/>
+            <a:ext cx="4983480" cy="603504"/>
           </a:xfrm>
           <a:prstGeom prst="rect">
             <a:avLst/>
@@ -5126,8 +5165,8 @@
         </p:nvSpPr>
         <p:spPr>
           <a:xfrm>
-            <a:off x="4663440" y="3566160"/>
-            <a:ext cx="3931920" cy="502920"/>
+            <a:off x="6291072" y="4754880"/>
+            <a:ext cx="5257800" cy="603504"/>
           </a:xfrm>
           <a:prstGeom prst="rect">
             <a:avLst/>
@@ -5160,6 +5199,7 @@
           <a:lstStyle/>
           <a:p>
             <a:pPr algn="ctr"/>
+            <a:endParaRPr/>
           </a:p>
         </p:txBody>
       </p:sp>
@@ -5171,8 +5211,8 @@
         </p:nvSpPr>
         <p:spPr>
           <a:xfrm>
-            <a:off x="4800600" y="3566160"/>
-            <a:ext cx="3657600" cy="502920"/>
+            <a:off x="6473952" y="4754880"/>
+            <a:ext cx="4983480" cy="603504"/>
           </a:xfrm>
           <a:prstGeom prst="rect">
             <a:avLst/>
@@ -5207,8 +5247,8 @@
         </p:nvSpPr>
         <p:spPr>
           <a:xfrm>
-            <a:off x="548640" y="4114800"/>
-            <a:ext cx="8046720" cy="365760"/>
+            <a:off x="548640" y="6080760"/>
+            <a:ext cx="10908792" cy="365760"/>
           </a:xfrm>
           <a:prstGeom prst="rect">
             <a:avLst/>
@@ -5244,7 +5284,7 @@
 </file>
 
 <file path=ppt/slides/slide4.xml><?xml version="1.0" encoding="utf-8"?>
-<p:sld xmlns:a="http://schemas.openxmlformats.org/drawingml/2006/main" xmlns:p="http://schemas.openxmlformats.org/presentationml/2006/main" xmlns:r="http://schemas.openxmlformats.org/officeDocument/2006/relationships">
+<p:sld xmlns:a="http://schemas.openxmlformats.org/drawingml/2006/main" xmlns:r="http://schemas.openxmlformats.org/officeDocument/2006/relationships" xmlns:p="http://schemas.openxmlformats.org/presentationml/2006/main">
   <p:cSld>
     <p:bg>
       <p:bgPr>
@@ -5260,7 +5300,14 @@
         <p:cNvGrpSpPr/>
         <p:nvPr/>
       </p:nvGrpSpPr>
-      <p:grpSpPr/>
+      <p:grpSpPr>
+        <a:xfrm>
+          <a:off x="0" y="0"/>
+          <a:ext cx="0" cy="0"/>
+          <a:chOff x="0" y="0"/>
+          <a:chExt cx="0" cy="0"/>
+        </a:xfrm>
+      </p:grpSpPr>
       <p:sp>
         <p:nvSpPr>
           <p:cNvPr id="2" name="TextBox 1"/>
@@ -5305,8 +5352,8 @@
         </p:nvSpPr>
         <p:spPr>
           <a:xfrm>
-            <a:off x="548640" y="1097280"/>
-            <a:ext cx="8046720" cy="411480"/>
+            <a:off x="548640" y="1325880"/>
+            <a:ext cx="10908792" cy="411480"/>
           </a:xfrm>
           <a:prstGeom prst="rect">
             <a:avLst/>
@@ -5341,8 +5388,8 @@
         </p:nvSpPr>
         <p:spPr>
           <a:xfrm>
-            <a:off x="548640" y="1508760"/>
-            <a:ext cx="8046720" cy="320040"/>
+            <a:off x="548640" y="1783080"/>
+            <a:ext cx="10908792" cy="320040"/>
           </a:xfrm>
           <a:prstGeom prst="rect">
             <a:avLst/>
@@ -5377,8 +5424,8 @@
         </p:nvSpPr>
         <p:spPr>
           <a:xfrm>
-            <a:off x="548640" y="2194560"/>
-            <a:ext cx="2468880" cy="1645920"/>
+            <a:off x="640080" y="2606040"/>
+            <a:ext cx="3291840" cy="2331720"/>
           </a:xfrm>
           <a:prstGeom prst="rect">
             <a:avLst/>
@@ -5409,6 +5456,7 @@
           <a:lstStyle/>
           <a:p>
             <a:pPr algn="ctr"/>
+            <a:endParaRPr/>
           </a:p>
         </p:txBody>
       </p:sp>
@@ -5420,8 +5468,8 @@
         </p:nvSpPr>
         <p:spPr>
           <a:xfrm>
-            <a:off x="548640" y="2304288"/>
-            <a:ext cx="2468880" cy="411480"/>
+            <a:off x="640080" y="2834640"/>
+            <a:ext cx="3291840" cy="457200"/>
           </a:xfrm>
           <a:prstGeom prst="rect">
             <a:avLst/>
@@ -5456,8 +5504,8 @@
         </p:nvSpPr>
         <p:spPr>
           <a:xfrm>
-            <a:off x="548640" y="2697480"/>
-            <a:ext cx="2468880" cy="502920"/>
+            <a:off x="640080" y="3383280"/>
+            <a:ext cx="3291840" cy="640080"/>
           </a:xfrm>
           <a:prstGeom prst="rect">
             <a:avLst/>
@@ -5492,8 +5540,8 @@
         </p:nvSpPr>
         <p:spPr>
           <a:xfrm>
-            <a:off x="548640" y="3246120"/>
-            <a:ext cx="2468880" cy="411480"/>
+            <a:off x="640080" y="4251960"/>
+            <a:ext cx="3291840" cy="457200"/>
           </a:xfrm>
           <a:prstGeom prst="rect">
             <a:avLst/>
@@ -5532,8 +5580,8 @@
         </p:nvSpPr>
         <p:spPr>
           <a:xfrm>
-            <a:off x="3246120" y="2194560"/>
-            <a:ext cx="2468880" cy="1645920"/>
+            <a:off x="4453128" y="2606040"/>
+            <a:ext cx="3291840" cy="2331720"/>
           </a:xfrm>
           <a:prstGeom prst="rect">
             <a:avLst/>
@@ -5564,6 +5612,7 @@
           <a:lstStyle/>
           <a:p>
             <a:pPr algn="ctr"/>
+            <a:endParaRPr/>
           </a:p>
         </p:txBody>
       </p:sp>
@@ -5575,8 +5624,8 @@
         </p:nvSpPr>
         <p:spPr>
           <a:xfrm>
-            <a:off x="3246120" y="2304288"/>
-            <a:ext cx="2468880" cy="411480"/>
+            <a:off x="4453128" y="2834640"/>
+            <a:ext cx="3291840" cy="457200"/>
           </a:xfrm>
           <a:prstGeom prst="rect">
             <a:avLst/>
@@ -5598,7 +5647,7 @@
               </a:defRPr>
             </a:pPr>
             <a:r>
-              <a:t>GOSSIP</a:t>
+              <a:t>GRIDAI</a:t>
             </a:r>
             <a:br/>
             <a:r>
@@ -5615,8 +5664,8 @@
         </p:nvSpPr>
         <p:spPr>
           <a:xfrm>
-            <a:off x="3246120" y="2697480"/>
-            <a:ext cx="2468880" cy="502920"/>
+            <a:off x="4453128" y="3383280"/>
+            <a:ext cx="3291840" cy="640080"/>
           </a:xfrm>
           <a:prstGeom prst="rect">
             <a:avLst/>
@@ -5651,8 +5700,8 @@
         </p:nvSpPr>
         <p:spPr>
           <a:xfrm>
-            <a:off x="3246120" y="3246120"/>
-            <a:ext cx="2468880" cy="411480"/>
+            <a:off x="4453128" y="4251960"/>
+            <a:ext cx="3291840" cy="457200"/>
           </a:xfrm>
           <a:prstGeom prst="rect">
             <a:avLst/>
@@ -5691,8 +5740,8 @@
         </p:nvSpPr>
         <p:spPr>
           <a:xfrm>
-            <a:off x="5943600" y="2194560"/>
-            <a:ext cx="2468880" cy="1645920"/>
+            <a:off x="8257031" y="2606040"/>
+            <a:ext cx="3291840" cy="2331720"/>
           </a:xfrm>
           <a:prstGeom prst="rect">
             <a:avLst/>
@@ -5723,6 +5772,7 @@
           <a:lstStyle/>
           <a:p>
             <a:pPr algn="ctr"/>
+            <a:endParaRPr/>
           </a:p>
         </p:txBody>
       </p:sp>
@@ -5734,8 +5784,8 @@
         </p:nvSpPr>
         <p:spPr>
           <a:xfrm>
-            <a:off x="5943600" y="2304288"/>
-            <a:ext cx="2468880" cy="411480"/>
+            <a:off x="8257031" y="2834640"/>
+            <a:ext cx="3291840" cy="457200"/>
           </a:xfrm>
           <a:prstGeom prst="rect">
             <a:avLst/>
@@ -5757,7 +5807,7 @@
               </a:defRPr>
             </a:pPr>
             <a:r>
-              <a:t>GOSSIP</a:t>
+              <a:t>GRIDAI</a:t>
             </a:r>
             <a:br/>
             <a:r>
@@ -5774,8 +5824,8 @@
         </p:nvSpPr>
         <p:spPr>
           <a:xfrm>
-            <a:off x="5943600" y="2697480"/>
-            <a:ext cx="2468880" cy="502920"/>
+            <a:off x="8257031" y="3383280"/>
+            <a:ext cx="3291840" cy="640080"/>
           </a:xfrm>
           <a:prstGeom prst="rect">
             <a:avLst/>
@@ -5810,8 +5860,8 @@
         </p:nvSpPr>
         <p:spPr>
           <a:xfrm>
-            <a:off x="5943600" y="3246120"/>
-            <a:ext cx="2468880" cy="411480"/>
+            <a:off x="8257031" y="4251960"/>
+            <a:ext cx="3291840" cy="457200"/>
           </a:xfrm>
           <a:prstGeom prst="rect">
             <a:avLst/>
@@ -5850,8 +5900,8 @@
         </p:nvSpPr>
         <p:spPr>
           <a:xfrm>
-            <a:off x="548640" y="4160520"/>
-            <a:ext cx="8046720" cy="320040"/>
+            <a:off x="548640" y="5897880"/>
+            <a:ext cx="10908792" cy="320040"/>
           </a:xfrm>
           <a:prstGeom prst="rect">
             <a:avLst/>
@@ -5887,7 +5937,7 @@
 </file>
 
 <file path=ppt/slides/slide5.xml><?xml version="1.0" encoding="utf-8"?>
-<p:sld xmlns:a="http://schemas.openxmlformats.org/drawingml/2006/main" xmlns:p="http://schemas.openxmlformats.org/presentationml/2006/main" xmlns:r="http://schemas.openxmlformats.org/officeDocument/2006/relationships">
+<p:sld xmlns:a="http://schemas.openxmlformats.org/drawingml/2006/main" xmlns:r="http://schemas.openxmlformats.org/officeDocument/2006/relationships" xmlns:p="http://schemas.openxmlformats.org/presentationml/2006/main">
   <p:cSld>
     <p:bg>
       <p:bgPr>
@@ -5903,7 +5953,14 @@
         <p:cNvGrpSpPr/>
         <p:nvPr/>
       </p:nvGrpSpPr>
-      <p:grpSpPr/>
+      <p:grpSpPr>
+        <a:xfrm>
+          <a:off x="0" y="0"/>
+          <a:ext cx="0" cy="0"/>
+          <a:chOff x="0" y="0"/>
+          <a:chExt cx="0" cy="0"/>
+        </a:xfrm>
+      </p:grpSpPr>
       <p:sp>
         <p:nvSpPr>
           <p:cNvPr id="2" name="TextBox 1"/>
@@ -5948,8 +6005,8 @@
         </p:nvSpPr>
         <p:spPr>
           <a:xfrm>
-            <a:off x="548640" y="1097280"/>
-            <a:ext cx="4754880" cy="502920"/>
+            <a:off x="548640" y="1554480"/>
+            <a:ext cx="6217920" cy="640080"/>
           </a:xfrm>
           <a:prstGeom prst="rect">
             <a:avLst/>
@@ -5971,7 +6028,7 @@
               </a:defRPr>
             </a:pPr>
             <a:r>
-              <a:t>GridAI: gossip-based decentralised protocol with a Band-native compliance layer.</a:t>
+              <a:t>GridAI: priority-based coordination protocol with a Band-native compliance layer.</a:t>
             </a:r>
           </a:p>
         </p:txBody>
@@ -5984,8 +6041,8 @@
         </p:nvSpPr>
         <p:spPr>
           <a:xfrm>
-            <a:off x="731520" y="1828800"/>
-            <a:ext cx="4572000" cy="457200"/>
+            <a:off x="731520" y="2514600"/>
+            <a:ext cx="6035040" cy="502920"/>
           </a:xfrm>
           <a:prstGeom prst="rect">
             <a:avLst/>
@@ -6007,7 +6064,7 @@
               </a:defRPr>
             </a:pPr>
             <a:r>
-              <a:t>•  Each battery negotiates with local neighbours only using SOC and owner preference.</a:t>
+              <a:t>•  The Coordinator allocates each battery's dispatch slot from global fleet state, using SOC and owner preference.</a:t>
             </a:r>
           </a:p>
         </p:txBody>
@@ -6020,8 +6077,8 @@
         </p:nvSpPr>
         <p:spPr>
           <a:xfrm>
-            <a:off x="731520" y="2331720"/>
-            <a:ext cx="4572000" cy="457200"/>
+            <a:off x="731520" y="3154680"/>
+            <a:ext cx="6035040" cy="502920"/>
           </a:xfrm>
           <a:prstGeom prst="rect">
             <a:avLst/>
@@ -6043,7 +6100,7 @@
               </a:defRPr>
             </a:pPr>
             <a:r>
-              <a:t>•  No central controller. Converges in 1 round.</a:t>
+              <a:t>•  Centralised priority allocation, decentralised-ready. Converges in 1 to 2 rounds.</a:t>
             </a:r>
           </a:p>
         </p:txBody>
@@ -6056,8 +6113,8 @@
         </p:nvSpPr>
         <p:spPr>
           <a:xfrm>
-            <a:off x="548640" y="3017520"/>
-            <a:ext cx="4572000" cy="320040"/>
+            <a:off x="548640" y="4069080"/>
+            <a:ext cx="6217920" cy="320040"/>
           </a:xfrm>
           <a:prstGeom prst="rect">
             <a:avLst/>
@@ -6092,8 +6149,8 @@
         </p:nvSpPr>
         <p:spPr>
           <a:xfrm>
-            <a:off x="548640" y="3383279"/>
-            <a:ext cx="4572000" cy="502920"/>
+            <a:off x="548640" y="4480560"/>
+            <a:ext cx="6217920" cy="640080"/>
           </a:xfrm>
           <a:prstGeom prst="rect">
             <a:avLst/>
@@ -6128,8 +6185,8 @@
         </p:nvSpPr>
         <p:spPr>
           <a:xfrm>
-            <a:off x="548640" y="3931920"/>
-            <a:ext cx="4572000" cy="320040"/>
+            <a:off x="548640" y="5349240"/>
+            <a:ext cx="6217920" cy="365760"/>
           </a:xfrm>
           <a:prstGeom prst="rect">
             <a:avLst/>
@@ -6151,7 +6208,7 @@
               </a:defRPr>
             </a:pPr>
             <a:r>
-              <a:t>Honest tradeoff: mild far-feeder undervoltage (distinct from herding, surfaced not hidden)</a:t>
+              <a:t>Honest tradeoff: 435 far-feeder undervoltage events (distinct from herding, disclosed not hidden, next tuning target)</a:t>
             </a:r>
           </a:p>
         </p:txBody>
@@ -6172,8 +6229,8 @@
         </p:blipFill>
         <p:spPr>
           <a:xfrm>
-            <a:off x="5486400" y="1097280"/>
-            <a:ext cx="3200400" cy="3200400"/>
+            <a:off x="6976872" y="1508760"/>
+            <a:ext cx="4572000" cy="4572000"/>
           </a:xfrm>
           <a:prstGeom prst="rect">
             <a:avLst/>
@@ -6189,7 +6246,7 @@
 </file>
 
 <file path=ppt/slides/slide6.xml><?xml version="1.0" encoding="utf-8"?>
-<p:sld xmlns:a="http://schemas.openxmlformats.org/drawingml/2006/main" xmlns:p="http://schemas.openxmlformats.org/presentationml/2006/main" xmlns:r="http://schemas.openxmlformats.org/officeDocument/2006/relationships">
+<p:sld xmlns:a="http://schemas.openxmlformats.org/drawingml/2006/main" xmlns:r="http://schemas.openxmlformats.org/officeDocument/2006/relationships" xmlns:p="http://schemas.openxmlformats.org/presentationml/2006/main">
   <p:cSld>
     <p:bg>
       <p:bgPr>
@@ -6205,7 +6262,14 @@
         <p:cNvGrpSpPr/>
         <p:nvPr/>
       </p:nvGrpSpPr>
-      <p:grpSpPr/>
+      <p:grpSpPr>
+        <a:xfrm>
+          <a:off x="0" y="0"/>
+          <a:ext cx="0" cy="0"/>
+          <a:chOff x="0" y="0"/>
+          <a:chExt cx="0" cy="0"/>
+        </a:xfrm>
+      </p:grpSpPr>
       <p:sp>
         <p:nvSpPr>
           <p:cNvPr id="2" name="TextBox 1"/>
@@ -6250,8 +6314,8 @@
         </p:nvSpPr>
         <p:spPr>
           <a:xfrm>
-            <a:off x="548640" y="1051560"/>
-            <a:ext cx="8046720" cy="365760"/>
+            <a:off x="548640" y="1325880"/>
+            <a:ext cx="10908792" cy="365760"/>
           </a:xfrm>
           <a:prstGeom prst="rect">
             <a:avLst/>
@@ -6286,8 +6350,8 @@
         </p:nvSpPr>
         <p:spPr>
           <a:xfrm>
-            <a:off x="548640" y="1645920"/>
-            <a:ext cx="1828800" cy="1371600"/>
+            <a:off x="640080" y="2194560"/>
+            <a:ext cx="2514600" cy="1783080"/>
           </a:xfrm>
           <a:prstGeom prst="rect">
             <a:avLst/>
@@ -6318,6 +6382,7 @@
           <a:lstStyle/>
           <a:p>
             <a:pPr algn="ctr"/>
+            <a:endParaRPr/>
           </a:p>
         </p:txBody>
       </p:sp>
@@ -6329,8 +6394,8 @@
         </p:nvSpPr>
         <p:spPr>
           <a:xfrm>
-            <a:off x="548640" y="1755648"/>
-            <a:ext cx="1828800" cy="320040"/>
+            <a:off x="640080" y="2331720"/>
+            <a:ext cx="2514600" cy="320040"/>
           </a:xfrm>
           <a:prstGeom prst="rect">
             <a:avLst/>
@@ -6365,8 +6430,8 @@
         </p:nvSpPr>
         <p:spPr>
           <a:xfrm>
-            <a:off x="640080" y="2148840"/>
-            <a:ext cx="1645920" cy="731520"/>
+            <a:off x="731520" y="2743200"/>
+            <a:ext cx="2331720" cy="868680"/>
           </a:xfrm>
           <a:prstGeom prst="rect">
             <a:avLst/>
@@ -6405,7 +6470,7 @@
         </p:nvSpPr>
         <p:spPr>
           <a:xfrm>
-            <a:off x="2395728" y="1965960"/>
+            <a:off x="3182112" y="2926080"/>
             <a:ext cx="237744" cy="365760"/>
           </a:xfrm>
           <a:prstGeom prst="rect">
@@ -6441,8 +6506,8 @@
         </p:nvSpPr>
         <p:spPr>
           <a:xfrm>
-            <a:off x="2651760" y="1645920"/>
-            <a:ext cx="1828800" cy="1371600"/>
+            <a:off x="3438144" y="2194560"/>
+            <a:ext cx="2514600" cy="1783080"/>
           </a:xfrm>
           <a:prstGeom prst="rect">
             <a:avLst/>
@@ -6473,6 +6538,7 @@
           <a:lstStyle/>
           <a:p>
             <a:pPr algn="ctr"/>
+            <a:endParaRPr/>
           </a:p>
         </p:txBody>
       </p:sp>
@@ -6484,8 +6550,8 @@
         </p:nvSpPr>
         <p:spPr>
           <a:xfrm>
-            <a:off x="2651760" y="1755648"/>
-            <a:ext cx="1828800" cy="320040"/>
+            <a:off x="3438144" y="2331720"/>
+            <a:ext cx="2514600" cy="320040"/>
           </a:xfrm>
           <a:prstGeom prst="rect">
             <a:avLst/>
@@ -6520,8 +6586,8 @@
         </p:nvSpPr>
         <p:spPr>
           <a:xfrm>
-            <a:off x="2743200" y="2148840"/>
-            <a:ext cx="1645920" cy="731520"/>
+            <a:off x="3529584" y="2743200"/>
+            <a:ext cx="2331720" cy="868680"/>
           </a:xfrm>
           <a:prstGeom prst="rect">
             <a:avLst/>
@@ -6543,7 +6609,7 @@
               </a:defRPr>
             </a:pPr>
             <a:r>
-              <a:t>Runs gossip protocol, hands</a:t>
+              <a:t>Runs priority-based dispatch, hands</a:t>
             </a:r>
             <a:br/>
             <a:r>
@@ -6560,7 +6626,7 @@
         </p:nvSpPr>
         <p:spPr>
           <a:xfrm>
-            <a:off x="4498848" y="1965960"/>
+            <a:off x="5980176" y="2926080"/>
             <a:ext cx="237744" cy="365760"/>
           </a:xfrm>
           <a:prstGeom prst="rect">
@@ -6596,8 +6662,8 @@
         </p:nvSpPr>
         <p:spPr>
           <a:xfrm>
-            <a:off x="4754879" y="1645920"/>
-            <a:ext cx="1828800" cy="1371600"/>
+            <a:off x="6236208" y="2194560"/>
+            <a:ext cx="2514600" cy="1783080"/>
           </a:xfrm>
           <a:prstGeom prst="rect">
             <a:avLst/>
@@ -6628,6 +6694,7 @@
           <a:lstStyle/>
           <a:p>
             <a:pPr algn="ctr"/>
+            <a:endParaRPr/>
           </a:p>
         </p:txBody>
       </p:sp>
@@ -6639,8 +6706,8 @@
         </p:nvSpPr>
         <p:spPr>
           <a:xfrm>
-            <a:off x="4754879" y="1755648"/>
-            <a:ext cx="1828800" cy="320040"/>
+            <a:off x="6236208" y="2331720"/>
+            <a:ext cx="2514600" cy="320040"/>
           </a:xfrm>
           <a:prstGeom prst="rect">
             <a:avLst/>
@@ -6675,8 +6742,8 @@
         </p:nvSpPr>
         <p:spPr>
           <a:xfrm>
-            <a:off x="4846319" y="2148840"/>
-            <a:ext cx="1645920" cy="731520"/>
+            <a:off x="6327648" y="2743200"/>
+            <a:ext cx="2331720" cy="868680"/>
           </a:xfrm>
           <a:prstGeom prst="rect">
             <a:avLst/>
@@ -6715,7 +6782,7 @@
         </p:nvSpPr>
         <p:spPr>
           <a:xfrm>
-            <a:off x="6601967" y="1965960"/>
+            <a:off x="8778240" y="2926080"/>
             <a:ext cx="237744" cy="365760"/>
           </a:xfrm>
           <a:prstGeom prst="rect">
@@ -6751,8 +6818,8 @@
         </p:nvSpPr>
         <p:spPr>
           <a:xfrm>
-            <a:off x="6857999" y="1645920"/>
-            <a:ext cx="1828800" cy="1371600"/>
+            <a:off x="9034272" y="2194560"/>
+            <a:ext cx="2514600" cy="1783080"/>
           </a:xfrm>
           <a:prstGeom prst="rect">
             <a:avLst/>
@@ -6783,6 +6850,7 @@
           <a:lstStyle/>
           <a:p>
             <a:pPr algn="ctr"/>
+            <a:endParaRPr/>
           </a:p>
         </p:txBody>
       </p:sp>
@@ -6794,8 +6862,8 @@
         </p:nvSpPr>
         <p:spPr>
           <a:xfrm>
-            <a:off x="6857999" y="1755648"/>
-            <a:ext cx="1828800" cy="320040"/>
+            <a:off x="9034272" y="2331720"/>
+            <a:ext cx="2514600" cy="320040"/>
           </a:xfrm>
           <a:prstGeom prst="rect">
             <a:avLst/>
@@ -6830,8 +6898,8 @@
         </p:nvSpPr>
         <p:spPr>
           <a:xfrm>
-            <a:off x="6949439" y="2148840"/>
-            <a:ext cx="1645920" cy="731520"/>
+            <a:off x="9125712" y="2743200"/>
+            <a:ext cx="2331720" cy="868680"/>
           </a:xfrm>
           <a:prstGeom prst="rect">
             <a:avLst/>
@@ -6870,8 +6938,8 @@
         </p:nvSpPr>
         <p:spPr>
           <a:xfrm>
-            <a:off x="548640" y="3383280"/>
-            <a:ext cx="8046720" cy="320040"/>
+            <a:off x="640080" y="4297680"/>
+            <a:ext cx="10908792" cy="411480"/>
           </a:xfrm>
           <a:prstGeom prst="rect">
             <a:avLst/>
@@ -6902,6 +6970,7 @@
           <a:lstStyle/>
           <a:p>
             <a:pPr algn="ctr"/>
+            <a:endParaRPr/>
           </a:p>
         </p:txBody>
       </p:sp>
@@ -6913,8 +6982,8 @@
         </p:nvSpPr>
         <p:spPr>
           <a:xfrm>
-            <a:off x="548640" y="3383280"/>
-            <a:ext cx="8046720" cy="320040"/>
+            <a:off x="640080" y="4297680"/>
+            <a:ext cx="10908792" cy="411480"/>
           </a:xfrm>
           <a:prstGeom prst="rect">
             <a:avLst/>
@@ -6949,8 +7018,8 @@
         </p:nvSpPr>
         <p:spPr>
           <a:xfrm>
-            <a:off x="1371600" y="3931920"/>
-            <a:ext cx="6400800" cy="411480"/>
+            <a:off x="2441448" y="4983480"/>
+            <a:ext cx="7315200" cy="502920"/>
           </a:xfrm>
           <a:prstGeom prst="rect">
             <a:avLst/>
@@ -6981,6 +7050,7 @@
           <a:lstStyle/>
           <a:p>
             <a:pPr algn="ctr"/>
+            <a:endParaRPr/>
           </a:p>
         </p:txBody>
       </p:sp>
@@ -6992,8 +7062,8 @@
         </p:nvSpPr>
         <p:spPr>
           <a:xfrm>
-            <a:off x="1371600" y="3931920"/>
-            <a:ext cx="6400800" cy="411480"/>
+            <a:off x="2441448" y="4983480"/>
+            <a:ext cx="7315200" cy="502920"/>
           </a:xfrm>
           <a:prstGeom prst="rect">
             <a:avLst/>
@@ -7028,8 +7098,8 @@
         </p:nvSpPr>
         <p:spPr>
           <a:xfrm>
-            <a:off x="548640" y="4709160"/>
-            <a:ext cx="8046720" cy="320040"/>
+            <a:off x="548640" y="5989320"/>
+            <a:ext cx="10908792" cy="320040"/>
           </a:xfrm>
           <a:prstGeom prst="rect">
             <a:avLst/>
@@ -7065,7 +7135,7 @@
 </file>
 
 <file path=ppt/slides/slide7.xml><?xml version="1.0" encoding="utf-8"?>
-<p:sld xmlns:a="http://schemas.openxmlformats.org/drawingml/2006/main" xmlns:p="http://schemas.openxmlformats.org/presentationml/2006/main" xmlns:r="http://schemas.openxmlformats.org/officeDocument/2006/relationships">
+<p:sld xmlns:a="http://schemas.openxmlformats.org/drawingml/2006/main" xmlns:r="http://schemas.openxmlformats.org/officeDocument/2006/relationships" xmlns:p="http://schemas.openxmlformats.org/presentationml/2006/main">
   <p:cSld>
     <p:bg>
       <p:bgPr>
@@ -7081,7 +7151,14 @@
         <p:cNvGrpSpPr/>
         <p:nvPr/>
       </p:nvGrpSpPr>
-      <p:grpSpPr/>
+      <p:grpSpPr>
+        <a:xfrm>
+          <a:off x="0" y="0"/>
+          <a:ext cx="0" cy="0"/>
+          <a:chOff x="0" y="0"/>
+          <a:chExt cx="0" cy="0"/>
+        </a:xfrm>
+      </p:grpSpPr>
       <p:sp>
         <p:nvSpPr>
           <p:cNvPr id="2" name="TextBox 1"/>
@@ -7126,8 +7203,8 @@
         </p:nvSpPr>
         <p:spPr>
           <a:xfrm>
-            <a:off x="640080" y="1188720"/>
-            <a:ext cx="3657600" cy="347472"/>
+            <a:off x="640080" y="1691640"/>
+            <a:ext cx="5303520" cy="438912"/>
           </a:xfrm>
           <a:prstGeom prst="rect">
             <a:avLst/>
@@ -7158,6 +7235,7 @@
           <a:lstStyle/>
           <a:p>
             <a:pPr algn="ctr"/>
+            <a:endParaRPr/>
           </a:p>
         </p:txBody>
       </p:sp>
@@ -7169,8 +7247,8 @@
         </p:nvSpPr>
         <p:spPr>
           <a:xfrm>
-            <a:off x="777240" y="1188720"/>
-            <a:ext cx="3383280" cy="347472"/>
+            <a:off x="777240" y="1691640"/>
+            <a:ext cx="5029200" cy="438912"/>
           </a:xfrm>
           <a:prstGeom prst="rect">
             <a:avLst/>
@@ -7205,8 +7283,8 @@
         </p:nvSpPr>
         <p:spPr>
           <a:xfrm>
-            <a:off x="4343400" y="1188720"/>
-            <a:ext cx="2103120" cy="347472"/>
+            <a:off x="6126480" y="1691640"/>
+            <a:ext cx="2606040" cy="438912"/>
           </a:xfrm>
           <a:prstGeom prst="rect">
             <a:avLst/>
@@ -7237,6 +7315,7 @@
           <a:lstStyle/>
           <a:p>
             <a:pPr algn="ctr"/>
+            <a:endParaRPr/>
           </a:p>
         </p:txBody>
       </p:sp>
@@ -7248,8 +7327,8 @@
         </p:nvSpPr>
         <p:spPr>
           <a:xfrm>
-            <a:off x="4480560" y="1188720"/>
-            <a:ext cx="1828799" cy="347472"/>
+            <a:off x="6263640" y="1691640"/>
+            <a:ext cx="2331720" cy="438912"/>
           </a:xfrm>
           <a:prstGeom prst="rect">
             <a:avLst/>
@@ -7284,8 +7363,8 @@
         </p:nvSpPr>
         <p:spPr>
           <a:xfrm>
-            <a:off x="6492240" y="1188720"/>
-            <a:ext cx="2103120" cy="347472"/>
+            <a:off x="8851392" y="1691640"/>
+            <a:ext cx="2606040" cy="438912"/>
           </a:xfrm>
           <a:prstGeom prst="rect">
             <a:avLst/>
@@ -7316,6 +7395,7 @@
           <a:lstStyle/>
           <a:p>
             <a:pPr algn="ctr"/>
+            <a:endParaRPr/>
           </a:p>
         </p:txBody>
       </p:sp>
@@ -7327,8 +7407,8 @@
         </p:nvSpPr>
         <p:spPr>
           <a:xfrm>
-            <a:off x="6629400" y="1188720"/>
-            <a:ext cx="1828799" cy="347472"/>
+            <a:off x="8988552" y="1691640"/>
+            <a:ext cx="2331720" cy="438912"/>
           </a:xfrm>
           <a:prstGeom prst="rect">
             <a:avLst/>
@@ -7363,8 +7443,8 @@
         </p:nvSpPr>
         <p:spPr>
           <a:xfrm>
-            <a:off x="777240" y="1554480"/>
-            <a:ext cx="3383280" cy="347472"/>
+            <a:off x="777240" y="2286000"/>
+            <a:ext cx="5029200" cy="502920"/>
           </a:xfrm>
           <a:prstGeom prst="rect">
             <a:avLst/>
@@ -7399,8 +7479,8 @@
         </p:nvSpPr>
         <p:spPr>
           <a:xfrm>
-            <a:off x="4480560" y="1554480"/>
-            <a:ext cx="1828799" cy="347472"/>
+            <a:off x="6263640" y="2286000"/>
+            <a:ext cx="2331720" cy="502920"/>
           </a:xfrm>
           <a:prstGeom prst="rect">
             <a:avLst/>
@@ -7435,8 +7515,8 @@
         </p:nvSpPr>
         <p:spPr>
           <a:xfrm>
-            <a:off x="6629400" y="1554480"/>
-            <a:ext cx="1828799" cy="347472"/>
+            <a:off x="8988552" y="2286000"/>
+            <a:ext cx="2331720" cy="502920"/>
           </a:xfrm>
           <a:prstGeom prst="rect">
             <a:avLst/>
@@ -7471,8 +7551,8 @@
         </p:nvSpPr>
         <p:spPr>
           <a:xfrm>
-            <a:off x="640080" y="1920240"/>
-            <a:ext cx="3657600" cy="347472"/>
+            <a:off x="640080" y="2880360"/>
+            <a:ext cx="5303520" cy="502920"/>
           </a:xfrm>
           <a:prstGeom prst="rect">
             <a:avLst/>
@@ -7503,6 +7583,7 @@
           <a:lstStyle/>
           <a:p>
             <a:pPr algn="ctr"/>
+            <a:endParaRPr/>
           </a:p>
         </p:txBody>
       </p:sp>
@@ -7514,8 +7595,8 @@
         </p:nvSpPr>
         <p:spPr>
           <a:xfrm>
-            <a:off x="777240" y="1920240"/>
-            <a:ext cx="3383280" cy="347472"/>
+            <a:off x="777240" y="2880360"/>
+            <a:ext cx="5029200" cy="502920"/>
           </a:xfrm>
           <a:prstGeom prst="rect">
             <a:avLst/>
@@ -7550,8 +7631,8 @@
         </p:nvSpPr>
         <p:spPr>
           <a:xfrm>
-            <a:off x="4343400" y="1920240"/>
-            <a:ext cx="2103120" cy="347472"/>
+            <a:off x="6126480" y="2880360"/>
+            <a:ext cx="2606040" cy="502920"/>
           </a:xfrm>
           <a:prstGeom prst="rect">
             <a:avLst/>
@@ -7582,6 +7663,7 @@
           <a:lstStyle/>
           <a:p>
             <a:pPr algn="ctr"/>
+            <a:endParaRPr/>
           </a:p>
         </p:txBody>
       </p:sp>
@@ -7593,8 +7675,8 @@
         </p:nvSpPr>
         <p:spPr>
           <a:xfrm>
-            <a:off x="4480560" y="1920240"/>
-            <a:ext cx="1828799" cy="347472"/>
+            <a:off x="6263640" y="2880360"/>
+            <a:ext cx="2331720" cy="502920"/>
           </a:xfrm>
           <a:prstGeom prst="rect">
             <a:avLst/>
@@ -7629,8 +7711,8 @@
         </p:nvSpPr>
         <p:spPr>
           <a:xfrm>
-            <a:off x="6492240" y="1920240"/>
-            <a:ext cx="2103120" cy="347472"/>
+            <a:off x="8851392" y="2880360"/>
+            <a:ext cx="2606040" cy="502920"/>
           </a:xfrm>
           <a:prstGeom prst="rect">
             <a:avLst/>
@@ -7661,6 +7743,7 @@
           <a:lstStyle/>
           <a:p>
             <a:pPr algn="ctr"/>
+            <a:endParaRPr/>
           </a:p>
         </p:txBody>
       </p:sp>
@@ -7672,8 +7755,8 @@
         </p:nvSpPr>
         <p:spPr>
           <a:xfrm>
-            <a:off x="6629400" y="1920240"/>
-            <a:ext cx="1828799" cy="347472"/>
+            <a:off x="8988552" y="2880360"/>
+            <a:ext cx="2331720" cy="502920"/>
           </a:xfrm>
           <a:prstGeom prst="rect">
             <a:avLst/>
@@ -7708,8 +7791,8 @@
         </p:nvSpPr>
         <p:spPr>
           <a:xfrm>
-            <a:off x="777240" y="2286000"/>
-            <a:ext cx="3383280" cy="347472"/>
+            <a:off x="777240" y="3474720"/>
+            <a:ext cx="5029200" cy="502920"/>
           </a:xfrm>
           <a:prstGeom prst="rect">
             <a:avLst/>
@@ -7744,8 +7827,8 @@
         </p:nvSpPr>
         <p:spPr>
           <a:xfrm>
-            <a:off x="4480560" y="2286000"/>
-            <a:ext cx="1828799" cy="347472"/>
+            <a:off x="6263640" y="3474720"/>
+            <a:ext cx="2331720" cy="502920"/>
           </a:xfrm>
           <a:prstGeom prst="rect">
             <a:avLst/>
@@ -7780,8 +7863,8 @@
         </p:nvSpPr>
         <p:spPr>
           <a:xfrm>
-            <a:off x="6629400" y="2286000"/>
-            <a:ext cx="1828799" cy="347472"/>
+            <a:off x="8988552" y="3474720"/>
+            <a:ext cx="2331720" cy="502920"/>
           </a:xfrm>
           <a:prstGeom prst="rect">
             <a:avLst/>
@@ -7816,8 +7899,8 @@
         </p:nvSpPr>
         <p:spPr>
           <a:xfrm>
-            <a:off x="640080" y="2651760"/>
-            <a:ext cx="3657600" cy="347472"/>
+            <a:off x="640080" y="4069080"/>
+            <a:ext cx="5303520" cy="502920"/>
           </a:xfrm>
           <a:prstGeom prst="rect">
             <a:avLst/>
@@ -7848,6 +7931,7 @@
           <a:lstStyle/>
           <a:p>
             <a:pPr algn="ctr"/>
+            <a:endParaRPr/>
           </a:p>
         </p:txBody>
       </p:sp>
@@ -7859,8 +7943,8 @@
         </p:nvSpPr>
         <p:spPr>
           <a:xfrm>
-            <a:off x="777240" y="2651760"/>
-            <a:ext cx="3383280" cy="347472"/>
+            <a:off x="777240" y="4069080"/>
+            <a:ext cx="5029200" cy="502920"/>
           </a:xfrm>
           <a:prstGeom prst="rect">
             <a:avLst/>
@@ -7895,8 +7979,8 @@
         </p:nvSpPr>
         <p:spPr>
           <a:xfrm>
-            <a:off x="4343400" y="2651760"/>
-            <a:ext cx="2103120" cy="347472"/>
+            <a:off x="6126480" y="4069080"/>
+            <a:ext cx="2606040" cy="502920"/>
           </a:xfrm>
           <a:prstGeom prst="rect">
             <a:avLst/>
@@ -7927,6 +8011,7 @@
           <a:lstStyle/>
           <a:p>
             <a:pPr algn="ctr"/>
+            <a:endParaRPr/>
           </a:p>
         </p:txBody>
       </p:sp>
@@ -7938,8 +8023,8 @@
         </p:nvSpPr>
         <p:spPr>
           <a:xfrm>
-            <a:off x="4480560" y="2651760"/>
-            <a:ext cx="1828799" cy="347472"/>
+            <a:off x="6263640" y="4069080"/>
+            <a:ext cx="2331720" cy="502920"/>
           </a:xfrm>
           <a:prstGeom prst="rect">
             <a:avLst/>
@@ -7974,8 +8059,8 @@
         </p:nvSpPr>
         <p:spPr>
           <a:xfrm>
-            <a:off x="6492240" y="2651760"/>
-            <a:ext cx="2103120" cy="347472"/>
+            <a:off x="8851392" y="4069080"/>
+            <a:ext cx="2606040" cy="502920"/>
           </a:xfrm>
           <a:prstGeom prst="rect">
             <a:avLst/>
@@ -8006,6 +8091,7 @@
           <a:lstStyle/>
           <a:p>
             <a:pPr algn="ctr"/>
+            <a:endParaRPr/>
           </a:p>
         </p:txBody>
       </p:sp>
@@ -8017,8 +8103,8 @@
         </p:nvSpPr>
         <p:spPr>
           <a:xfrm>
-            <a:off x="6629400" y="2651760"/>
-            <a:ext cx="1828799" cy="347472"/>
+            <a:off x="8988552" y="4069080"/>
+            <a:ext cx="2331720" cy="502920"/>
           </a:xfrm>
           <a:prstGeom prst="rect">
             <a:avLst/>
@@ -8040,7 +8126,7 @@
               </a:defRPr>
             </a:pPr>
             <a:r>
-              <a:t>1 round</a:t>
+              <a:t>1 to 2 rounds</a:t>
             </a:r>
           </a:p>
         </p:txBody>
@@ -8053,8 +8139,8 @@
         </p:nvSpPr>
         <p:spPr>
           <a:xfrm>
-            <a:off x="777240" y="3017520"/>
-            <a:ext cx="3383280" cy="347472"/>
+            <a:off x="777240" y="4663440"/>
+            <a:ext cx="5029200" cy="502920"/>
           </a:xfrm>
           <a:prstGeom prst="rect">
             <a:avLst/>
@@ -8089,8 +8175,8 @@
         </p:nvSpPr>
         <p:spPr>
           <a:xfrm>
-            <a:off x="4480560" y="3017520"/>
-            <a:ext cx="1828799" cy="347472"/>
+            <a:off x="6263640" y="4663440"/>
+            <a:ext cx="2331720" cy="502920"/>
           </a:xfrm>
           <a:prstGeom prst="rect">
             <a:avLst/>
@@ -8125,8 +8211,8 @@
         </p:nvSpPr>
         <p:spPr>
           <a:xfrm>
-            <a:off x="6629400" y="3017520"/>
-            <a:ext cx="1828799" cy="347472"/>
+            <a:off x="8988552" y="4663440"/>
+            <a:ext cx="2331720" cy="502920"/>
           </a:xfrm>
           <a:prstGeom prst="rect">
             <a:avLst/>
@@ -8161,8 +8247,8 @@
         </p:nvSpPr>
         <p:spPr>
           <a:xfrm>
-            <a:off x="640080" y="3566160"/>
-            <a:ext cx="7863840" cy="274320"/>
+            <a:off x="640080" y="5440680"/>
+            <a:ext cx="10908792" cy="274320"/>
           </a:xfrm>
           <a:prstGeom prst="rect">
             <a:avLst/>
@@ -8197,8 +8283,8 @@
         </p:nvSpPr>
         <p:spPr>
           <a:xfrm>
-            <a:off x="640080" y="3886200"/>
-            <a:ext cx="7863840" cy="274320"/>
+            <a:off x="640080" y="5806440"/>
+            <a:ext cx="10908792" cy="274320"/>
           </a:xfrm>
           <a:prstGeom prst="rect">
             <a:avLst/>
@@ -8234,7 +8320,7 @@
 </file>
 
 <file path=ppt/slides/slide8.xml><?xml version="1.0" encoding="utf-8"?>
-<p:sld xmlns:a="http://schemas.openxmlformats.org/drawingml/2006/main" xmlns:p="http://schemas.openxmlformats.org/presentationml/2006/main" xmlns:r="http://schemas.openxmlformats.org/officeDocument/2006/relationships">
+<p:sld xmlns:a="http://schemas.openxmlformats.org/drawingml/2006/main" xmlns:r="http://schemas.openxmlformats.org/officeDocument/2006/relationships" xmlns:p="http://schemas.openxmlformats.org/presentationml/2006/main">
   <p:cSld>
     <p:bg>
       <p:bgPr>
@@ -8250,7 +8336,14 @@
         <p:cNvGrpSpPr/>
         <p:nvPr/>
       </p:nvGrpSpPr>
-      <p:grpSpPr/>
+      <p:grpSpPr>
+        <a:xfrm>
+          <a:off x="0" y="0"/>
+          <a:ext cx="0" cy="0"/>
+          <a:chOff x="0" y="0"/>
+          <a:chExt cx="0" cy="0"/>
+        </a:xfrm>
+      </p:grpSpPr>
       <p:sp>
         <p:nvSpPr>
           <p:cNvPr id="2" name="TextBox 1"/>
@@ -8289,7 +8382,7 @@
       </p:sp>
       <p:pic>
         <p:nvPicPr>
-          <p:cNvPr id="3" name="Picture 2" descr="06_gossip_compliance_card.png"/>
+          <p:cNvPr id="3" name="Picture 2" descr="06_compliance_compliance_card.png"/>
           <p:cNvPicPr>
             <a:picLocks noChangeAspect="1"/>
           </p:cNvPicPr>
@@ -8303,8 +8396,8 @@
         </p:blipFill>
         <p:spPr>
           <a:xfrm>
-            <a:off x="548640" y="1097280"/>
-            <a:ext cx="4572000" cy="3291840"/>
+            <a:off x="640080" y="1600200"/>
+            <a:ext cx="5486400" cy="3026664"/>
           </a:xfrm>
           <a:prstGeom prst="rect">
             <a:avLst/>
@@ -8319,8 +8412,8 @@
         </p:nvSpPr>
         <p:spPr>
           <a:xfrm>
-            <a:off x="5394960" y="1097280"/>
-            <a:ext cx="3474720" cy="502920"/>
+            <a:off x="6355080" y="1828800"/>
+            <a:ext cx="5193792" cy="548640"/>
           </a:xfrm>
           <a:prstGeom prst="rect">
             <a:avLst/>
@@ -8355,8 +8448,8 @@
         </p:nvSpPr>
         <p:spPr>
           <a:xfrm>
-            <a:off x="5394960" y="1737360"/>
-            <a:ext cx="3474720" cy="274320"/>
+            <a:off x="6355080" y="2560320"/>
+            <a:ext cx="5193792" cy="274320"/>
           </a:xfrm>
           <a:prstGeom prst="rect">
             <a:avLst/>
@@ -8391,8 +8484,8 @@
         </p:nvSpPr>
         <p:spPr>
           <a:xfrm>
-            <a:off x="5577840" y="2103120"/>
-            <a:ext cx="3200400" cy="256032"/>
+            <a:off x="6537960" y="3017520"/>
+            <a:ext cx="5010912" cy="292608"/>
           </a:xfrm>
           <a:prstGeom prst="rect">
             <a:avLst/>
@@ -8427,8 +8520,8 @@
         </p:nvSpPr>
         <p:spPr>
           <a:xfrm>
-            <a:off x="5577840" y="2395727"/>
-            <a:ext cx="3200400" cy="256032"/>
+            <a:off x="6537960" y="3429000"/>
+            <a:ext cx="5010912" cy="292608"/>
           </a:xfrm>
           <a:prstGeom prst="rect">
             <a:avLst/>
@@ -8463,8 +8556,8 @@
         </p:nvSpPr>
         <p:spPr>
           <a:xfrm>
-            <a:off x="5577840" y="2688336"/>
-            <a:ext cx="3200400" cy="256032"/>
+            <a:off x="6537960" y="3840480"/>
+            <a:ext cx="5010912" cy="292608"/>
           </a:xfrm>
           <a:prstGeom prst="rect">
             <a:avLst/>
@@ -8499,8 +8592,8 @@
         </p:nvSpPr>
         <p:spPr>
           <a:xfrm>
-            <a:off x="5577840" y="2980944"/>
-            <a:ext cx="3200400" cy="256032"/>
+            <a:off x="6537960" y="4251960"/>
+            <a:ext cx="5010912" cy="292608"/>
           </a:xfrm>
           <a:prstGeom prst="rect">
             <a:avLst/>
@@ -8535,8 +8628,8 @@
         </p:nvSpPr>
         <p:spPr>
           <a:xfrm>
-            <a:off x="5394960" y="3566160"/>
-            <a:ext cx="3474720" cy="457200"/>
+            <a:off x="6355080" y="4892040"/>
+            <a:ext cx="5193792" cy="502920"/>
           </a:xfrm>
           <a:prstGeom prst="rect">
             <a:avLst/>
@@ -8571,8 +8664,8 @@
         </p:nvSpPr>
         <p:spPr>
           <a:xfrm>
-            <a:off x="548640" y="4846320"/>
-            <a:ext cx="8046720" cy="274320"/>
+            <a:off x="548640" y="5989320"/>
+            <a:ext cx="10908792" cy="274320"/>
           </a:xfrm>
           <a:prstGeom prst="rect">
             <a:avLst/>
@@ -8608,7 +8701,7 @@
 </file>
 
 <file path=ppt/slides/slide9.xml><?xml version="1.0" encoding="utf-8"?>
-<p:sld xmlns:a="http://schemas.openxmlformats.org/drawingml/2006/main" xmlns:p="http://schemas.openxmlformats.org/presentationml/2006/main" xmlns:r="http://schemas.openxmlformats.org/officeDocument/2006/relationships">
+<p:sld xmlns:a="http://schemas.openxmlformats.org/drawingml/2006/main" xmlns:r="http://schemas.openxmlformats.org/officeDocument/2006/relationships" xmlns:p="http://schemas.openxmlformats.org/presentationml/2006/main">
   <p:cSld>
     <p:bg>
       <p:bgPr>
@@ -8624,7 +8717,14 @@
         <p:cNvGrpSpPr/>
         <p:nvPr/>
       </p:nvGrpSpPr>
-      <p:grpSpPr/>
+      <p:grpSpPr>
+        <a:xfrm>
+          <a:off x="0" y="0"/>
+          <a:ext cx="0" cy="0"/>
+          <a:chOff x="0" y="0"/>
+          <a:chExt cx="0" cy="0"/>
+        </a:xfrm>
+      </p:grpSpPr>
       <p:sp>
         <p:nvSpPr>
           <p:cNvPr id="2" name="TextBox 1"/>
@@ -8669,8 +8769,8 @@
         </p:nvSpPr>
         <p:spPr>
           <a:xfrm>
-            <a:off x="548640" y="1097280"/>
-            <a:ext cx="8046720" cy="411480"/>
+            <a:off x="548640" y="1325880"/>
+            <a:ext cx="10908792" cy="411480"/>
           </a:xfrm>
           <a:prstGeom prst="rect">
             <a:avLst/>
@@ -8705,8 +8805,8 @@
         </p:nvSpPr>
         <p:spPr>
           <a:xfrm>
-            <a:off x="548640" y="1508760"/>
-            <a:ext cx="8046720" cy="320040"/>
+            <a:off x="548640" y="1783080"/>
+            <a:ext cx="10908792" cy="320040"/>
           </a:xfrm>
           <a:prstGeom prst="rect">
             <a:avLst/>
@@ -8741,8 +8841,8 @@
         </p:nvSpPr>
         <p:spPr>
           <a:xfrm>
-            <a:off x="2834640" y="2194560"/>
-            <a:ext cx="3657600" cy="457200"/>
+            <a:off x="2212848" y="2331720"/>
+            <a:ext cx="7772400" cy="566928"/>
           </a:xfrm>
           <a:prstGeom prst="rect">
             <a:avLst/>
@@ -8773,6 +8873,7 @@
           <a:lstStyle/>
           <a:p>
             <a:pPr algn="ctr"/>
+            <a:endParaRPr/>
           </a:p>
         </p:txBody>
       </p:sp>
@@ -8784,8 +8885,8 @@
         </p:nvSpPr>
         <p:spPr>
           <a:xfrm>
-            <a:off x="2834640" y="2194560"/>
-            <a:ext cx="45720" cy="457200"/>
+            <a:off x="2212848" y="2331720"/>
+            <a:ext cx="45720" cy="566928"/>
           </a:xfrm>
           <a:prstGeom prst="rect">
             <a:avLst/>
@@ -8816,6 +8917,7 @@
           <a:lstStyle/>
           <a:p>
             <a:pPr algn="ctr"/>
+            <a:endParaRPr/>
           </a:p>
         </p:txBody>
       </p:sp>
@@ -8827,8 +8929,8 @@
         </p:nvSpPr>
         <p:spPr>
           <a:xfrm>
-            <a:off x="3017520" y="2221991"/>
-            <a:ext cx="3383280" cy="228600"/>
+            <a:off x="2395728" y="2359152"/>
+            <a:ext cx="7498079" cy="246888"/>
           </a:xfrm>
           <a:prstGeom prst="rect">
             <a:avLst/>
@@ -8863,8 +8965,8 @@
         </p:nvSpPr>
         <p:spPr>
           <a:xfrm>
-            <a:off x="3017520" y="2450591"/>
-            <a:ext cx="3383280" cy="182880"/>
+            <a:off x="2395728" y="2606040"/>
+            <a:ext cx="7498079" cy="201168"/>
           </a:xfrm>
           <a:prstGeom prst="rect">
             <a:avLst/>
@@ -8899,8 +9001,8 @@
         </p:nvSpPr>
         <p:spPr>
           <a:xfrm>
-            <a:off x="2834640" y="2788920"/>
-            <a:ext cx="3657600" cy="457200"/>
+            <a:off x="2212848" y="3154680"/>
+            <a:ext cx="7772400" cy="566928"/>
           </a:xfrm>
           <a:prstGeom prst="rect">
             <a:avLst/>
@@ -8931,6 +9033,7 @@
           <a:lstStyle/>
           <a:p>
             <a:pPr algn="ctr"/>
+            <a:endParaRPr/>
           </a:p>
         </p:txBody>
       </p:sp>
@@ -8942,8 +9045,8 @@
         </p:nvSpPr>
         <p:spPr>
           <a:xfrm>
-            <a:off x="2834640" y="2788920"/>
-            <a:ext cx="45720" cy="457200"/>
+            <a:off x="2212848" y="3154680"/>
+            <a:ext cx="45720" cy="566928"/>
           </a:xfrm>
           <a:prstGeom prst="rect">
             <a:avLst/>
@@ -8974,6 +9077,7 @@
           <a:lstStyle/>
           <a:p>
             <a:pPr algn="ctr"/>
+            <a:endParaRPr/>
           </a:p>
         </p:txBody>
       </p:sp>
@@ -8985,8 +9089,8 @@
         </p:nvSpPr>
         <p:spPr>
           <a:xfrm>
-            <a:off x="3017520" y="2816351"/>
-            <a:ext cx="3383280" cy="228600"/>
+            <a:off x="2395728" y="3182112"/>
+            <a:ext cx="7498079" cy="246888"/>
           </a:xfrm>
           <a:prstGeom prst="rect">
             <a:avLst/>
@@ -9021,8 +9125,8 @@
         </p:nvSpPr>
         <p:spPr>
           <a:xfrm>
-            <a:off x="3017520" y="3044952"/>
-            <a:ext cx="3383280" cy="182880"/>
+            <a:off x="2395728" y="3429000"/>
+            <a:ext cx="7498079" cy="201168"/>
           </a:xfrm>
           <a:prstGeom prst="rect">
             <a:avLst/>
@@ -9057,8 +9161,8 @@
         </p:nvSpPr>
         <p:spPr>
           <a:xfrm>
-            <a:off x="2834640" y="3383280"/>
-            <a:ext cx="3657600" cy="457200"/>
+            <a:off x="2212848" y="3977639"/>
+            <a:ext cx="7772400" cy="566928"/>
           </a:xfrm>
           <a:prstGeom prst="rect">
             <a:avLst/>
@@ -9089,6 +9193,7 @@
           <a:lstStyle/>
           <a:p>
             <a:pPr algn="ctr"/>
+            <a:endParaRPr/>
           </a:p>
         </p:txBody>
       </p:sp>
@@ -9100,8 +9205,8 @@
         </p:nvSpPr>
         <p:spPr>
           <a:xfrm>
-            <a:off x="2834640" y="3383280"/>
-            <a:ext cx="45720" cy="457200"/>
+            <a:off x="2212848" y="3977639"/>
+            <a:ext cx="45720" cy="566928"/>
           </a:xfrm>
           <a:prstGeom prst="rect">
             <a:avLst/>
@@ -9132,6 +9237,7 @@
           <a:lstStyle/>
           <a:p>
             <a:pPr algn="ctr"/>
+            <a:endParaRPr/>
           </a:p>
         </p:txBody>
       </p:sp>
@@ -9143,8 +9249,8 @@
         </p:nvSpPr>
         <p:spPr>
           <a:xfrm>
-            <a:off x="3017520" y="3410712"/>
-            <a:ext cx="3383280" cy="228600"/>
+            <a:off x="2395728" y="4005072"/>
+            <a:ext cx="7498079" cy="246888"/>
           </a:xfrm>
           <a:prstGeom prst="rect">
             <a:avLst/>
@@ -9179,8 +9285,8 @@
         </p:nvSpPr>
         <p:spPr>
           <a:xfrm>
-            <a:off x="3017520" y="3639312"/>
-            <a:ext cx="3383280" cy="182880"/>
+            <a:off x="2395728" y="4251960"/>
+            <a:ext cx="7498079" cy="201168"/>
           </a:xfrm>
           <a:prstGeom prst="rect">
             <a:avLst/>
@@ -9215,8 +9321,8 @@
         </p:nvSpPr>
         <p:spPr>
           <a:xfrm>
-            <a:off x="4526279" y="2651760"/>
-            <a:ext cx="274320" cy="182880"/>
+            <a:off x="5961888" y="2862072"/>
+            <a:ext cx="274320" cy="201168"/>
           </a:xfrm>
           <a:prstGeom prst="rect">
             <a:avLst/>
@@ -9251,8 +9357,8 @@
         </p:nvSpPr>
         <p:spPr>
           <a:xfrm>
-            <a:off x="4526279" y="3246120"/>
-            <a:ext cx="274320" cy="182880"/>
+            <a:off x="5961888" y="3685032"/>
+            <a:ext cx="274320" cy="201168"/>
           </a:xfrm>
           <a:prstGeom prst="rect">
             <a:avLst/>
@@ -9287,8 +9393,8 @@
         </p:nvSpPr>
         <p:spPr>
           <a:xfrm>
-            <a:off x="548640" y="4160520"/>
-            <a:ext cx="1828800" cy="274320"/>
+            <a:off x="548640" y="4846320"/>
+            <a:ext cx="2743200" cy="274320"/>
           </a:xfrm>
           <a:prstGeom prst="rect">
             <a:avLst/>
@@ -9323,8 +9429,8 @@
         </p:nvSpPr>
         <p:spPr>
           <a:xfrm>
-            <a:off x="548640" y="4434840"/>
-            <a:ext cx="8046720" cy="256032"/>
+            <a:off x="548640" y="5138928"/>
+            <a:ext cx="10908792" cy="256032"/>
           </a:xfrm>
           <a:prstGeom prst="rect">
             <a:avLst/>
@@ -9359,8 +9465,8 @@
         </p:nvSpPr>
         <p:spPr>
           <a:xfrm>
-            <a:off x="548640" y="4690872"/>
-            <a:ext cx="8046720" cy="256032"/>
+            <a:off x="548640" y="5413248"/>
+            <a:ext cx="10908792" cy="256032"/>
           </a:xfrm>
           <a:prstGeom prst="rect">
             <a:avLst/>
@@ -9395,8 +9501,8 @@
         </p:nvSpPr>
         <p:spPr>
           <a:xfrm>
-            <a:off x="548640" y="4946904"/>
-            <a:ext cx="8046720" cy="256032"/>
+            <a:off x="548640" y="5687568"/>
+            <a:ext cx="10908792" cy="256032"/>
           </a:xfrm>
           <a:prstGeom prst="rect">
             <a:avLst/>
@@ -9431,8 +9537,8 @@
         </p:nvSpPr>
         <p:spPr>
           <a:xfrm>
-            <a:off x="548640" y="5202936"/>
-            <a:ext cx="8046720" cy="256032"/>
+            <a:off x="548640" y="5961888"/>
+            <a:ext cx="10908792" cy="256032"/>
           </a:xfrm>
           <a:prstGeom prst="rect">
             <a:avLst/>

</xml_diff>